<commit_message>
docs/architecture ③: FrameworkOnCore.Compat as a partial layer on .NET 10 (the application's other calls to .NET 10 directly)
Co-Authored-By: Claude Opus 5.5 <noreply@anthropic.com>
</commit_message>
<xml_diff>
--- a/docs/architecture/architecture.pptx
+++ b/docs/architecture/architecture.pptx
@@ -15061,7 +15061,7 @@
         <p:spPr>
           <a:xfrm>
             <a:off x="2636935" y="393572"/>
-            <a:ext cx="1377503" cy="629715"/>
+            <a:ext cx="1220074" cy="629715"/>
           </a:xfrm>
           <a:prstGeom prst="rect">
             <a:avLst/>
@@ -15226,8 +15226,8 @@
         </p:nvSpPr>
         <p:spPr>
           <a:xfrm>
-            <a:off x="4053796" y="393572"/>
-            <a:ext cx="1298789" cy="629715"/>
+            <a:off x="3896367" y="393572"/>
+            <a:ext cx="1141360" cy="629715"/>
           </a:xfrm>
           <a:prstGeom prst="rect">
             <a:avLst/>
@@ -15280,7 +15280,7 @@
         </p:nvSpPr>
         <p:spPr>
           <a:xfrm>
-            <a:off x="4112832" y="610037"/>
+            <a:off x="3955403" y="610037"/>
             <a:ext cx="856758" cy="167268"/>
           </a:xfrm>
           <a:prstGeom prst="roundRect">
@@ -15336,7 +15336,7 @@
         </p:nvSpPr>
         <p:spPr>
           <a:xfrm>
-            <a:off x="4112832" y="806823"/>
+            <a:off x="3955403" y="806823"/>
             <a:ext cx="619138" cy="167268"/>
           </a:xfrm>
           <a:prstGeom prst="roundRect">
@@ -15392,8 +15392,8 @@
         </p:nvSpPr>
         <p:spPr>
           <a:xfrm>
-            <a:off x="5391942" y="393572"/>
-            <a:ext cx="1298789" cy="629715"/>
+            <a:off x="5077084" y="393572"/>
+            <a:ext cx="1141360" cy="629715"/>
           </a:xfrm>
           <a:prstGeom prst="rect">
             <a:avLst/>
@@ -15446,7 +15446,7 @@
         </p:nvSpPr>
         <p:spPr>
           <a:xfrm>
-            <a:off x="5450978" y="610037"/>
+            <a:off x="5136120" y="610037"/>
             <a:ext cx="743113" cy="167268"/>
           </a:xfrm>
           <a:prstGeom prst="roundRect">
@@ -15502,8 +15502,8 @@
         </p:nvSpPr>
         <p:spPr>
           <a:xfrm>
-            <a:off x="6730088" y="393572"/>
-            <a:ext cx="1377503" cy="629715"/>
+            <a:off x="6257802" y="393572"/>
+            <a:ext cx="1220074" cy="629715"/>
           </a:xfrm>
           <a:prstGeom prst="rect">
             <a:avLst/>
@@ -15556,7 +15556,7 @@
         </p:nvSpPr>
         <p:spPr>
           <a:xfrm>
-            <a:off x="6789124" y="610037"/>
+            <a:off x="6316837" y="610037"/>
             <a:ext cx="345359" cy="167268"/>
           </a:xfrm>
           <a:prstGeom prst="roundRect">
@@ -15612,7 +15612,7 @@
         </p:nvSpPr>
         <p:spPr>
           <a:xfrm>
-            <a:off x="7164002" y="610037"/>
+            <a:off x="6316837" y="806823"/>
             <a:ext cx="799936" cy="167268"/>
           </a:xfrm>
           <a:prstGeom prst="roundRect">
@@ -15891,7 +15891,7 @@
         <p:spPr>
           <a:xfrm>
             <a:off x="2636935" y="1062645"/>
-            <a:ext cx="1377503" cy="767466"/>
+            <a:ext cx="1220074" cy="767466"/>
           </a:xfrm>
           <a:prstGeom prst="rect">
             <a:avLst/>
@@ -15945,7 +15945,7 @@
         <p:spPr>
           <a:xfrm>
             <a:off x="2695971" y="1279110"/>
-            <a:ext cx="1259431" cy="167268"/>
+            <a:ext cx="1102002" cy="167268"/>
           </a:xfrm>
           <a:prstGeom prst="roundRect">
             <a:avLst>
@@ -16001,7 +16001,7 @@
         <p:spPr>
           <a:xfrm>
             <a:off x="2695971" y="1475896"/>
-            <a:ext cx="1259431" cy="167268"/>
+            <a:ext cx="1102002" cy="167268"/>
           </a:xfrm>
           <a:prstGeom prst="roundRect">
             <a:avLst>
@@ -16057,7 +16057,7 @@
         <p:spPr>
           <a:xfrm>
             <a:off x="2695971" y="1672682"/>
-            <a:ext cx="1259431" cy="167268"/>
+            <a:ext cx="1102002" cy="167268"/>
           </a:xfrm>
           <a:prstGeom prst="roundRect">
             <a:avLst>
@@ -16099,7 +16099,7 @@
                 <a:latin typeface="Yu Gothic UI"/>
                 <a:ea typeface="Yu Gothic UI"/>
               </a:rPr>
-              <a:t>AspNetWebStack から</a:t>
+              <a:t>AspNetWebStack</a:t>
             </a:r>
           </a:p>
         </p:txBody>
@@ -16112,8 +16112,8 @@
         </p:nvSpPr>
         <p:spPr>
           <a:xfrm>
-            <a:off x="4053796" y="1062645"/>
-            <a:ext cx="1298789" cy="1042967"/>
+            <a:off x="3896367" y="1062645"/>
+            <a:ext cx="1141360" cy="1042967"/>
           </a:xfrm>
           <a:prstGeom prst="rect">
             <a:avLst/>
@@ -16166,8 +16166,8 @@
         </p:nvSpPr>
         <p:spPr>
           <a:xfrm>
-            <a:off x="4112832" y="1279110"/>
-            <a:ext cx="1180717" cy="167268"/>
+            <a:off x="3955403" y="1279110"/>
+            <a:ext cx="1023288" cy="167268"/>
           </a:xfrm>
           <a:prstGeom prst="roundRect">
             <a:avLst>
@@ -16222,8 +16222,8 @@
         </p:nvSpPr>
         <p:spPr>
           <a:xfrm>
-            <a:off x="4112832" y="1475896"/>
-            <a:ext cx="1180717" cy="167268"/>
+            <a:off x="3955403" y="1475896"/>
+            <a:ext cx="1023288" cy="167268"/>
           </a:xfrm>
           <a:prstGeom prst="roundRect">
             <a:avLst>
@@ -16278,8 +16278,8 @@
         </p:nvSpPr>
         <p:spPr>
           <a:xfrm>
-            <a:off x="4112832" y="1672682"/>
-            <a:ext cx="1180717" cy="167268"/>
+            <a:off x="3955403" y="1672682"/>
+            <a:ext cx="1023288" cy="167268"/>
           </a:xfrm>
           <a:prstGeom prst="roundRect">
             <a:avLst>
@@ -16321,7 +16321,7 @@
                 <a:latin typeface="Yu Gothic UI"/>
                 <a:ea typeface="Yu Gothic UI"/>
               </a:rPr>
-              <a:t>Newtonsoft.Json(他社)</a:t>
+              <a:t>Newtonsoft.Json</a:t>
             </a:r>
           </a:p>
         </p:txBody>
@@ -16334,8 +16334,8 @@
         </p:nvSpPr>
         <p:spPr>
           <a:xfrm>
-            <a:off x="5391942" y="1062645"/>
-            <a:ext cx="1298789" cy="1042967"/>
+            <a:off x="5077084" y="1062645"/>
+            <a:ext cx="1141360" cy="1042967"/>
           </a:xfrm>
           <a:prstGeom prst="rect">
             <a:avLst/>
@@ -16388,8 +16388,8 @@
         </p:nvSpPr>
         <p:spPr>
           <a:xfrm>
-            <a:off x="5450978" y="1279110"/>
-            <a:ext cx="1180717" cy="167268"/>
+            <a:off x="5136120" y="1279110"/>
+            <a:ext cx="1023288" cy="167268"/>
           </a:xfrm>
           <a:prstGeom prst="roundRect">
             <a:avLst>
@@ -16431,7 +16431,7 @@
                 <a:latin typeface="Yu Gothic UI"/>
                 <a:ea typeface="Yu Gothic UI"/>
               </a:rPr>
-              <a:t>System.Web.Services</a:t>
+              <a:t>Web.Services</a:t>
             </a:r>
           </a:p>
         </p:txBody>
@@ -16444,8 +16444,8 @@
         </p:nvSpPr>
         <p:spPr>
           <a:xfrm>
-            <a:off x="5450978" y="1475896"/>
-            <a:ext cx="1180717" cy="167268"/>
+            <a:off x="5136120" y="1475896"/>
+            <a:ext cx="1023288" cy="167268"/>
           </a:xfrm>
           <a:prstGeom prst="roundRect">
             <a:avLst>
@@ -16500,8 +16500,8 @@
         </p:nvSpPr>
         <p:spPr>
           <a:xfrm>
-            <a:off x="6730088" y="1062645"/>
-            <a:ext cx="1377503" cy="1042967"/>
+            <a:off x="6257802" y="1062645"/>
+            <a:ext cx="1220074" cy="1042967"/>
           </a:xfrm>
           <a:prstGeom prst="rect">
             <a:avLst/>
@@ -16554,8 +16554,8 @@
         </p:nvSpPr>
         <p:spPr>
           <a:xfrm>
-            <a:off x="6789124" y="1279110"/>
-            <a:ext cx="1259431" cy="167268"/>
+            <a:off x="6316837" y="1279110"/>
+            <a:ext cx="1102002" cy="167268"/>
           </a:xfrm>
           <a:prstGeom prst="roundRect">
             <a:avLst>
@@ -16610,8 +16610,8 @@
         </p:nvSpPr>
         <p:spPr>
           <a:xfrm>
-            <a:off x="6789124" y="1475896"/>
-            <a:ext cx="1259431" cy="167268"/>
+            <a:off x="6316837" y="1475896"/>
+            <a:ext cx="1102002" cy="167268"/>
           </a:xfrm>
           <a:prstGeom prst="roundRect">
             <a:avLst>
@@ -16653,7 +16653,7 @@
                 <a:latin typeface="Yu Gothic UI"/>
                 <a:ea typeface="Yu Gothic UI"/>
               </a:rPr>
-              <a:t>ServiceModel(.svc)</a:t>
+              <a:t>.svc の構成</a:t>
             </a:r>
           </a:p>
         </p:txBody>
@@ -16666,8 +16666,8 @@
         </p:nvSpPr>
         <p:spPr>
           <a:xfrm>
-            <a:off x="6789124" y="1672682"/>
-            <a:ext cx="1259431" cy="167268"/>
+            <a:off x="6316837" y="1672682"/>
+            <a:ext cx="1102002" cy="167268"/>
           </a:xfrm>
           <a:prstGeom prst="roundRect">
             <a:avLst>
@@ -16709,7 +16709,7 @@
                 <a:latin typeface="Yu Gothic UI"/>
                 <a:ea typeface="Yu Gothic UI"/>
               </a:rPr>
-              <a:t>AspNetCompatibility</a:t>
+              <a:t>ASP.NET 互換</a:t>
             </a:r>
           </a:p>
         </p:txBody>
@@ -16723,7 +16723,7 @@
         <p:spPr>
           <a:xfrm>
             <a:off x="432929" y="1869469"/>
-            <a:ext cx="3581509" cy="236143"/>
+            <a:ext cx="3424080" cy="236143"/>
           </a:xfrm>
           <a:prstGeom prst="rect">
             <a:avLst/>
@@ -16776,8 +16776,8 @@
         </p:nvSpPr>
         <p:spPr>
           <a:xfrm>
-            <a:off x="8146949" y="393572"/>
-            <a:ext cx="1849790" cy="1712040"/>
+            <a:off x="7517233" y="393572"/>
+            <a:ext cx="2479506" cy="1712040"/>
           </a:xfrm>
           <a:prstGeom prst="rect">
             <a:avLst/>
@@ -16843,8 +16843,8 @@
         </p:nvSpPr>
         <p:spPr>
           <a:xfrm>
-            <a:off x="8205985" y="767466"/>
-            <a:ext cx="1731718" cy="167268"/>
+            <a:off x="7576269" y="767466"/>
+            <a:ext cx="2361434" cy="167268"/>
           </a:xfrm>
           <a:prstGeom prst="roundRect">
             <a:avLst>
@@ -16899,8 +16899,8 @@
         </p:nvSpPr>
         <p:spPr>
           <a:xfrm>
-            <a:off x="8205985" y="964252"/>
-            <a:ext cx="1731718" cy="167268"/>
+            <a:off x="7576269" y="964252"/>
+            <a:ext cx="2361434" cy="167268"/>
           </a:xfrm>
           <a:prstGeom prst="roundRect">
             <a:avLst>
@@ -16955,8 +16955,8 @@
         </p:nvSpPr>
         <p:spPr>
           <a:xfrm>
-            <a:off x="8205985" y="1161038"/>
-            <a:ext cx="1731718" cy="167268"/>
+            <a:off x="7576269" y="1161038"/>
+            <a:ext cx="2361434" cy="167268"/>
           </a:xfrm>
           <a:prstGeom prst="roundRect">
             <a:avLst>
@@ -17011,8 +17011,8 @@
         </p:nvSpPr>
         <p:spPr>
           <a:xfrm>
-            <a:off x="8205985" y="1357824"/>
-            <a:ext cx="1731718" cy="167268"/>
+            <a:off x="7576269" y="1357824"/>
+            <a:ext cx="2361434" cy="167268"/>
           </a:xfrm>
           <a:prstGeom prst="roundRect">
             <a:avLst>
@@ -17067,8 +17067,8 @@
         </p:nvSpPr>
         <p:spPr>
           <a:xfrm>
-            <a:off x="8205985" y="1554611"/>
-            <a:ext cx="1731718" cy="167268"/>
+            <a:off x="7576269" y="1554611"/>
+            <a:ext cx="2361434" cy="167268"/>
           </a:xfrm>
           <a:prstGeom prst="roundRect">
             <a:avLst>
@@ -17123,8 +17123,8 @@
         </p:nvSpPr>
         <p:spPr>
           <a:xfrm>
-            <a:off x="8619236" y="2105612"/>
-            <a:ext cx="1377503" cy="708430"/>
+            <a:off x="7989520" y="2105612"/>
+            <a:ext cx="2007219" cy="1416860"/>
           </a:xfrm>
           <a:prstGeom prst="rect">
             <a:avLst/>
@@ -17177,8 +17177,8 @@
         </p:nvSpPr>
         <p:spPr>
           <a:xfrm>
-            <a:off x="8619236" y="2577899"/>
-            <a:ext cx="1377503" cy="196786"/>
+            <a:off x="7989520" y="2577899"/>
+            <a:ext cx="2007219" cy="196786"/>
           </a:xfrm>
           <a:prstGeom prst="rect">
             <a:avLst/>
@@ -17229,15 +17229,13 @@
         </p:nvSpPr>
         <p:spPr>
           <a:xfrm>
-            <a:off x="9091523" y="2814043"/>
-            <a:ext cx="905216" cy="1456218"/>
+            <a:off x="7989520" y="3325687"/>
+            <a:ext cx="2007219" cy="196786"/>
           </a:xfrm>
           <a:prstGeom prst="rect">
             <a:avLst/>
           </a:prstGeom>
-          <a:solidFill>
-            <a:srgbClr val="F39A3D"/>
-          </a:solidFill>
+          <a:noFill/>
           <a:ln>
             <a:noFill/>
           </a:ln>
@@ -17263,14 +17261,14 @@
           <a:p>
             <a:pPr algn="l"/>
             <a:r>
-              <a:rPr sz="929" b="1">
+              <a:rPr sz="851" b="1">
                 <a:solidFill>
                   <a:srgbClr val="FFFFFF"/>
                 </a:solidFill>
                 <a:latin typeface="Yu Gothic UI"/>
                 <a:ea typeface="Yu Gothic UI"/>
               </a:rPr>
-              <a:t/>
+              <a:t>Compat ↓(違う所・無い所だけ)</a:t>
             </a:r>
           </a:p>
         </p:txBody>
@@ -17283,46 +17281,48 @@
         </p:nvSpPr>
         <p:spPr>
           <a:xfrm>
-            <a:off x="9091523" y="4073474"/>
-            <a:ext cx="905216" cy="196786"/>
+            <a:off x="9760596" y="3522473"/>
+            <a:ext cx="236143" cy="865859"/>
           </a:xfrm>
           <a:prstGeom prst="rect">
             <a:avLst/>
           </a:prstGeom>
-          <a:noFill/>
-          <a:ln>
-            <a:noFill/>
-          </a:ln>
-          <a:effectLst/>
-        </p:spPr>
-        <p:style>
-          <a:lnRef idx="1">
-            <a:schemeClr val="accent1"/>
-          </a:lnRef>
-          <a:fillRef idx="3">
-            <a:schemeClr val="accent1"/>
-          </a:fillRef>
-          <a:effectRef idx="2">
-            <a:schemeClr val="accent1"/>
-          </a:effectRef>
-          <a:fontRef idx="minor">
-            <a:schemeClr val="lt1"/>
-          </a:fontRef>
-        </p:style>
-        <p:txBody>
-          <a:bodyPr rtlCol="0" anchor="t" wrap="square" lIns="49196" rIns="49196" tIns="19678" bIns="19678"/>
-          <a:lstStyle/>
-          <a:p>
-            <a:pPr algn="l"/>
-            <a:r>
-              <a:rPr sz="851" b="1">
+          <a:solidFill>
+            <a:srgbClr val="F39A3D"/>
+          </a:solidFill>
+          <a:ln>
+            <a:noFill/>
+          </a:ln>
+          <a:effectLst/>
+        </p:spPr>
+        <p:style>
+          <a:lnRef idx="1">
+            <a:schemeClr val="accent1"/>
+          </a:lnRef>
+          <a:fillRef idx="3">
+            <a:schemeClr val="accent1"/>
+          </a:fillRef>
+          <a:effectRef idx="2">
+            <a:schemeClr val="accent1"/>
+          </a:effectRef>
+          <a:fontRef idx="minor">
+            <a:schemeClr val="lt1"/>
+          </a:fontRef>
+        </p:style>
+        <p:txBody>
+          <a:bodyPr rtlCol="0" anchor="ctr" wrap="square" lIns="49196" rIns="49196" tIns="19678" bIns="19678" vert="eaVert"/>
+          <a:lstStyle/>
+          <a:p>
+            <a:pPr algn="ctr"/>
+            <a:r>
+              <a:rPr sz="774" b="1">
                 <a:solidFill>
                   <a:srgbClr val="FFFFFF"/>
                 </a:solidFill>
                 <a:latin typeface="Yu Gothic UI"/>
                 <a:ea typeface="Yu Gothic UI"/>
               </a:rPr>
-              <a:t>Compat ↓</a:t>
+              <a:t>直接</a:t>
             </a:r>
           </a:p>
         </p:txBody>
@@ -17335,14 +17335,14 @@
         </p:nvSpPr>
         <p:spPr>
           <a:xfrm>
-            <a:off x="432929" y="2144969"/>
-            <a:ext cx="8146949" cy="629715"/>
+            <a:off x="7989520" y="3561830"/>
+            <a:ext cx="1731718" cy="826502"/>
           </a:xfrm>
           <a:prstGeom prst="rect">
             <a:avLst/>
           </a:prstGeom>
           <a:solidFill>
-            <a:srgbClr val="C8102E"/>
+            <a:srgbClr val="3AA357"/>
           </a:solidFill>
           <a:ln>
             <a:noFill/>
@@ -17376,7 +17376,7 @@
                 <a:latin typeface="Yu Gothic UI"/>
                 <a:ea typeface="Yu Gothic UI"/>
               </a:rPr>
-              <a:t>FrameworkOnCore の System.Web のコア ― 全種類で共通(referencesource の移植)</a:t>
+              <a:t>FrameworkOnCore.Compat</a:t>
             </a:r>
           </a:p>
         </p:txBody>
@@ -17389,8 +17389,8 @@
         </p:nvSpPr>
         <p:spPr>
           <a:xfrm>
-            <a:off x="491965" y="2361434"/>
-            <a:ext cx="1693591" cy="167268"/>
+            <a:off x="8048556" y="3778295"/>
+            <a:ext cx="1613647" cy="167268"/>
           </a:xfrm>
           <a:prstGeom prst="roundRect">
             <a:avLst>
@@ -17398,7 +17398,7 @@
             </a:avLst>
           </a:prstGeom>
           <a:solidFill>
-            <a:srgbClr val="F8E2E6"/>
+            <a:srgbClr val="E7F4EB"/>
           </a:solidFill>
           <a:ln>
             <a:noFill/>
@@ -17432,7 +17432,7 @@
                 <a:latin typeface="Yu Gothic UI"/>
                 <a:ea typeface="Yu Gothic UI"/>
               </a:rPr>
-              <a:t>HttpApplication・パイプライン</a:t>
+              <a:t>数値・カルチャ・ファイル</a:t>
             </a:r>
           </a:p>
         </p:txBody>
@@ -17445,8 +17445,8 @@
         </p:nvSpPr>
         <p:spPr>
           <a:xfrm>
-            <a:off x="2215074" y="2361434"/>
-            <a:ext cx="1538622" cy="167268"/>
+            <a:off x="8048556" y="3975081"/>
+            <a:ext cx="1613647" cy="167268"/>
           </a:xfrm>
           <a:prstGeom prst="roundRect">
             <a:avLst>
@@ -17454,7 +17454,7 @@
             </a:avLst>
           </a:prstGeom>
           <a:solidFill>
-            <a:srgbClr val="F8E2E6"/>
+            <a:srgbClr val="E7F4EB"/>
           </a:solidFill>
           <a:ln>
             <a:noFill/>
@@ -17488,7 +17488,7 @@
                 <a:latin typeface="Yu Gothic UI"/>
                 <a:ea typeface="Yu Gothic UI"/>
               </a:rPr>
-              <a:t>HTTP モジュール・ハンドラー</a:t>
+              <a:t>VB の文字列</a:t>
             </a:r>
           </a:p>
         </p:txBody>
@@ -17501,8 +17501,8 @@
         </p:nvSpPr>
         <p:spPr>
           <a:xfrm>
-            <a:off x="3783215" y="2361434"/>
-            <a:ext cx="1874388" cy="167268"/>
+            <a:off x="8048556" y="4171868"/>
+            <a:ext cx="1613647" cy="167268"/>
           </a:xfrm>
           <a:prstGeom prst="roundRect">
             <a:avLst>
@@ -17510,7 +17510,7 @@
             </a:avLst>
           </a:prstGeom>
           <a:solidFill>
-            <a:srgbClr val="F8E2E6"/>
+            <a:srgbClr val="E7F4EB"/>
           </a:solidFill>
           <a:ln>
             <a:noFill/>
@@ -17544,21 +17544,75 @@
                 <a:latin typeface="Yu Gothic UI"/>
                 <a:ea typeface="Yu Gothic UI"/>
               </a:rPr>
-              <a:t>ルーティング(System.Web.Routing)</a:t>
-            </a:r>
-          </a:p>
-        </p:txBody>
-      </p:sp>
-      <p:sp>
-        <p:nvSpPr>
-          <p:cNvPr id="51" name="Rounded Rectangle 50"/>
-          <p:cNvSpPr/>
-          <p:nvPr/>
-        </p:nvSpPr>
-        <p:spPr>
-          <a:xfrm>
-            <a:off x="5687121" y="2361434"/>
-            <a:ext cx="1254512" cy="167268"/>
+              <a:t>削除された型・メンバー</a:t>
+            </a:r>
+          </a:p>
+        </p:txBody>
+      </p:sp>
+      <p:sp>
+        <p:nvSpPr>
+          <p:cNvPr id="51" name="Rectangle 50"/>
+          <p:cNvSpPr/>
+          <p:nvPr/>
+        </p:nvSpPr>
+        <p:spPr>
+          <a:xfrm>
+            <a:off x="432929" y="2144969"/>
+            <a:ext cx="7517233" cy="629715"/>
+          </a:xfrm>
+          <a:prstGeom prst="rect">
+            <a:avLst/>
+          </a:prstGeom>
+          <a:solidFill>
+            <a:srgbClr val="C8102E"/>
+          </a:solidFill>
+          <a:ln>
+            <a:noFill/>
+          </a:ln>
+          <a:effectLst/>
+        </p:spPr>
+        <p:style>
+          <a:lnRef idx="1">
+            <a:schemeClr val="accent1"/>
+          </a:lnRef>
+          <a:fillRef idx="3">
+            <a:schemeClr val="accent1"/>
+          </a:fillRef>
+          <a:effectRef idx="2">
+            <a:schemeClr val="accent1"/>
+          </a:effectRef>
+          <a:fontRef idx="minor">
+            <a:schemeClr val="lt1"/>
+          </a:fontRef>
+        </p:style>
+        <p:txBody>
+          <a:bodyPr rtlCol="0" anchor="t" wrap="square" lIns="49196" rIns="49196" tIns="19678" bIns="19678"/>
+          <a:lstStyle/>
+          <a:p>
+            <a:pPr algn="l"/>
+            <a:r>
+              <a:rPr sz="929" b="1">
+                <a:solidFill>
+                  <a:srgbClr val="FFFFFF"/>
+                </a:solidFill>
+                <a:latin typeface="Yu Gothic UI"/>
+                <a:ea typeface="Yu Gothic UI"/>
+              </a:rPr>
+              <a:t>FrameworkOnCore の System.Web のコア ― 全種類で共通(referencesource の移植)</a:t>
+            </a:r>
+          </a:p>
+        </p:txBody>
+      </p:sp>
+      <p:sp>
+        <p:nvSpPr>
+          <p:cNvPr id="52" name="Rounded Rectangle 51"/>
+          <p:cNvSpPr/>
+          <p:nvPr/>
+        </p:nvSpPr>
+        <p:spPr>
+          <a:xfrm>
+            <a:off x="491965" y="2361434"/>
+            <a:ext cx="1693591" cy="167268"/>
           </a:xfrm>
           <a:prstGeom prst="roundRect">
             <a:avLst>
@@ -17600,21 +17654,21 @@
                 <a:latin typeface="Yu Gothic UI"/>
                 <a:ea typeface="Yu Gothic UI"/>
               </a:rPr>
-              <a:t>セッション・キャッシュ</a:t>
-            </a:r>
-          </a:p>
-        </p:txBody>
-      </p:sp>
-      <p:sp>
-        <p:nvSpPr>
-          <p:cNvPr id="52" name="Rounded Rectangle 51"/>
-          <p:cNvSpPr/>
-          <p:nvPr/>
-        </p:nvSpPr>
-        <p:spPr>
-          <a:xfrm>
-            <a:off x="491965" y="2558220"/>
-            <a:ext cx="1977701" cy="167268"/>
+              <a:t>HttpApplication・パイプライン</a:t>
+            </a:r>
+          </a:p>
+        </p:txBody>
+      </p:sp>
+      <p:sp>
+        <p:nvSpPr>
+          <p:cNvPr id="53" name="Rounded Rectangle 52"/>
+          <p:cNvSpPr/>
+          <p:nvPr/>
+        </p:nvSpPr>
+        <p:spPr>
+          <a:xfrm>
+            <a:off x="2215074" y="2361434"/>
+            <a:ext cx="1538622" cy="167268"/>
           </a:xfrm>
           <a:prstGeom prst="roundRect">
             <a:avLst>
@@ -17656,21 +17710,21 @@
                 <a:latin typeface="Yu Gothic UI"/>
                 <a:ea typeface="Yu Gothic UI"/>
               </a:rPr>
-              <a:t>フォーム認証・メンバーシップ・ロール</a:t>
-            </a:r>
-          </a:p>
-        </p:txBody>
-      </p:sp>
-      <p:sp>
-        <p:nvSpPr>
-          <p:cNvPr id="53" name="Rounded Rectangle 52"/>
-          <p:cNvSpPr/>
-          <p:nvPr/>
-        </p:nvSpPr>
-        <p:spPr>
-          <a:xfrm>
-            <a:off x="2499185" y="2558220"/>
-            <a:ext cx="1362990" cy="167268"/>
+              <a:t>HTTP モジュール・ハンドラー</a:t>
+            </a:r>
+          </a:p>
+        </p:txBody>
+      </p:sp>
+      <p:sp>
+        <p:nvSpPr>
+          <p:cNvPr id="54" name="Rounded Rectangle 53"/>
+          <p:cNvSpPr/>
+          <p:nvPr/>
+        </p:nvSpPr>
+        <p:spPr>
+          <a:xfrm>
+            <a:off x="3783215" y="2361434"/>
+            <a:ext cx="1874388" cy="167268"/>
           </a:xfrm>
           <a:prstGeom prst="roundRect">
             <a:avLst>
@@ -17712,21 +17766,21 @@
                 <a:latin typeface="Yu Gothic UI"/>
                 <a:ea typeface="Yu Gothic UI"/>
               </a:rPr>
-              <a:t>web.config のセクション</a:t>
-            </a:r>
-          </a:p>
-        </p:txBody>
-      </p:sp>
-      <p:sp>
-        <p:nvSpPr>
-          <p:cNvPr id="54" name="Rounded Rectangle 53"/>
-          <p:cNvSpPr/>
-          <p:nvPr/>
-        </p:nvSpPr>
-        <p:spPr>
-          <a:xfrm>
-            <a:off x="3891693" y="2558220"/>
-            <a:ext cx="2153333" cy="167268"/>
+              <a:t>ルーティング(System.Web.Routing)</a:t>
+            </a:r>
+          </a:p>
+        </p:txBody>
+      </p:sp>
+      <p:sp>
+        <p:nvSpPr>
+          <p:cNvPr id="55" name="Rounded Rectangle 54"/>
+          <p:cNvSpPr/>
+          <p:nvPr/>
+        </p:nvSpPr>
+        <p:spPr>
+          <a:xfrm>
+            <a:off x="5687121" y="2361434"/>
+            <a:ext cx="1254512" cy="167268"/>
           </a:xfrm>
           <a:prstGeom prst="roundRect">
             <a:avLst>
@@ -17768,61 +17822,7 @@
                 <a:latin typeface="Yu Gothic UI"/>
                 <a:ea typeface="Yu Gothic UI"/>
               </a:rPr>
-              <a:t>Compilers(実行時コンパイル + 書き換え)</a:t>
-            </a:r>
-          </a:p>
-        </p:txBody>
-      </p:sp>
-      <p:sp>
-        <p:nvSpPr>
-          <p:cNvPr id="55" name="Rectangle 54"/>
-          <p:cNvSpPr/>
-          <p:nvPr/>
-        </p:nvSpPr>
-        <p:spPr>
-          <a:xfrm>
-            <a:off x="432929" y="2814043"/>
-            <a:ext cx="5470657" cy="610037"/>
-          </a:xfrm>
-          <a:prstGeom prst="rect">
-            <a:avLst/>
-          </a:prstGeom>
-          <a:solidFill>
-            <a:srgbClr val="C8102E"/>
-          </a:solidFill>
-          <a:ln>
-            <a:noFill/>
-          </a:ln>
-          <a:effectLst/>
-        </p:spPr>
-        <p:style>
-          <a:lnRef idx="1">
-            <a:schemeClr val="accent1"/>
-          </a:lnRef>
-          <a:fillRef idx="3">
-            <a:schemeClr val="accent1"/>
-          </a:fillRef>
-          <a:effectRef idx="2">
-            <a:schemeClr val="accent1"/>
-          </a:effectRef>
-          <a:fontRef idx="minor">
-            <a:schemeClr val="lt1"/>
-          </a:fontRef>
-        </p:style>
-        <p:txBody>
-          <a:bodyPr rtlCol="0" anchor="t" wrap="square" lIns="49196" rIns="49196" tIns="19678" bIns="19678"/>
-          <a:lstStyle/>
-          <a:p>
-            <a:pPr algn="l"/>
-            <a:r>
-              <a:rPr sz="929" b="1">
-                <a:solidFill>
-                  <a:srgbClr val="FFFFFF"/>
-                </a:solidFill>
-                <a:latin typeface="Yu Gothic UI"/>
-                <a:ea typeface="Yu Gothic UI"/>
-              </a:rPr>
-              <a:t>IIS 互換ミドルウェア(FrameworkOnCore。IIS と同じ順、既定は IIS 互換)</a:t>
+              <a:t>セッション・キャッシュ</a:t>
             </a:r>
           </a:p>
         </p:txBody>
@@ -17835,8 +17835,8 @@
         </p:nvSpPr>
         <p:spPr>
           <a:xfrm>
-            <a:off x="491965" y="3030507"/>
-            <a:ext cx="551985" cy="167268"/>
+            <a:off x="491965" y="2558220"/>
+            <a:ext cx="1977701" cy="167268"/>
           </a:xfrm>
           <a:prstGeom prst="roundRect">
             <a:avLst>
@@ -17878,7 +17878,7 @@
                 <a:latin typeface="Yu Gothic UI"/>
                 <a:ea typeface="Yu Gothic UI"/>
               </a:rPr>
-              <a:t>W3C ログ</a:t>
+              <a:t>フォーム認証・メンバーシップ・ロール</a:t>
             </a:r>
           </a:p>
         </p:txBody>
@@ -17891,8 +17891,8 @@
         </p:nvSpPr>
         <p:spPr>
           <a:xfrm>
-            <a:off x="1073468" y="3030507"/>
-            <a:ext cx="1590278" cy="167268"/>
+            <a:off x="2499185" y="2558220"/>
+            <a:ext cx="1362990" cy="167268"/>
           </a:xfrm>
           <a:prstGeom prst="roundRect">
             <a:avLst>
@@ -17934,7 +17934,7 @@
                 <a:latin typeface="Yu Gothic UI"/>
                 <a:ea typeface="Yu Gothic UI"/>
               </a:rPr>
-              <a:t>応答ヘッダー(customHeaders)</a:t>
+              <a:t>web.config のセクション</a:t>
             </a:r>
           </a:p>
         </p:txBody>
@@ -17947,8 +17947,8 @@
         </p:nvSpPr>
         <p:spPr>
           <a:xfrm>
-            <a:off x="2693265" y="3030507"/>
-            <a:ext cx="324697" cy="167268"/>
+            <a:off x="3891693" y="2558220"/>
+            <a:ext cx="2153333" cy="167268"/>
           </a:xfrm>
           <a:prstGeom prst="roundRect">
             <a:avLst>
@@ -17990,21 +17990,75 @@
                 <a:latin typeface="Yu Gothic UI"/>
                 <a:ea typeface="Yu Gothic UI"/>
               </a:rPr>
-              <a:t>圧縮</a:t>
-            </a:r>
-          </a:p>
-        </p:txBody>
-      </p:sp>
-      <p:sp>
-        <p:nvSpPr>
-          <p:cNvPr id="59" name="Rounded Rectangle 58"/>
-          <p:cNvSpPr/>
-          <p:nvPr/>
-        </p:nvSpPr>
-        <p:spPr>
-          <a:xfrm>
-            <a:off x="3047480" y="3030507"/>
-            <a:ext cx="1476634" cy="167268"/>
+              <a:t>Compilers(実行時コンパイル + 書き換え)</a:t>
+            </a:r>
+          </a:p>
+        </p:txBody>
+      </p:sp>
+      <p:sp>
+        <p:nvSpPr>
+          <p:cNvPr id="59" name="Rectangle 58"/>
+          <p:cNvSpPr/>
+          <p:nvPr/>
+        </p:nvSpPr>
+        <p:spPr>
+          <a:xfrm>
+            <a:off x="432929" y="2814043"/>
+            <a:ext cx="5470657" cy="610037"/>
+          </a:xfrm>
+          <a:prstGeom prst="rect">
+            <a:avLst/>
+          </a:prstGeom>
+          <a:solidFill>
+            <a:srgbClr val="C8102E"/>
+          </a:solidFill>
+          <a:ln>
+            <a:noFill/>
+          </a:ln>
+          <a:effectLst/>
+        </p:spPr>
+        <p:style>
+          <a:lnRef idx="1">
+            <a:schemeClr val="accent1"/>
+          </a:lnRef>
+          <a:fillRef idx="3">
+            <a:schemeClr val="accent1"/>
+          </a:fillRef>
+          <a:effectRef idx="2">
+            <a:schemeClr val="accent1"/>
+          </a:effectRef>
+          <a:fontRef idx="minor">
+            <a:schemeClr val="lt1"/>
+          </a:fontRef>
+        </p:style>
+        <p:txBody>
+          <a:bodyPr rtlCol="0" anchor="t" wrap="square" lIns="49196" rIns="49196" tIns="19678" bIns="19678"/>
+          <a:lstStyle/>
+          <a:p>
+            <a:pPr algn="l"/>
+            <a:r>
+              <a:rPr sz="929" b="1">
+                <a:solidFill>
+                  <a:srgbClr val="FFFFFF"/>
+                </a:solidFill>
+                <a:latin typeface="Yu Gothic UI"/>
+                <a:ea typeface="Yu Gothic UI"/>
+              </a:rPr>
+              <a:t>IIS 互換ミドルウェア(FrameworkOnCore。IIS と同じ順、既定は IIS 互換)</a:t>
+            </a:r>
+          </a:p>
+        </p:txBody>
+      </p:sp>
+      <p:sp>
+        <p:nvSpPr>
+          <p:cNvPr id="60" name="Rounded Rectangle 59"/>
+          <p:cNvSpPr/>
+          <p:nvPr/>
+        </p:nvSpPr>
+        <p:spPr>
+          <a:xfrm>
+            <a:off x="491965" y="3030507"/>
+            <a:ext cx="551985" cy="167268"/>
           </a:xfrm>
           <a:prstGeom prst="roundRect">
             <a:avLst>
@@ -18046,21 +18100,21 @@
                 <a:latin typeface="Yu Gothic UI"/>
                 <a:ea typeface="Yu Gothic UI"/>
               </a:rPr>
-              <a:t>エラー ページ(httpErrors)</a:t>
-            </a:r>
-          </a:p>
-        </p:txBody>
-      </p:sp>
-      <p:sp>
-        <p:nvSpPr>
-          <p:cNvPr id="60" name="Rounded Rectangle 59"/>
-          <p:cNvSpPr/>
-          <p:nvPr/>
-        </p:nvSpPr>
-        <p:spPr>
-          <a:xfrm>
-            <a:off x="4553633" y="3030507"/>
-            <a:ext cx="743113" cy="167268"/>
+              <a:t>W3C ログ</a:t>
+            </a:r>
+          </a:p>
+        </p:txBody>
+      </p:sp>
+      <p:sp>
+        <p:nvSpPr>
+          <p:cNvPr id="61" name="Rounded Rectangle 60"/>
+          <p:cNvSpPr/>
+          <p:nvPr/>
+        </p:nvSpPr>
+        <p:spPr>
+          <a:xfrm>
+            <a:off x="1073468" y="3030507"/>
+            <a:ext cx="1590278" cy="167268"/>
           </a:xfrm>
           <a:prstGeom prst="roundRect">
             <a:avLst>
@@ -18102,21 +18156,21 @@
                 <a:latin typeface="Yu Gothic UI"/>
                 <a:ea typeface="Yu Gothic UI"/>
               </a:rPr>
-              <a:t>URL Rewrite</a:t>
-            </a:r>
-          </a:p>
-        </p:txBody>
-      </p:sp>
-      <p:sp>
-        <p:nvSpPr>
-          <p:cNvPr id="61" name="Rounded Rectangle 60"/>
-          <p:cNvSpPr/>
-          <p:nvPr/>
-        </p:nvSpPr>
-        <p:spPr>
-          <a:xfrm>
-            <a:off x="491965" y="3227294"/>
-            <a:ext cx="799936" cy="167268"/>
+              <a:t>応答ヘッダー(customHeaders)</a:t>
+            </a:r>
+          </a:p>
+        </p:txBody>
+      </p:sp>
+      <p:sp>
+        <p:nvSpPr>
+          <p:cNvPr id="62" name="Rounded Rectangle 61"/>
+          <p:cNvSpPr/>
+          <p:nvPr/>
+        </p:nvSpPr>
+        <p:spPr>
+          <a:xfrm>
+            <a:off x="2693265" y="3030507"/>
+            <a:ext cx="324697" cy="167268"/>
           </a:xfrm>
           <a:prstGeom prst="roundRect">
             <a:avLst>
@@ -18158,21 +18212,21 @@
                 <a:latin typeface="Yu Gothic UI"/>
                 <a:ea typeface="Yu Gothic UI"/>
               </a:rPr>
-              <a:t>httpRedirect</a:t>
-            </a:r>
-          </a:p>
-        </p:txBody>
-      </p:sp>
-      <p:sp>
-        <p:nvSpPr>
-          <p:cNvPr id="62" name="Rounded Rectangle 61"/>
-          <p:cNvSpPr/>
-          <p:nvPr/>
-        </p:nvSpPr>
-        <p:spPr>
-          <a:xfrm>
-            <a:off x="1321419" y="3227294"/>
-            <a:ext cx="2700890" cy="167268"/>
+              <a:t>圧縮</a:t>
+            </a:r>
+          </a:p>
+        </p:txBody>
+      </p:sp>
+      <p:sp>
+        <p:nvSpPr>
+          <p:cNvPr id="63" name="Rounded Rectangle 62"/>
+          <p:cNvSpPr/>
+          <p:nvPr/>
+        </p:nvSpPr>
+        <p:spPr>
+          <a:xfrm>
+            <a:off x="3047480" y="3030507"/>
+            <a:ext cx="1476634" cy="167268"/>
           </a:xfrm>
           <a:prstGeom prst="roundRect">
             <a:avLst>
@@ -18214,21 +18268,21 @@
                 <a:latin typeface="Yu Gothic UI"/>
                 <a:ea typeface="Yu Gothic UI"/>
               </a:rPr>
-              <a:t>既定のドキュメント・静的ファイル・フォルダーの一覧</a:t>
-            </a:r>
-          </a:p>
-        </p:txBody>
-      </p:sp>
-      <p:sp>
-        <p:nvSpPr>
-          <p:cNvPr id="63" name="Rounded Rectangle 62"/>
-          <p:cNvSpPr/>
-          <p:nvPr/>
-        </p:nvSpPr>
-        <p:spPr>
-          <a:xfrm>
-            <a:off x="4051828" y="3227294"/>
-            <a:ext cx="634635" cy="167268"/>
+              <a:t>エラー ページ(httpErrors)</a:t>
+            </a:r>
+          </a:p>
+        </p:txBody>
+      </p:sp>
+      <p:sp>
+        <p:nvSpPr>
+          <p:cNvPr id="64" name="Rounded Rectangle 63"/>
+          <p:cNvSpPr/>
+          <p:nvPr/>
+        </p:nvSpPr>
+        <p:spPr>
+          <a:xfrm>
+            <a:off x="4553633" y="3030507"/>
+            <a:ext cx="743113" cy="167268"/>
           </a:xfrm>
           <a:prstGeom prst="roundRect">
             <a:avLst>
@@ -18270,61 +18324,7 @@
                 <a:latin typeface="Yu Gothic UI"/>
                 <a:ea typeface="Yu Gothic UI"/>
               </a:rPr>
-              <a:t>セッション</a:t>
-            </a:r>
-          </a:p>
-        </p:txBody>
-      </p:sp>
-      <p:sp>
-        <p:nvSpPr>
-          <p:cNvPr id="64" name="Rectangle 63"/>
-          <p:cNvSpPr/>
-          <p:nvPr/>
-        </p:nvSpPr>
-        <p:spPr>
-          <a:xfrm>
-            <a:off x="432929" y="3453598"/>
-            <a:ext cx="5470657" cy="393572"/>
-          </a:xfrm>
-          <a:prstGeom prst="rect">
-            <a:avLst/>
-          </a:prstGeom>
-          <a:solidFill>
-            <a:srgbClr val="C8102E"/>
-          </a:solidFill>
-          <a:ln>
-            <a:noFill/>
-          </a:ln>
-          <a:effectLst/>
-        </p:spPr>
-        <p:style>
-          <a:lnRef idx="1">
-            <a:schemeClr val="accent1"/>
-          </a:lnRef>
-          <a:fillRef idx="3">
-            <a:schemeClr val="accent1"/>
-          </a:fillRef>
-          <a:effectRef idx="2">
-            <a:schemeClr val="accent1"/>
-          </a:effectRef>
-          <a:fontRef idx="minor">
-            <a:schemeClr val="lt1"/>
-          </a:fontRef>
-        </p:style>
-        <p:txBody>
-          <a:bodyPr rtlCol="0" anchor="t" wrap="square" lIns="49196" rIns="49196" tIns="19678" bIns="19678"/>
-          <a:lstStyle/>
-          <a:p>
-            <a:pPr algn="l"/>
-            <a:r>
-              <a:rPr sz="929" b="1">
-                <a:solidFill>
-                  <a:srgbClr val="FFFFFF"/>
-                </a:solidFill>
-                <a:latin typeface="Yu Gothic UI"/>
-                <a:ea typeface="Yu Gothic UI"/>
-              </a:rPr>
-              <a:t>作業プロセス(FrameworkOnCore。アプリケーション プールの役目)</a:t>
+              <a:t>URL Rewrite</a:t>
             </a:r>
           </a:p>
         </p:txBody>
@@ -18337,8 +18337,8 @@
         </p:nvSpPr>
         <p:spPr>
           <a:xfrm>
-            <a:off x="491965" y="3670063"/>
-            <a:ext cx="1740082" cy="167268"/>
+            <a:off x="491965" y="3227294"/>
+            <a:ext cx="799936" cy="167268"/>
           </a:xfrm>
           <a:prstGeom prst="roundRect">
             <a:avLst>
@@ -18380,7 +18380,7 @@
                 <a:latin typeface="Yu Gothic UI"/>
                 <a:ea typeface="Yu Gothic UI"/>
               </a:rPr>
-              <a:t>web.config・bin の変更で再起動</a:t>
+              <a:t>httpRedirect</a:t>
             </a:r>
           </a:p>
         </p:txBody>
@@ -18393,8 +18393,8 @@
         </p:nvSpPr>
         <p:spPr>
           <a:xfrm>
-            <a:off x="2261565" y="3670063"/>
-            <a:ext cx="1171861" cy="167268"/>
+            <a:off x="1321419" y="3227294"/>
+            <a:ext cx="2700890" cy="167268"/>
           </a:xfrm>
           <a:prstGeom prst="roundRect">
             <a:avLst>
@@ -18436,7 +18436,7 @@
                 <a:latin typeface="Yu Gothic UI"/>
                 <a:ea typeface="Yu Gothic UI"/>
               </a:rPr>
-              <a:t>bin のコピーから実行</a:t>
+              <a:t>既定のドキュメント・静的ファイル・フォルダーの一覧</a:t>
             </a:r>
           </a:p>
         </p:txBody>
@@ -18449,8 +18449,8 @@
         </p:nvSpPr>
         <p:spPr>
           <a:xfrm>
-            <a:off x="3462945" y="3670063"/>
-            <a:ext cx="1755579" cy="167268"/>
+            <a:off x="4051828" y="3227294"/>
+            <a:ext cx="634635" cy="167268"/>
           </a:xfrm>
           <a:prstGeom prst="roundRect">
             <a:avLst>
@@ -18492,7 +18492,7 @@
                 <a:latin typeface="Yu Gothic UI"/>
                 <a:ea typeface="Yu Gothic UI"/>
               </a:rPr>
-              <a:t>再起動中の要求を待たせる(Linux)</a:t>
+              <a:t>セッション</a:t>
             </a:r>
           </a:p>
         </p:txBody>
@@ -18505,14 +18505,14 @@
         </p:nvSpPr>
         <p:spPr>
           <a:xfrm>
-            <a:off x="432929" y="3876688"/>
+            <a:off x="432929" y="3453598"/>
             <a:ext cx="5470657" cy="393572"/>
           </a:xfrm>
           <a:prstGeom prst="rect">
             <a:avLst/>
           </a:prstGeom>
           <a:solidFill>
-            <a:srgbClr val="3B73B9"/>
+            <a:srgbClr val="C8102E"/>
           </a:solidFill>
           <a:ln>
             <a:noFill/>
@@ -18546,7 +18546,7 @@
                 <a:latin typeface="Yu Gothic UI"/>
                 <a:ea typeface="Yu Gothic UI"/>
               </a:rPr>
-              <a:t>ASP.NET Core(Microsoft)</a:t>
+              <a:t>作業プロセス(FrameworkOnCore。アプリケーション プールの役目)</a:t>
             </a:r>
           </a:p>
         </p:txBody>
@@ -18559,7 +18559,7 @@
         </p:nvSpPr>
         <p:spPr>
           <a:xfrm>
-            <a:off x="491965" y="4093153"/>
+            <a:off x="491965" y="3670063"/>
             <a:ext cx="1740082" cy="167268"/>
           </a:xfrm>
           <a:prstGeom prst="roundRect">
@@ -18568,7 +18568,7 @@
             </a:avLst>
           </a:prstGeom>
           <a:solidFill>
-            <a:srgbClr val="E7EEF7"/>
+            <a:srgbClr val="F8E2E6"/>
           </a:solidFill>
           <a:ln>
             <a:noFill/>
@@ -18602,7 +18602,7 @@
                 <a:latin typeface="Yu Gothic UI"/>
                 <a:ea typeface="Yu Gothic UI"/>
               </a:rPr>
-              <a:t>Kestrel(.NET の上のライブラリ)</a:t>
+              <a:t>web.config・bin の変更で再起動</a:t>
             </a:r>
           </a:p>
         </p:txBody>
@@ -18615,8 +18615,8 @@
         </p:nvSpPr>
         <p:spPr>
           <a:xfrm>
-            <a:off x="2261565" y="4093153"/>
-            <a:ext cx="1461137" cy="167268"/>
+            <a:off x="2261565" y="3670063"/>
+            <a:ext cx="1171861" cy="167268"/>
           </a:xfrm>
           <a:prstGeom prst="roundRect">
             <a:avLst>
@@ -18624,7 +18624,7 @@
             </a:avLst>
           </a:prstGeom>
           <a:solidFill>
-            <a:srgbClr val="E7EEF7"/>
+            <a:srgbClr val="F8E2E6"/>
           </a:solidFill>
           <a:ln>
             <a:noFill/>
@@ -18658,7 +18658,7 @@
                 <a:latin typeface="Yu Gothic UI"/>
                 <a:ea typeface="Yu Gothic UI"/>
               </a:rPr>
-              <a:t>ミドルウェアのパイプライン</a:t>
+              <a:t>bin のコピーから実行</a:t>
             </a:r>
           </a:p>
         </p:txBody>
@@ -18671,8 +18671,8 @@
         </p:nvSpPr>
         <p:spPr>
           <a:xfrm>
-            <a:off x="3752221" y="4093153"/>
-            <a:ext cx="851592" cy="167268"/>
+            <a:off x="3462945" y="3670063"/>
+            <a:ext cx="1755579" cy="167268"/>
           </a:xfrm>
           <a:prstGeom prst="roundRect">
             <a:avLst>
@@ -18680,7 +18680,7 @@
             </a:avLst>
           </a:prstGeom>
           <a:solidFill>
-            <a:srgbClr val="E7EEF7"/>
+            <a:srgbClr val="F8E2E6"/>
           </a:solidFill>
           <a:ln>
             <a:noFill/>
@@ -18714,21 +18714,75 @@
                 <a:latin typeface="Yu Gothic UI"/>
                 <a:ea typeface="Yu Gothic UI"/>
               </a:rPr>
-              <a:t>構成・ログ・DI</a:t>
-            </a:r>
-          </a:p>
-        </p:txBody>
-      </p:sp>
-      <p:sp>
-        <p:nvSpPr>
-          <p:cNvPr id="72" name="Rounded Rectangle 71"/>
-          <p:cNvSpPr/>
-          <p:nvPr/>
-        </p:nvSpPr>
-        <p:spPr>
-          <a:xfrm>
-            <a:off x="4034117" y="3896367"/>
-            <a:ext cx="1656448" cy="196786"/>
+              <a:t>再起動中の要求を待たせる(Linux)</a:t>
+            </a:r>
+          </a:p>
+        </p:txBody>
+      </p:sp>
+      <p:sp>
+        <p:nvSpPr>
+          <p:cNvPr id="72" name="Rectangle 71"/>
+          <p:cNvSpPr/>
+          <p:nvPr/>
+        </p:nvSpPr>
+        <p:spPr>
+          <a:xfrm>
+            <a:off x="432929" y="3876688"/>
+            <a:ext cx="5470657" cy="511644"/>
+          </a:xfrm>
+          <a:prstGeom prst="rect">
+            <a:avLst/>
+          </a:prstGeom>
+          <a:solidFill>
+            <a:srgbClr val="3B73B9"/>
+          </a:solidFill>
+          <a:ln>
+            <a:noFill/>
+          </a:ln>
+          <a:effectLst/>
+        </p:spPr>
+        <p:style>
+          <a:lnRef idx="1">
+            <a:schemeClr val="accent1"/>
+          </a:lnRef>
+          <a:fillRef idx="3">
+            <a:schemeClr val="accent1"/>
+          </a:fillRef>
+          <a:effectRef idx="2">
+            <a:schemeClr val="accent1"/>
+          </a:effectRef>
+          <a:fontRef idx="minor">
+            <a:schemeClr val="lt1"/>
+          </a:fontRef>
+        </p:style>
+        <p:txBody>
+          <a:bodyPr rtlCol="0" anchor="t" wrap="square" lIns="49196" rIns="49196" tIns="19678" bIns="19678"/>
+          <a:lstStyle/>
+          <a:p>
+            <a:pPr algn="l"/>
+            <a:r>
+              <a:rPr sz="929" b="1">
+                <a:solidFill>
+                  <a:srgbClr val="FFFFFF"/>
+                </a:solidFill>
+                <a:latin typeface="Yu Gothic UI"/>
+                <a:ea typeface="Yu Gothic UI"/>
+              </a:rPr>
+              <a:t>ASP.NET Core(Microsoft)</a:t>
+            </a:r>
+          </a:p>
+        </p:txBody>
+      </p:sp>
+      <p:sp>
+        <p:nvSpPr>
+          <p:cNvPr id="73" name="Rounded Rectangle 72"/>
+          <p:cNvSpPr/>
+          <p:nvPr/>
+        </p:nvSpPr>
+        <p:spPr>
+          <a:xfrm>
+            <a:off x="491965" y="4093153"/>
+            <a:ext cx="1740082" cy="167268"/>
           </a:xfrm>
           <a:prstGeom prst="roundRect">
             <a:avLst>
@@ -18736,6 +18790,174 @@
             </a:avLst>
           </a:prstGeom>
           <a:solidFill>
+            <a:srgbClr val="E7EEF7"/>
+          </a:solidFill>
+          <a:ln>
+            <a:noFill/>
+          </a:ln>
+          <a:effectLst/>
+        </p:spPr>
+        <p:style>
+          <a:lnRef idx="1">
+            <a:schemeClr val="accent1"/>
+          </a:lnRef>
+          <a:fillRef idx="3">
+            <a:schemeClr val="accent1"/>
+          </a:fillRef>
+          <a:effectRef idx="2">
+            <a:schemeClr val="accent1"/>
+          </a:effectRef>
+          <a:fontRef idx="minor">
+            <a:schemeClr val="lt1"/>
+          </a:fontRef>
+        </p:style>
+        <p:txBody>
+          <a:bodyPr rtlCol="0" anchor="ctr" wrap="none" lIns="49196" rIns="49196" tIns="19678" bIns="19678"/>
+          <a:lstStyle/>
+          <a:p>
+            <a:pPr algn="l"/>
+            <a:r>
+              <a:rPr sz="812" b="1">
+                <a:solidFill>
+                  <a:srgbClr val="333333"/>
+                </a:solidFill>
+                <a:latin typeface="Yu Gothic UI"/>
+                <a:ea typeface="Yu Gothic UI"/>
+              </a:rPr>
+              <a:t>Kestrel(.NET の上のライブラリ)</a:t>
+            </a:r>
+          </a:p>
+        </p:txBody>
+      </p:sp>
+      <p:sp>
+        <p:nvSpPr>
+          <p:cNvPr id="74" name="Rounded Rectangle 73"/>
+          <p:cNvSpPr/>
+          <p:nvPr/>
+        </p:nvSpPr>
+        <p:spPr>
+          <a:xfrm>
+            <a:off x="2261565" y="4093153"/>
+            <a:ext cx="1461137" cy="167268"/>
+          </a:xfrm>
+          <a:prstGeom prst="roundRect">
+            <a:avLst>
+              <a:gd name="adj" fmla="val 18000"/>
+            </a:avLst>
+          </a:prstGeom>
+          <a:solidFill>
+            <a:srgbClr val="E7EEF7"/>
+          </a:solidFill>
+          <a:ln>
+            <a:noFill/>
+          </a:ln>
+          <a:effectLst/>
+        </p:spPr>
+        <p:style>
+          <a:lnRef idx="1">
+            <a:schemeClr val="accent1"/>
+          </a:lnRef>
+          <a:fillRef idx="3">
+            <a:schemeClr val="accent1"/>
+          </a:fillRef>
+          <a:effectRef idx="2">
+            <a:schemeClr val="accent1"/>
+          </a:effectRef>
+          <a:fontRef idx="minor">
+            <a:schemeClr val="lt1"/>
+          </a:fontRef>
+        </p:style>
+        <p:txBody>
+          <a:bodyPr rtlCol="0" anchor="ctr" wrap="none" lIns="49196" rIns="49196" tIns="19678" bIns="19678"/>
+          <a:lstStyle/>
+          <a:p>
+            <a:pPr algn="l"/>
+            <a:r>
+              <a:rPr sz="812" b="1">
+                <a:solidFill>
+                  <a:srgbClr val="333333"/>
+                </a:solidFill>
+                <a:latin typeface="Yu Gothic UI"/>
+                <a:ea typeface="Yu Gothic UI"/>
+              </a:rPr>
+              <a:t>ミドルウェアのパイプライン</a:t>
+            </a:r>
+          </a:p>
+        </p:txBody>
+      </p:sp>
+      <p:sp>
+        <p:nvSpPr>
+          <p:cNvPr id="75" name="Rounded Rectangle 74"/>
+          <p:cNvSpPr/>
+          <p:nvPr/>
+        </p:nvSpPr>
+        <p:spPr>
+          <a:xfrm>
+            <a:off x="3752221" y="4093153"/>
+            <a:ext cx="851592" cy="167268"/>
+          </a:xfrm>
+          <a:prstGeom prst="roundRect">
+            <a:avLst>
+              <a:gd name="adj" fmla="val 18000"/>
+            </a:avLst>
+          </a:prstGeom>
+          <a:solidFill>
+            <a:srgbClr val="E7EEF7"/>
+          </a:solidFill>
+          <a:ln>
+            <a:noFill/>
+          </a:ln>
+          <a:effectLst/>
+        </p:spPr>
+        <p:style>
+          <a:lnRef idx="1">
+            <a:schemeClr val="accent1"/>
+          </a:lnRef>
+          <a:fillRef idx="3">
+            <a:schemeClr val="accent1"/>
+          </a:fillRef>
+          <a:effectRef idx="2">
+            <a:schemeClr val="accent1"/>
+          </a:effectRef>
+          <a:fontRef idx="minor">
+            <a:schemeClr val="lt1"/>
+          </a:fontRef>
+        </p:style>
+        <p:txBody>
+          <a:bodyPr rtlCol="0" anchor="ctr" wrap="none" lIns="49196" rIns="49196" tIns="19678" bIns="19678"/>
+          <a:lstStyle/>
+          <a:p>
+            <a:pPr algn="l"/>
+            <a:r>
+              <a:rPr sz="812" b="1">
+                <a:solidFill>
+                  <a:srgbClr val="333333"/>
+                </a:solidFill>
+                <a:latin typeface="Yu Gothic UI"/>
+                <a:ea typeface="Yu Gothic UI"/>
+              </a:rPr>
+              <a:t>構成・ログ・DI</a:t>
+            </a:r>
+          </a:p>
+        </p:txBody>
+      </p:sp>
+      <p:sp>
+        <p:nvSpPr>
+          <p:cNvPr id="76" name="Rounded Rectangle 75"/>
+          <p:cNvSpPr/>
+          <p:nvPr/>
+        </p:nvSpPr>
+        <p:spPr>
+          <a:xfrm>
+            <a:off x="4034117" y="3896367"/>
+            <a:ext cx="1656448" cy="196786"/>
+          </a:xfrm>
+          <a:prstGeom prst="roundRect">
+            <a:avLst>
+              <a:gd name="adj" fmla="val 18000"/>
+            </a:avLst>
+          </a:prstGeom>
+          <a:solidFill>
             <a:srgbClr val="F2C200"/>
           </a:solidFill>
           <a:ln w="14748">
@@ -18779,14 +19001,14 @@
       </p:sp>
       <p:sp>
         <p:nvSpPr>
-          <p:cNvPr id="73" name="Rectangle 72"/>
+          <p:cNvPr id="77" name="Rectangle 76"/>
           <p:cNvSpPr/>
           <p:nvPr/>
         </p:nvSpPr>
         <p:spPr>
           <a:xfrm>
             <a:off x="5942944" y="2814043"/>
-            <a:ext cx="3109222" cy="1456218"/>
+            <a:ext cx="2007219" cy="1574289"/>
           </a:xfrm>
           <a:prstGeom prst="rect">
             <a:avLst/>
@@ -18826,21 +19048,34 @@
                 <a:latin typeface="Yu Gothic UI"/>
                 <a:ea typeface="Yu Gothic UI"/>
               </a:rPr>
-              <a:t>ライブラリの移植・代わり ― 全種類で共通</a:t>
-            </a:r>
-          </a:p>
-        </p:txBody>
-      </p:sp>
-      <p:sp>
-        <p:nvSpPr>
-          <p:cNvPr id="74" name="Rounded Rectangle 73"/>
-          <p:cNvSpPr/>
-          <p:nvPr/>
-        </p:nvSpPr>
-        <p:spPr>
-          <a:xfrm>
-            <a:off x="6001979" y="3030507"/>
-            <a:ext cx="949739" cy="167268"/>
+              <a:t>ライブラリの移植・代わり</a:t>
+            </a:r>
+          </a:p>
+          <a:p>
+            <a:pPr algn="l"/>
+            <a:r>
+              <a:rPr sz="929" b="1">
+                <a:solidFill>
+                  <a:srgbClr val="FFFFFF"/>
+                </a:solidFill>
+                <a:latin typeface="Yu Gothic UI"/>
+                <a:ea typeface="Yu Gothic UI"/>
+              </a:rPr>
+              <a:t>(全種類で共通)</a:t>
+            </a:r>
+          </a:p>
+        </p:txBody>
+      </p:sp>
+      <p:sp>
+        <p:nvSpPr>
+          <p:cNvPr id="78" name="Rounded Rectangle 77"/>
+          <p:cNvSpPr/>
+          <p:nvPr/>
+        </p:nvSpPr>
+        <p:spPr>
+          <a:xfrm>
+            <a:off x="6001979" y="3187936"/>
+            <a:ext cx="1889147" cy="167268"/>
           </a:xfrm>
           <a:prstGeom prst="roundRect">
             <a:avLst>
@@ -18889,14 +19124,14 @@
       </p:sp>
       <p:sp>
         <p:nvSpPr>
-          <p:cNvPr id="75" name="Rounded Rectangle 74"/>
-          <p:cNvSpPr/>
-          <p:nvPr/>
-        </p:nvSpPr>
-        <p:spPr>
-          <a:xfrm>
-            <a:off x="6981237" y="3030507"/>
-            <a:ext cx="1063383" cy="167268"/>
+          <p:cNvPr id="79" name="Rounded Rectangle 78"/>
+          <p:cNvSpPr/>
+          <p:nvPr/>
+        </p:nvSpPr>
+        <p:spPr>
+          <a:xfrm>
+            <a:off x="6001979" y="3384723"/>
+            <a:ext cx="1889147" cy="167268"/>
           </a:xfrm>
           <a:prstGeom prst="roundRect">
             <a:avLst>
@@ -18945,14 +19180,14 @@
       </p:sp>
       <p:sp>
         <p:nvSpPr>
-          <p:cNvPr id="76" name="Rounded Rectangle 75"/>
-          <p:cNvSpPr/>
-          <p:nvPr/>
-        </p:nvSpPr>
-        <p:spPr>
-          <a:xfrm>
-            <a:off x="8074138" y="3030507"/>
-            <a:ext cx="629469" cy="167268"/>
+          <p:cNvPr id="80" name="Rounded Rectangle 79"/>
+          <p:cNvSpPr/>
+          <p:nvPr/>
+        </p:nvSpPr>
+        <p:spPr>
+          <a:xfrm>
+            <a:off x="6001979" y="3581509"/>
+            <a:ext cx="1889147" cy="167268"/>
           </a:xfrm>
           <a:prstGeom prst="roundRect">
             <a:avLst>
@@ -19001,14 +19236,14 @@
       </p:sp>
       <p:sp>
         <p:nvSpPr>
-          <p:cNvPr id="77" name="Rounded Rectangle 76"/>
-          <p:cNvSpPr/>
-          <p:nvPr/>
-        </p:nvSpPr>
-        <p:spPr>
-          <a:xfrm>
-            <a:off x="6001979" y="3227294"/>
-            <a:ext cx="1471469" cy="167268"/>
+          <p:cNvPr id="81" name="Rounded Rectangle 80"/>
+          <p:cNvSpPr/>
+          <p:nvPr/>
+        </p:nvSpPr>
+        <p:spPr>
+          <a:xfrm>
+            <a:off x="6001979" y="3778295"/>
+            <a:ext cx="1889147" cy="167268"/>
           </a:xfrm>
           <a:prstGeom prst="roundRect">
             <a:avLst>
@@ -19050,21 +19285,21 @@
                 <a:latin typeface="Yu Gothic UI"/>
                 <a:ea typeface="Yu Gothic UI"/>
               </a:rPr>
-              <a:t>Drawing.Common(Linux 版)</a:t>
-            </a:r>
-          </a:p>
-        </p:txBody>
-      </p:sp>
-      <p:sp>
-        <p:nvSpPr>
-          <p:cNvPr id="78" name="Rounded Rectangle 77"/>
-          <p:cNvSpPr/>
-          <p:nvPr/>
-        </p:nvSpPr>
-        <p:spPr>
-          <a:xfrm>
-            <a:off x="7502966" y="3227294"/>
-            <a:ext cx="1290671" cy="167268"/>
+              <a:t>Drawing.Common(Linux)</a:t>
+            </a:r>
+          </a:p>
+        </p:txBody>
+      </p:sp>
+      <p:sp>
+        <p:nvSpPr>
+          <p:cNvPr id="82" name="Rounded Rectangle 81"/>
+          <p:cNvSpPr/>
+          <p:nvPr/>
+        </p:nvSpPr>
+        <p:spPr>
+          <a:xfrm>
+            <a:off x="6001979" y="3975081"/>
+            <a:ext cx="1889147" cy="167268"/>
           </a:xfrm>
           <a:prstGeom prst="roundRect">
             <a:avLst>
@@ -19113,14 +19348,14 @@
       </p:sp>
       <p:sp>
         <p:nvSpPr>
-          <p:cNvPr id="79" name="Rounded Rectangle 78"/>
-          <p:cNvSpPr/>
-          <p:nvPr/>
-        </p:nvSpPr>
-        <p:spPr>
-          <a:xfrm>
-            <a:off x="6001979" y="3424080"/>
-            <a:ext cx="1884720" cy="167268"/>
+          <p:cNvPr id="83" name="Rounded Rectangle 82"/>
+          <p:cNvSpPr/>
+          <p:nvPr/>
+        </p:nvSpPr>
+        <p:spPr>
+          <a:xfrm>
+            <a:off x="6001979" y="4171868"/>
+            <a:ext cx="1889147" cy="167268"/>
           </a:xfrm>
           <a:prstGeom prst="roundRect">
             <a:avLst>
@@ -19162,21 +19397,21 @@
                 <a:latin typeface="Yu Gothic UI"/>
                 <a:ea typeface="Yu Gothic UI"/>
               </a:rPr>
-              <a:t>構成(System.Configuration・移植)</a:t>
-            </a:r>
-          </a:p>
-        </p:txBody>
-      </p:sp>
-      <p:sp>
-        <p:nvSpPr>
-          <p:cNvPr id="80" name="Rectangle 79"/>
-          <p:cNvSpPr/>
-          <p:nvPr/>
-        </p:nvSpPr>
-        <p:spPr>
-          <a:xfrm>
-            <a:off x="432929" y="4309618"/>
-            <a:ext cx="4683512" cy="432929"/>
+              <a:t>構成(移植)</a:t>
+            </a:r>
+          </a:p>
+        </p:txBody>
+      </p:sp>
+      <p:sp>
+        <p:nvSpPr>
+          <p:cNvPr id="84" name="Rectangle 83"/>
+          <p:cNvSpPr/>
+          <p:nvPr/>
+        </p:nvSpPr>
+        <p:spPr>
+          <a:xfrm>
+            <a:off x="432929" y="4427690"/>
+            <a:ext cx="9563810" cy="432929"/>
           </a:xfrm>
           <a:prstGeom prst="rect">
             <a:avLst/>
@@ -19216,20 +19451,20 @@
                 <a:latin typeface="Yu Gothic UI"/>
                 <a:ea typeface="Yu Gothic UI"/>
               </a:rPr>
-              <a:t>.NET 10 クラスライブラリ(そのまま)</a:t>
-            </a:r>
-          </a:p>
-        </p:txBody>
-      </p:sp>
-      <p:sp>
-        <p:nvSpPr>
-          <p:cNvPr id="81" name="Rounded Rectangle 80"/>
-          <p:cNvSpPr/>
-          <p:nvPr/>
-        </p:nvSpPr>
-        <p:spPr>
-          <a:xfrm>
-            <a:off x="491965" y="4526083"/>
+              <a:t>.NET 10 クラスライブラリ(そのまま。Compat も、その上で動く)</a:t>
+            </a:r>
+          </a:p>
+        </p:txBody>
+      </p:sp>
+      <p:sp>
+        <p:nvSpPr>
+          <p:cNvPr id="85" name="Rounded Rectangle 84"/>
+          <p:cNvSpPr/>
+          <p:nvPr/>
+        </p:nvSpPr>
+        <p:spPr>
+          <a:xfrm>
+            <a:off x="491965" y="4644154"/>
             <a:ext cx="743113" cy="167268"/>
           </a:xfrm>
           <a:prstGeom prst="roundRect">
@@ -19279,13 +19514,13 @@
       </p:sp>
       <p:sp>
         <p:nvSpPr>
-          <p:cNvPr id="82" name="Rounded Rectangle 81"/>
-          <p:cNvSpPr/>
-          <p:nvPr/>
-        </p:nvSpPr>
-        <p:spPr>
-          <a:xfrm>
-            <a:off x="1264597" y="4526083"/>
+          <p:cNvPr id="86" name="Rounded Rectangle 85"/>
+          <p:cNvSpPr/>
+          <p:nvPr/>
+        </p:nvSpPr>
+        <p:spPr>
+          <a:xfrm>
+            <a:off x="1264597" y="4644154"/>
             <a:ext cx="686291" cy="167268"/>
           </a:xfrm>
           <a:prstGeom prst="roundRect">
@@ -19335,13 +19570,13 @@
       </p:sp>
       <p:sp>
         <p:nvSpPr>
-          <p:cNvPr id="83" name="Rounded Rectangle 82"/>
-          <p:cNvSpPr/>
-          <p:nvPr/>
-        </p:nvSpPr>
-        <p:spPr>
-          <a:xfrm>
-            <a:off x="1980407" y="4526083"/>
+          <p:cNvPr id="87" name="Rounded Rectangle 86"/>
+          <p:cNvSpPr/>
+          <p:nvPr/>
+        </p:nvSpPr>
+        <p:spPr>
+          <a:xfrm>
+            <a:off x="1980407" y="4644154"/>
             <a:ext cx="1027224" cy="167268"/>
           </a:xfrm>
           <a:prstGeom prst="roundRect">
@@ -19391,13 +19626,13 @@
       </p:sp>
       <p:sp>
         <p:nvSpPr>
-          <p:cNvPr id="84" name="Rounded Rectangle 83"/>
-          <p:cNvSpPr/>
-          <p:nvPr/>
-        </p:nvSpPr>
-        <p:spPr>
-          <a:xfrm>
-            <a:off x="3037149" y="4526083"/>
+          <p:cNvPr id="88" name="Rounded Rectangle 87"/>
+          <p:cNvSpPr/>
+          <p:nvPr/>
+        </p:nvSpPr>
+        <p:spPr>
+          <a:xfrm>
+            <a:off x="3037149" y="4644154"/>
             <a:ext cx="970402" cy="167268"/>
           </a:xfrm>
           <a:prstGeom prst="roundRect">
@@ -19447,68 +19682,14 @@
       </p:sp>
       <p:sp>
         <p:nvSpPr>
-          <p:cNvPr id="85" name="Rectangle 84"/>
-          <p:cNvSpPr/>
-          <p:nvPr/>
-        </p:nvSpPr>
-        <p:spPr>
-          <a:xfrm>
-            <a:off x="5155799" y="4309618"/>
-            <a:ext cx="4840941" cy="432929"/>
-          </a:xfrm>
-          <a:prstGeom prst="rect">
-            <a:avLst/>
-          </a:prstGeom>
-          <a:solidFill>
-            <a:srgbClr val="3AA357"/>
-          </a:solidFill>
-          <a:ln>
-            <a:noFill/>
-          </a:ln>
-          <a:effectLst/>
-        </p:spPr>
-        <p:style>
-          <a:lnRef idx="1">
-            <a:schemeClr val="accent1"/>
-          </a:lnRef>
-          <a:fillRef idx="3">
-            <a:schemeClr val="accent1"/>
-          </a:fillRef>
-          <a:effectRef idx="2">
-            <a:schemeClr val="accent1"/>
-          </a:effectRef>
-          <a:fontRef idx="minor">
-            <a:schemeClr val="lt1"/>
-          </a:fontRef>
-        </p:style>
-        <p:txBody>
-          <a:bodyPr rtlCol="0" anchor="t" wrap="square" lIns="49196" rIns="49196" tIns="19678" bIns="19678"/>
-          <a:lstStyle/>
-          <a:p>
-            <a:pPr algn="l"/>
-            <a:r>
-              <a:rPr sz="929" b="1">
-                <a:solidFill>
-                  <a:srgbClr val="FFFFFF"/>
-                </a:solidFill>
-                <a:latin typeface="Yu Gothic UI"/>
-                <a:ea typeface="Yu Gothic UI"/>
-              </a:rPr>
-              <a:t>FrameworkOnCore.Compat ― CoreLib の代わりにアプリが呼ぶ</a:t>
-            </a:r>
-          </a:p>
-        </p:txBody>
-      </p:sp>
-      <p:sp>
-        <p:nvSpPr>
-          <p:cNvPr id="86" name="Rounded Rectangle 85"/>
-          <p:cNvSpPr/>
-          <p:nvPr/>
-        </p:nvSpPr>
-        <p:spPr>
-          <a:xfrm>
-            <a:off x="5214835" y="4526083"/>
-            <a:ext cx="1027224" cy="167268"/>
+          <p:cNvPr id="89" name="Rounded Rectangle 88"/>
+          <p:cNvSpPr/>
+          <p:nvPr/>
+        </p:nvSpPr>
+        <p:spPr>
+          <a:xfrm>
+            <a:off x="4037069" y="4644154"/>
+            <a:ext cx="1652266" cy="167268"/>
           </a:xfrm>
           <a:prstGeom prst="roundRect">
             <a:avLst>
@@ -19516,7 +19697,7 @@
             </a:avLst>
           </a:prstGeom>
           <a:solidFill>
-            <a:srgbClr val="E7F4EB"/>
+            <a:srgbClr val="EFECF4"/>
           </a:solidFill>
           <a:ln>
             <a:noFill/>
@@ -19550,21 +19731,77 @@
                 <a:latin typeface="Yu Gothic UI"/>
                 <a:ea typeface="Yu Gothic UI"/>
               </a:rPr>
-              <a:t>FrameworkNumbers</a:t>
-            </a:r>
-          </a:p>
-        </p:txBody>
-      </p:sp>
-      <p:sp>
-        <p:nvSpPr>
-          <p:cNvPr id="87" name="Rounded Rectangle 86"/>
-          <p:cNvSpPr/>
-          <p:nvPr/>
-        </p:nvSpPr>
-        <p:spPr>
-          <a:xfrm>
-            <a:off x="6271577" y="4526083"/>
-            <a:ext cx="913580" cy="167268"/>
+              <a:t>System.Diagnostics.EventLog</a:t>
+            </a:r>
+          </a:p>
+        </p:txBody>
+      </p:sp>
+      <p:sp>
+        <p:nvSpPr>
+          <p:cNvPr id="90" name="Rectangle 89"/>
+          <p:cNvSpPr/>
+          <p:nvPr/>
+        </p:nvSpPr>
+        <p:spPr>
+          <a:xfrm>
+            <a:off x="432929" y="4899977"/>
+            <a:ext cx="9563810" cy="452608"/>
+          </a:xfrm>
+          <a:prstGeom prst="rect">
+            <a:avLst/>
+          </a:prstGeom>
+          <a:solidFill>
+            <a:srgbClr val="3E2470"/>
+          </a:solidFill>
+          <a:ln w="39329">
+            <a:solidFill>
+              <a:srgbClr val="F2C200"/>
+            </a:solidFill>
+          </a:ln>
+          <a:effectLst/>
+        </p:spPr>
+        <p:style>
+          <a:lnRef idx="1">
+            <a:schemeClr val="accent1"/>
+          </a:lnRef>
+          <a:fillRef idx="3">
+            <a:schemeClr val="accent1"/>
+          </a:fillRef>
+          <a:effectRef idx="2">
+            <a:schemeClr val="accent1"/>
+          </a:effectRef>
+          <a:fontRef idx="minor">
+            <a:schemeClr val="lt1"/>
+          </a:fontRef>
+        </p:style>
+        <p:txBody>
+          <a:bodyPr rtlCol="0" anchor="t" wrap="square" lIns="49196" rIns="49196" tIns="19678" bIns="19678"/>
+          <a:lstStyle/>
+          <a:p>
+            <a:pPr algn="l"/>
+            <a:r>
+              <a:rPr sz="929" b="1">
+                <a:solidFill>
+                  <a:srgbClr val="FFFFFF"/>
+                </a:solidFill>
+                <a:latin typeface="Yu Gothic UI"/>
+                <a:ea typeface="Yu Gothic UI"/>
+              </a:rPr>
+              <a:t>System.Private.CoreLib + CoreCLR(一組)</a:t>
+            </a:r>
+          </a:p>
+        </p:txBody>
+      </p:sp>
+      <p:sp>
+        <p:nvSpPr>
+          <p:cNvPr id="91" name="Rounded Rectangle 90"/>
+          <p:cNvSpPr/>
+          <p:nvPr/>
+        </p:nvSpPr>
+        <p:spPr>
+          <a:xfrm>
+            <a:off x="491965" y="5116441"/>
+            <a:ext cx="2628572" cy="167268"/>
           </a:xfrm>
           <a:prstGeom prst="roundRect">
             <a:avLst>
@@ -19572,7 +19809,7 @@
             </a:avLst>
           </a:prstGeom>
           <a:solidFill>
-            <a:srgbClr val="E7F4EB"/>
+            <a:srgbClr val="E8E5EE"/>
           </a:solidFill>
           <a:ln>
             <a:noFill/>
@@ -19606,21 +19843,21 @@
                 <a:latin typeface="Yu Gothic UI"/>
                 <a:ea typeface="Yu Gothic UI"/>
               </a:rPr>
-              <a:t>FrameworkFiles</a:t>
-            </a:r>
-          </a:p>
-        </p:txBody>
-      </p:sp>
-      <p:sp>
-        <p:nvSpPr>
-          <p:cNvPr id="88" name="Rounded Rectangle 87"/>
-          <p:cNvSpPr/>
-          <p:nvPr/>
-        </p:nvSpPr>
-        <p:spPr>
-          <a:xfrm>
-            <a:off x="7214675" y="4526083"/>
-            <a:ext cx="1084046" cy="167268"/>
+              <a:t>.NET のまま(ASP.NET Core は .NET の動きが前提)</a:t>
+            </a:r>
+          </a:p>
+        </p:txBody>
+      </p:sp>
+      <p:sp>
+        <p:nvSpPr>
+          <p:cNvPr id="92" name="Rounded Rectangle 91"/>
+          <p:cNvSpPr/>
+          <p:nvPr/>
+        </p:nvSpPr>
+        <p:spPr>
+          <a:xfrm>
+            <a:off x="3150055" y="5116441"/>
+            <a:ext cx="2845528" cy="167268"/>
           </a:xfrm>
           <a:prstGeom prst="roundRect">
             <a:avLst>
@@ -19628,7 +19865,7 @@
             </a:avLst>
           </a:prstGeom>
           <a:solidFill>
-            <a:srgbClr val="E7F4EB"/>
+            <a:srgbClr val="E8E5EE"/>
           </a:solidFill>
           <a:ln>
             <a:noFill/>
@@ -19662,21 +19899,21 @@
                 <a:latin typeface="Yu Gothic UI"/>
                 <a:ea typeface="Yu Gothic UI"/>
               </a:rPr>
-              <a:t>FrameworkCultures</a:t>
-            </a:r>
-          </a:p>
-        </p:txBody>
-      </p:sp>
-      <p:sp>
-        <p:nvSpPr>
-          <p:cNvPr id="89" name="Rounded Rectangle 88"/>
-          <p:cNvSpPr/>
-          <p:nvPr/>
-        </p:nvSpPr>
-        <p:spPr>
-          <a:xfrm>
-            <a:off x="8328239" y="4526083"/>
-            <a:ext cx="970402" cy="167268"/>
+              <a:t>アプリの、結果が違う呼び出しだけ Compat に書き換える</a:t>
+            </a:r>
+          </a:p>
+        </p:txBody>
+      </p:sp>
+      <p:sp>
+        <p:nvSpPr>
+          <p:cNvPr id="93" name="Rounded Rectangle 92"/>
+          <p:cNvSpPr/>
+          <p:nvPr/>
+        </p:nvSpPr>
+        <p:spPr>
+          <a:xfrm>
+            <a:off x="8461807" y="4949173"/>
+            <a:ext cx="1436539" cy="196786"/>
           </a:xfrm>
           <a:prstGeom prst="roundRect">
             <a:avLst>
@@ -19684,10 +19921,12 @@
             </a:avLst>
           </a:prstGeom>
           <a:solidFill>
-            <a:srgbClr val="E7F4EB"/>
-          </a:solidFill>
-          <a:ln>
-            <a:noFill/>
+            <a:srgbClr val="D32F2F"/>
+          </a:solidFill>
+          <a:ln w="14748">
+            <a:solidFill>
+              <a:srgbClr val="FFFFFF"/>
+            </a:solidFill>
           </a:ln>
           <a:effectLst/>
         </p:spPr>
@@ -19709,41 +19948,39 @@
           <a:bodyPr rtlCol="0" anchor="ctr" wrap="none" lIns="49196" rIns="49196" tIns="19678" bIns="19678"/>
           <a:lstStyle/>
           <a:p>
-            <a:pPr algn="l"/>
-            <a:r>
-              <a:rPr sz="812" b="1">
-                <a:solidFill>
-                  <a:srgbClr val="333333"/>
-                </a:solidFill>
-                <a:latin typeface="Yu Gothic UI"/>
-                <a:ea typeface="Yu Gothic UI"/>
-              </a:rPr>
-              <a:t>VisualBasicText</a:t>
-            </a:r>
-          </a:p>
-        </p:txBody>
-      </p:sp>
-      <p:sp>
-        <p:nvSpPr>
-          <p:cNvPr id="90" name="Rectangle 89"/>
-          <p:cNvSpPr/>
-          <p:nvPr/>
-        </p:nvSpPr>
-        <p:spPr>
-          <a:xfrm>
-            <a:off x="432929" y="4781905"/>
-            <a:ext cx="9563810" cy="452608"/>
+            <a:pPr algn="ctr"/>
+            <a:r>
+              <a:rPr sz="851" b="1">
+                <a:solidFill>
+                  <a:srgbClr val="FFFFFF"/>
+                </a:solidFill>
+                <a:latin typeface="Yu Gothic UI"/>
+                <a:ea typeface="Yu Gothic UI"/>
+              </a:rPr>
+              <a:t>例外: 差し替え不可</a:t>
+            </a:r>
+          </a:p>
+        </p:txBody>
+      </p:sp>
+      <p:sp>
+        <p:nvSpPr>
+          <p:cNvPr id="94" name="Rectangle 93"/>
+          <p:cNvSpPr/>
+          <p:nvPr/>
+        </p:nvSpPr>
+        <p:spPr>
+          <a:xfrm>
+            <a:off x="432929" y="5391942"/>
+            <a:ext cx="4781905" cy="393572"/>
           </a:xfrm>
           <a:prstGeom prst="rect">
             <a:avLst/>
           </a:prstGeom>
           <a:solidFill>
-            <a:srgbClr val="3E2470"/>
-          </a:solidFill>
-          <a:ln w="39329">
-            <a:solidFill>
-              <a:srgbClr val="F2C200"/>
-            </a:solidFill>
+            <a:srgbClr val="24508C"/>
+          </a:solidFill>
+          <a:ln>
+            <a:noFill/>
           </a:ln>
           <a:effectLst/>
         </p:spPr>
@@ -19774,21 +20011,21 @@
                 <a:latin typeface="Yu Gothic UI"/>
                 <a:ea typeface="Yu Gothic UI"/>
               </a:rPr>
-              <a:t>System.Private.CoreLib + CoreCLR(一組)</a:t>
-            </a:r>
-          </a:p>
-        </p:txBody>
-      </p:sp>
-      <p:sp>
-        <p:nvSpPr>
-          <p:cNvPr id="91" name="Rounded Rectangle 90"/>
-          <p:cNvSpPr/>
-          <p:nvPr/>
-        </p:nvSpPr>
-        <p:spPr>
-          <a:xfrm>
-            <a:off x="491965" y="4998370"/>
-            <a:ext cx="2628572" cy="167268"/>
+              <a:t>プロセスを載せる(Windows)</a:t>
+            </a:r>
+          </a:p>
+        </p:txBody>
+      </p:sp>
+      <p:sp>
+        <p:nvSpPr>
+          <p:cNvPr id="95" name="Rounded Rectangle 94"/>
+          <p:cNvSpPr/>
+          <p:nvPr/>
+        </p:nvSpPr>
+        <p:spPr>
+          <a:xfrm>
+            <a:off x="491965" y="5608407"/>
+            <a:ext cx="2892019" cy="167268"/>
           </a:xfrm>
           <a:prstGeom prst="roundRect">
             <a:avLst>
@@ -19796,7 +20033,7 @@
             </a:avLst>
           </a:prstGeom>
           <a:solidFill>
-            <a:srgbClr val="E8E5EE"/>
+            <a:srgbClr val="E5EAF1"/>
           </a:solidFill>
           <a:ln>
             <a:noFill/>
@@ -19830,21 +20067,75 @@
                 <a:latin typeface="Yu Gothic UI"/>
                 <a:ea typeface="Yu Gothic UI"/>
               </a:rPr>
-              <a:t>.NET のまま(ASP.NET Core は .NET の動きが前提)</a:t>
-            </a:r>
-          </a:p>
-        </p:txBody>
-      </p:sp>
-      <p:sp>
-        <p:nvSpPr>
-          <p:cNvPr id="92" name="Rounded Rectangle 91"/>
-          <p:cNvSpPr/>
-          <p:nvPr/>
-        </p:nvSpPr>
-        <p:spPr>
-          <a:xfrm>
-            <a:off x="3150055" y="4998370"/>
-            <a:ext cx="2432277" cy="167268"/>
+              <a:t>IIS + ANCM(任意): Kestrel に転送する・.NET を載せる</a:t>
+            </a:r>
+          </a:p>
+        </p:txBody>
+      </p:sp>
+      <p:sp>
+        <p:nvSpPr>
+          <p:cNvPr id="96" name="Rectangle 95"/>
+          <p:cNvSpPr/>
+          <p:nvPr/>
+        </p:nvSpPr>
+        <p:spPr>
+          <a:xfrm>
+            <a:off x="5254192" y="5391942"/>
+            <a:ext cx="4742548" cy="393572"/>
+          </a:xfrm>
+          <a:prstGeom prst="rect">
+            <a:avLst/>
+          </a:prstGeom>
+          <a:solidFill>
+            <a:srgbClr val="24508C"/>
+          </a:solidFill>
+          <a:ln>
+            <a:noFill/>
+          </a:ln>
+          <a:effectLst/>
+        </p:spPr>
+        <p:style>
+          <a:lnRef idx="1">
+            <a:schemeClr val="accent1"/>
+          </a:lnRef>
+          <a:fillRef idx="3">
+            <a:schemeClr val="accent1"/>
+          </a:fillRef>
+          <a:effectRef idx="2">
+            <a:schemeClr val="accent1"/>
+          </a:effectRef>
+          <a:fontRef idx="minor">
+            <a:schemeClr val="lt1"/>
+          </a:fontRef>
+        </p:style>
+        <p:txBody>
+          <a:bodyPr rtlCol="0" anchor="t" wrap="square" lIns="49196" rIns="49196" tIns="19678" bIns="19678"/>
+          <a:lstStyle/>
+          <a:p>
+            <a:pPr algn="l"/>
+            <a:r>
+              <a:rPr sz="929" b="1">
+                <a:solidFill>
+                  <a:srgbClr val="FFFFFF"/>
+                </a:solidFill>
+                <a:latin typeface="Yu Gothic UI"/>
+                <a:ea typeface="Yu Gothic UI"/>
+              </a:rPr>
+              <a:t>プロセスを載せる(Linux)</a:t>
+            </a:r>
+          </a:p>
+        </p:txBody>
+      </p:sp>
+      <p:sp>
+        <p:nvSpPr>
+          <p:cNvPr id="97" name="Rounded Rectangle 96"/>
+          <p:cNvSpPr/>
+          <p:nvPr/>
+        </p:nvSpPr>
+        <p:spPr>
+          <a:xfrm>
+            <a:off x="5313228" y="5608407"/>
+            <a:ext cx="960070" cy="167268"/>
           </a:xfrm>
           <a:prstGeom prst="roundRect">
             <a:avLst>
@@ -19852,7 +20143,7 @@
             </a:avLst>
           </a:prstGeom>
           <a:solidFill>
-            <a:srgbClr val="E8E5EE"/>
+            <a:srgbClr val="E5EAF1"/>
           </a:solidFill>
           <a:ln>
             <a:noFill/>
@@ -19886,21 +20177,75 @@
                 <a:latin typeface="Yu Gothic UI"/>
                 <a:ea typeface="Yu Gothic UI"/>
               </a:rPr>
-              <a:t>アプリの呼び出しは Compat に書き換えて避ける</a:t>
-            </a:r>
-          </a:p>
-        </p:txBody>
-      </p:sp>
-      <p:sp>
-        <p:nvSpPr>
-          <p:cNvPr id="93" name="Rounded Rectangle 92"/>
-          <p:cNvSpPr/>
-          <p:nvPr/>
-        </p:nvSpPr>
-        <p:spPr>
-          <a:xfrm>
-            <a:off x="8461807" y="4831101"/>
-            <a:ext cx="1436539" cy="196786"/>
+              <a:t>Docker・systemd</a:t>
+            </a:r>
+          </a:p>
+        </p:txBody>
+      </p:sp>
+      <p:sp>
+        <p:nvSpPr>
+          <p:cNvPr id="98" name="Rectangle 97"/>
+          <p:cNvSpPr/>
+          <p:nvPr/>
+        </p:nvSpPr>
+        <p:spPr>
+          <a:xfrm>
+            <a:off x="432929" y="5824872"/>
+            <a:ext cx="4781905" cy="393572"/>
+          </a:xfrm>
+          <a:prstGeom prst="rect">
+            <a:avLst/>
+          </a:prstGeom>
+          <a:solidFill>
+            <a:srgbClr val="6B6B6B"/>
+          </a:solidFill>
+          <a:ln>
+            <a:noFill/>
+          </a:ln>
+          <a:effectLst/>
+        </p:spPr>
+        <p:style>
+          <a:lnRef idx="1">
+            <a:schemeClr val="accent1"/>
+          </a:lnRef>
+          <a:fillRef idx="3">
+            <a:schemeClr val="accent1"/>
+          </a:fillRef>
+          <a:effectRef idx="2">
+            <a:schemeClr val="accent1"/>
+          </a:effectRef>
+          <a:fontRef idx="minor">
+            <a:schemeClr val="lt1"/>
+          </a:fontRef>
+        </p:style>
+        <p:txBody>
+          <a:bodyPr rtlCol="0" anchor="t" wrap="square" lIns="49196" rIns="49196" tIns="19678" bIns="19678"/>
+          <a:lstStyle/>
+          <a:p>
+            <a:pPr algn="l"/>
+            <a:r>
+              <a:rPr sz="929" b="1">
+                <a:solidFill>
+                  <a:srgbClr val="FFFFFF"/>
+                </a:solidFill>
+                <a:latin typeface="Yu Gothic UI"/>
+                <a:ea typeface="Yu Gothic UI"/>
+              </a:rPr>
+              <a:t>Windows Server</a:t>
+            </a:r>
+          </a:p>
+        </p:txBody>
+      </p:sp>
+      <p:sp>
+        <p:nvSpPr>
+          <p:cNvPr id="99" name="Rounded Rectangle 98"/>
+          <p:cNvSpPr/>
+          <p:nvPr/>
+        </p:nvSpPr>
+        <p:spPr>
+          <a:xfrm>
+            <a:off x="491965" y="6041337"/>
+            <a:ext cx="345359" cy="167268"/>
           </a:xfrm>
           <a:prstGeom prst="roundRect">
             <a:avLst>
@@ -19908,12 +20253,10 @@
             </a:avLst>
           </a:prstGeom>
           <a:solidFill>
-            <a:srgbClr val="D32F2F"/>
-          </a:solidFill>
-          <a:ln w="14748">
-            <a:solidFill>
-              <a:srgbClr val="FFFFFF"/>
-            </a:solidFill>
+            <a:srgbClr val="EDEDED"/>
+          </a:solidFill>
+          <a:ln>
+            <a:noFill/>
           </a:ln>
           <a:effectLst/>
         </p:spPr>
@@ -19935,84 +20278,30 @@
           <a:bodyPr rtlCol="0" anchor="ctr" wrap="none" lIns="49196" rIns="49196" tIns="19678" bIns="19678"/>
           <a:lstStyle/>
           <a:p>
-            <a:pPr algn="ctr"/>
-            <a:r>
-              <a:rPr sz="851" b="1">
-                <a:solidFill>
-                  <a:srgbClr val="FFFFFF"/>
-                </a:solidFill>
-                <a:latin typeface="Yu Gothic UI"/>
-                <a:ea typeface="Yu Gothic UI"/>
-              </a:rPr>
-              <a:t>例外: 差し替え不可</a:t>
-            </a:r>
-          </a:p>
-        </p:txBody>
-      </p:sp>
-      <p:sp>
-        <p:nvSpPr>
-          <p:cNvPr id="94" name="Rectangle 93"/>
-          <p:cNvSpPr/>
-          <p:nvPr/>
-        </p:nvSpPr>
-        <p:spPr>
-          <a:xfrm>
-            <a:off x="432929" y="5273870"/>
-            <a:ext cx="4781905" cy="432929"/>
-          </a:xfrm>
-          <a:prstGeom prst="rect">
-            <a:avLst/>
-          </a:prstGeom>
-          <a:solidFill>
-            <a:srgbClr val="24508C"/>
-          </a:solidFill>
-          <a:ln>
-            <a:noFill/>
-          </a:ln>
-          <a:effectLst/>
-        </p:spPr>
-        <p:style>
-          <a:lnRef idx="1">
-            <a:schemeClr val="accent1"/>
-          </a:lnRef>
-          <a:fillRef idx="3">
-            <a:schemeClr val="accent1"/>
-          </a:fillRef>
-          <a:effectRef idx="2">
-            <a:schemeClr val="accent1"/>
-          </a:effectRef>
-          <a:fontRef idx="minor">
-            <a:schemeClr val="lt1"/>
-          </a:fontRef>
-        </p:style>
-        <p:txBody>
-          <a:bodyPr rtlCol="0" anchor="t" wrap="square" lIns="49196" rIns="49196" tIns="19678" bIns="19678"/>
-          <a:lstStyle/>
-          <a:p>
-            <a:pPr algn="l"/>
-            <a:r>
-              <a:rPr sz="929" b="1">
-                <a:solidFill>
-                  <a:srgbClr val="FFFFFF"/>
-                </a:solidFill>
-                <a:latin typeface="Yu Gothic UI"/>
-                <a:ea typeface="Yu Gothic UI"/>
-              </a:rPr>
-              <a:t>プロセスを載せる(Windows)</a:t>
-            </a:r>
-          </a:p>
-        </p:txBody>
-      </p:sp>
-      <p:sp>
-        <p:nvSpPr>
-          <p:cNvPr id="95" name="Rounded Rectangle 94"/>
-          <p:cNvSpPr/>
-          <p:nvPr/>
-        </p:nvSpPr>
-        <p:spPr>
-          <a:xfrm>
-            <a:off x="491965" y="5490335"/>
-            <a:ext cx="2892019" cy="167268"/>
+            <a:pPr algn="l"/>
+            <a:r>
+              <a:rPr sz="812" b="1">
+                <a:solidFill>
+                  <a:srgbClr val="333333"/>
+                </a:solidFill>
+                <a:latin typeface="Yu Gothic UI"/>
+                <a:ea typeface="Yu Gothic UI"/>
+              </a:rPr>
+              <a:t>NTFS</a:t>
+            </a:r>
+          </a:p>
+        </p:txBody>
+      </p:sp>
+      <p:sp>
+        <p:nvSpPr>
+          <p:cNvPr id="100" name="Rounded Rectangle 99"/>
+          <p:cNvSpPr/>
+          <p:nvPr/>
+        </p:nvSpPr>
+        <p:spPr>
+          <a:xfrm>
+            <a:off x="866843" y="6041337"/>
+            <a:ext cx="288537" cy="167268"/>
           </a:xfrm>
           <a:prstGeom prst="roundRect">
             <a:avLst>
@@ -20020,7 +20309,7 @@
             </a:avLst>
           </a:prstGeom>
           <a:solidFill>
-            <a:srgbClr val="E5EAF1"/>
+            <a:srgbClr val="EDEDED"/>
           </a:solidFill>
           <a:ln>
             <a:noFill/>
@@ -20054,75 +20343,21 @@
                 <a:latin typeface="Yu Gothic UI"/>
                 <a:ea typeface="Yu Gothic UI"/>
               </a:rPr>
-              <a:t>IIS + ANCM(任意): Kestrel に転送する・.NET を載せる</a:t>
-            </a:r>
-          </a:p>
-        </p:txBody>
-      </p:sp>
-      <p:sp>
-        <p:nvSpPr>
-          <p:cNvPr id="96" name="Rectangle 95"/>
-          <p:cNvSpPr/>
-          <p:nvPr/>
-        </p:nvSpPr>
-        <p:spPr>
-          <a:xfrm>
-            <a:off x="5254192" y="5273870"/>
-            <a:ext cx="4742548" cy="432929"/>
-          </a:xfrm>
-          <a:prstGeom prst="rect">
-            <a:avLst/>
-          </a:prstGeom>
-          <a:solidFill>
-            <a:srgbClr val="24508C"/>
-          </a:solidFill>
-          <a:ln>
-            <a:noFill/>
-          </a:ln>
-          <a:effectLst/>
-        </p:spPr>
-        <p:style>
-          <a:lnRef idx="1">
-            <a:schemeClr val="accent1"/>
-          </a:lnRef>
-          <a:fillRef idx="3">
-            <a:schemeClr val="accent1"/>
-          </a:fillRef>
-          <a:effectRef idx="2">
-            <a:schemeClr val="accent1"/>
-          </a:effectRef>
-          <a:fontRef idx="minor">
-            <a:schemeClr val="lt1"/>
-          </a:fontRef>
-        </p:style>
-        <p:txBody>
-          <a:bodyPr rtlCol="0" anchor="t" wrap="square" lIns="49196" rIns="49196" tIns="19678" bIns="19678"/>
-          <a:lstStyle/>
-          <a:p>
-            <a:pPr algn="l"/>
-            <a:r>
-              <a:rPr sz="929" b="1">
-                <a:solidFill>
-                  <a:srgbClr val="FFFFFF"/>
-                </a:solidFill>
-                <a:latin typeface="Yu Gothic UI"/>
-                <a:ea typeface="Yu Gothic UI"/>
-              </a:rPr>
-              <a:t>プロセスを載せる(Linux)</a:t>
-            </a:r>
-          </a:p>
-        </p:txBody>
-      </p:sp>
-      <p:sp>
-        <p:nvSpPr>
-          <p:cNvPr id="97" name="Rounded Rectangle 96"/>
-          <p:cNvSpPr/>
-          <p:nvPr/>
-        </p:nvSpPr>
-        <p:spPr>
-          <a:xfrm>
-            <a:off x="5313228" y="5490335"/>
-            <a:ext cx="960070" cy="167268"/>
+              <a:t>NLS</a:t>
+            </a:r>
+          </a:p>
+        </p:txBody>
+      </p:sp>
+      <p:sp>
+        <p:nvSpPr>
+          <p:cNvPr id="101" name="Rounded Rectangle 100"/>
+          <p:cNvSpPr/>
+          <p:nvPr/>
+        </p:nvSpPr>
+        <p:spPr>
+          <a:xfrm>
+            <a:off x="1184899" y="6041337"/>
+            <a:ext cx="737948" cy="167268"/>
           </a:xfrm>
           <a:prstGeom prst="roundRect">
             <a:avLst>
@@ -20130,7 +20365,7 @@
             </a:avLst>
           </a:prstGeom>
           <a:solidFill>
-            <a:srgbClr val="E5EAF1"/>
+            <a:srgbClr val="EDEDED"/>
           </a:solidFill>
           <a:ln>
             <a:noFill/>
@@ -20164,21 +20399,21 @@
                 <a:latin typeface="Yu Gothic UI"/>
                 <a:ea typeface="Yu Gothic UI"/>
               </a:rPr>
-              <a:t>Docker・systemd</a:t>
-            </a:r>
-          </a:p>
-        </p:txBody>
-      </p:sp>
-      <p:sp>
-        <p:nvSpPr>
-          <p:cNvPr id="98" name="Rectangle 97"/>
-          <p:cNvSpPr/>
-          <p:nvPr/>
-        </p:nvSpPr>
-        <p:spPr>
-          <a:xfrm>
-            <a:off x="432929" y="5746157"/>
-            <a:ext cx="4781905" cy="432929"/>
+              <a:t>タイムゾーン</a:t>
+            </a:r>
+          </a:p>
+        </p:txBody>
+      </p:sp>
+      <p:sp>
+        <p:nvSpPr>
+          <p:cNvPr id="102" name="Rectangle 101"/>
+          <p:cNvSpPr/>
+          <p:nvPr/>
+        </p:nvSpPr>
+        <p:spPr>
+          <a:xfrm>
+            <a:off x="5254192" y="5824872"/>
+            <a:ext cx="4742548" cy="393572"/>
           </a:xfrm>
           <a:prstGeom prst="rect">
             <a:avLst/>
@@ -20218,21 +20453,21 @@
                 <a:latin typeface="Yu Gothic UI"/>
                 <a:ea typeface="Yu Gothic UI"/>
               </a:rPr>
-              <a:t>Windows Server</a:t>
-            </a:r>
-          </a:p>
-        </p:txBody>
-      </p:sp>
-      <p:sp>
-        <p:nvSpPr>
-          <p:cNvPr id="99" name="Rounded Rectangle 98"/>
-          <p:cNvSpPr/>
-          <p:nvPr/>
-        </p:nvSpPr>
-        <p:spPr>
-          <a:xfrm>
-            <a:off x="491965" y="5962622"/>
-            <a:ext cx="345359" cy="167268"/>
+              <a:t>Linux</a:t>
+            </a:r>
+          </a:p>
+        </p:txBody>
+      </p:sp>
+      <p:sp>
+        <p:nvSpPr>
+          <p:cNvPr id="103" name="Rounded Rectangle 102"/>
+          <p:cNvSpPr/>
+          <p:nvPr/>
+        </p:nvSpPr>
+        <p:spPr>
+          <a:xfrm>
+            <a:off x="5313228" y="6041337"/>
+            <a:ext cx="619138" cy="167268"/>
           </a:xfrm>
           <a:prstGeom prst="roundRect">
             <a:avLst>
@@ -20274,20 +20509,20 @@
                 <a:latin typeface="Yu Gothic UI"/>
                 <a:ea typeface="Yu Gothic UI"/>
               </a:rPr>
-              <a:t>NTFS</a:t>
-            </a:r>
-          </a:p>
-        </p:txBody>
-      </p:sp>
-      <p:sp>
-        <p:nvSpPr>
-          <p:cNvPr id="100" name="Rounded Rectangle 99"/>
-          <p:cNvSpPr/>
-          <p:nvPr/>
-        </p:nvSpPr>
-        <p:spPr>
-          <a:xfrm>
-            <a:off x="866843" y="5962622"/>
+              <a:t>ext4・xfs</a:t>
+            </a:r>
+          </a:p>
+        </p:txBody>
+      </p:sp>
+      <p:sp>
+        <p:nvSpPr>
+          <p:cNvPr id="104" name="Rounded Rectangle 103"/>
+          <p:cNvSpPr/>
+          <p:nvPr/>
+        </p:nvSpPr>
+        <p:spPr>
+          <a:xfrm>
+            <a:off x="5961884" y="6041337"/>
             <a:ext cx="288537" cy="167268"/>
           </a:xfrm>
           <a:prstGeom prst="roundRect">
@@ -20330,21 +20565,21 @@
                 <a:latin typeface="Yu Gothic UI"/>
                 <a:ea typeface="Yu Gothic UI"/>
               </a:rPr>
-              <a:t>NLS</a:t>
-            </a:r>
-          </a:p>
-        </p:txBody>
-      </p:sp>
-      <p:sp>
-        <p:nvSpPr>
-          <p:cNvPr id="101" name="Rounded Rectangle 100"/>
-          <p:cNvSpPr/>
-          <p:nvPr/>
-        </p:nvSpPr>
-        <p:spPr>
-          <a:xfrm>
-            <a:off x="1184899" y="5962622"/>
-            <a:ext cx="737948" cy="167268"/>
+              <a:t>ICU</a:t>
+            </a:r>
+          </a:p>
+        </p:txBody>
+      </p:sp>
+      <p:sp>
+        <p:nvSpPr>
+          <p:cNvPr id="105" name="Rounded Rectangle 104"/>
+          <p:cNvSpPr/>
+          <p:nvPr/>
+        </p:nvSpPr>
+        <p:spPr>
+          <a:xfrm>
+            <a:off x="6279940" y="6041337"/>
+            <a:ext cx="1125371" cy="167268"/>
           </a:xfrm>
           <a:prstGeom prst="roundRect">
             <a:avLst>
@@ -20386,75 +20621,21 @@
                 <a:latin typeface="Yu Gothic UI"/>
                 <a:ea typeface="Yu Gothic UI"/>
               </a:rPr>
-              <a:t>タイムゾーン</a:t>
-            </a:r>
-          </a:p>
-        </p:txBody>
-      </p:sp>
-      <p:sp>
-        <p:nvSpPr>
-          <p:cNvPr id="102" name="Rectangle 101"/>
-          <p:cNvSpPr/>
-          <p:nvPr/>
-        </p:nvSpPr>
-        <p:spPr>
-          <a:xfrm>
-            <a:off x="5254192" y="5746157"/>
-            <a:ext cx="4742548" cy="432929"/>
-          </a:xfrm>
-          <a:prstGeom prst="rect">
-            <a:avLst/>
-          </a:prstGeom>
-          <a:solidFill>
-            <a:srgbClr val="6B6B6B"/>
-          </a:solidFill>
-          <a:ln>
-            <a:noFill/>
-          </a:ln>
-          <a:effectLst/>
-        </p:spPr>
-        <p:style>
-          <a:lnRef idx="1">
-            <a:schemeClr val="accent1"/>
-          </a:lnRef>
-          <a:fillRef idx="3">
-            <a:schemeClr val="accent1"/>
-          </a:fillRef>
-          <a:effectRef idx="2">
-            <a:schemeClr val="accent1"/>
-          </a:effectRef>
-          <a:fontRef idx="minor">
-            <a:schemeClr val="lt1"/>
-          </a:fontRef>
-        </p:style>
-        <p:txBody>
-          <a:bodyPr rtlCol="0" anchor="t" wrap="square" lIns="49196" rIns="49196" tIns="19678" bIns="19678"/>
-          <a:lstStyle/>
-          <a:p>
-            <a:pPr algn="l"/>
-            <a:r>
-              <a:rPr sz="929" b="1">
-                <a:solidFill>
-                  <a:srgbClr val="FFFFFF"/>
-                </a:solidFill>
-                <a:latin typeface="Yu Gothic UI"/>
-                <a:ea typeface="Yu Gothic UI"/>
-              </a:rPr>
-              <a:t>Linux</a:t>
-            </a:r>
-          </a:p>
-        </p:txBody>
-      </p:sp>
-      <p:sp>
-        <p:nvSpPr>
-          <p:cNvPr id="103" name="Rounded Rectangle 102"/>
-          <p:cNvSpPr/>
-          <p:nvPr/>
-        </p:nvSpPr>
-        <p:spPr>
-          <a:xfrm>
-            <a:off x="5313228" y="5962622"/>
-            <a:ext cx="619138" cy="167268"/>
+              <a:t>TZ = 元のサーバーの</a:t>
+            </a:r>
+          </a:p>
+        </p:txBody>
+      </p:sp>
+      <p:sp>
+        <p:nvSpPr>
+          <p:cNvPr id="106" name="Rounded Rectangle 105"/>
+          <p:cNvSpPr/>
+          <p:nvPr/>
+        </p:nvSpPr>
+        <p:spPr>
+          <a:xfrm>
+            <a:off x="7434829" y="6041337"/>
+            <a:ext cx="686291" cy="167268"/>
           </a:xfrm>
           <a:prstGeom prst="roundRect">
             <a:avLst>
@@ -20496,174 +20677,6 @@
                 <a:latin typeface="Yu Gothic UI"/>
                 <a:ea typeface="Yu Gothic UI"/>
               </a:rPr>
-              <a:t>ext4・xfs</a:t>
-            </a:r>
-          </a:p>
-        </p:txBody>
-      </p:sp>
-      <p:sp>
-        <p:nvSpPr>
-          <p:cNvPr id="104" name="Rounded Rectangle 103"/>
-          <p:cNvSpPr/>
-          <p:nvPr/>
-        </p:nvSpPr>
-        <p:spPr>
-          <a:xfrm>
-            <a:off x="5961884" y="5962622"/>
-            <a:ext cx="288537" cy="167268"/>
-          </a:xfrm>
-          <a:prstGeom prst="roundRect">
-            <a:avLst>
-              <a:gd name="adj" fmla="val 18000"/>
-            </a:avLst>
-          </a:prstGeom>
-          <a:solidFill>
-            <a:srgbClr val="EDEDED"/>
-          </a:solidFill>
-          <a:ln>
-            <a:noFill/>
-          </a:ln>
-          <a:effectLst/>
-        </p:spPr>
-        <p:style>
-          <a:lnRef idx="1">
-            <a:schemeClr val="accent1"/>
-          </a:lnRef>
-          <a:fillRef idx="3">
-            <a:schemeClr val="accent1"/>
-          </a:fillRef>
-          <a:effectRef idx="2">
-            <a:schemeClr val="accent1"/>
-          </a:effectRef>
-          <a:fontRef idx="minor">
-            <a:schemeClr val="lt1"/>
-          </a:fontRef>
-        </p:style>
-        <p:txBody>
-          <a:bodyPr rtlCol="0" anchor="ctr" wrap="none" lIns="49196" rIns="49196" tIns="19678" bIns="19678"/>
-          <a:lstStyle/>
-          <a:p>
-            <a:pPr algn="l"/>
-            <a:r>
-              <a:rPr sz="812" b="1">
-                <a:solidFill>
-                  <a:srgbClr val="333333"/>
-                </a:solidFill>
-                <a:latin typeface="Yu Gothic UI"/>
-                <a:ea typeface="Yu Gothic UI"/>
-              </a:rPr>
-              <a:t>ICU</a:t>
-            </a:r>
-          </a:p>
-        </p:txBody>
-      </p:sp>
-      <p:sp>
-        <p:nvSpPr>
-          <p:cNvPr id="105" name="Rounded Rectangle 104"/>
-          <p:cNvSpPr/>
-          <p:nvPr/>
-        </p:nvSpPr>
-        <p:spPr>
-          <a:xfrm>
-            <a:off x="6279940" y="5962622"/>
-            <a:ext cx="1125371" cy="167268"/>
-          </a:xfrm>
-          <a:prstGeom prst="roundRect">
-            <a:avLst>
-              <a:gd name="adj" fmla="val 18000"/>
-            </a:avLst>
-          </a:prstGeom>
-          <a:solidFill>
-            <a:srgbClr val="EDEDED"/>
-          </a:solidFill>
-          <a:ln>
-            <a:noFill/>
-          </a:ln>
-          <a:effectLst/>
-        </p:spPr>
-        <p:style>
-          <a:lnRef idx="1">
-            <a:schemeClr val="accent1"/>
-          </a:lnRef>
-          <a:fillRef idx="3">
-            <a:schemeClr val="accent1"/>
-          </a:fillRef>
-          <a:effectRef idx="2">
-            <a:schemeClr val="accent1"/>
-          </a:effectRef>
-          <a:fontRef idx="minor">
-            <a:schemeClr val="lt1"/>
-          </a:fontRef>
-        </p:style>
-        <p:txBody>
-          <a:bodyPr rtlCol="0" anchor="ctr" wrap="none" lIns="49196" rIns="49196" tIns="19678" bIns="19678"/>
-          <a:lstStyle/>
-          <a:p>
-            <a:pPr algn="l"/>
-            <a:r>
-              <a:rPr sz="812" b="1">
-                <a:solidFill>
-                  <a:srgbClr val="333333"/>
-                </a:solidFill>
-                <a:latin typeface="Yu Gothic UI"/>
-                <a:ea typeface="Yu Gothic UI"/>
-              </a:rPr>
-              <a:t>TZ = 元のサーバーの</a:t>
-            </a:r>
-          </a:p>
-        </p:txBody>
-      </p:sp>
-      <p:sp>
-        <p:nvSpPr>
-          <p:cNvPr id="106" name="Rounded Rectangle 105"/>
-          <p:cNvSpPr/>
-          <p:nvPr/>
-        </p:nvSpPr>
-        <p:spPr>
-          <a:xfrm>
-            <a:off x="7434829" y="5962622"/>
-            <a:ext cx="686291" cy="167268"/>
-          </a:xfrm>
-          <a:prstGeom prst="roundRect">
-            <a:avLst>
-              <a:gd name="adj" fmla="val 18000"/>
-            </a:avLst>
-          </a:prstGeom>
-          <a:solidFill>
-            <a:srgbClr val="EDEDED"/>
-          </a:solidFill>
-          <a:ln>
-            <a:noFill/>
-          </a:ln>
-          <a:effectLst/>
-        </p:spPr>
-        <p:style>
-          <a:lnRef idx="1">
-            <a:schemeClr val="accent1"/>
-          </a:lnRef>
-          <a:fillRef idx="3">
-            <a:schemeClr val="accent1"/>
-          </a:fillRef>
-          <a:effectRef idx="2">
-            <a:schemeClr val="accent1"/>
-          </a:effectRef>
-          <a:fontRef idx="minor">
-            <a:schemeClr val="lt1"/>
-          </a:fontRef>
-        </p:style>
-        <p:txBody>
-          <a:bodyPr rtlCol="0" anchor="ctr" wrap="none" lIns="49196" rIns="49196" tIns="19678" bIns="19678"/>
-          <a:lstStyle/>
-          <a:p>
-            <a:pPr algn="l"/>
-            <a:r>
-              <a:rPr sz="812" b="1">
-                <a:solidFill>
-                  <a:srgbClr val="333333"/>
-                </a:solidFill>
-                <a:latin typeface="Yu Gothic UI"/>
-                <a:ea typeface="Yu Gothic UI"/>
-              </a:rPr>
               <a:t>libgdiplus</a:t>
             </a:r>
           </a:p>
@@ -20677,8 +20690,8 @@
         </p:nvSpPr>
         <p:spPr>
           <a:xfrm>
-            <a:off x="432929" y="6218444"/>
-            <a:ext cx="9563810" cy="216464"/>
+            <a:off x="432929" y="6257802"/>
+            <a:ext cx="9563810" cy="177107"/>
           </a:xfrm>
           <a:prstGeom prst="rect">
             <a:avLst/>
@@ -20732,7 +20745,7 @@
         <p:spPr>
           <a:xfrm>
             <a:off x="59035" y="1062645"/>
-            <a:ext cx="314857" cy="3207615"/>
+            <a:ext cx="314857" cy="3325687"/>
           </a:xfrm>
           <a:prstGeom prst="rect">
             <a:avLst/>
@@ -20785,8 +20798,8 @@
         </p:nvSpPr>
         <p:spPr>
           <a:xfrm>
-            <a:off x="59035" y="4309618"/>
-            <a:ext cx="314857" cy="1869469"/>
+            <a:off x="59035" y="4427690"/>
+            <a:ext cx="314857" cy="1790754"/>
           </a:xfrm>
           <a:prstGeom prst="rect">
             <a:avLst/>

</xml_diff>

<commit_message>
docs/architecture ③: CoreWCF under the WCF services (their code uses it), FrameworkOnCore's WCF entry small beside it
experiments/wf4c/README.md: CoreWCF.ConfigurationManager cannot replace FrameworkOnCore.ServiceModel's reading of
web.config (no behaviors, no default endpoints, no .svc addresses, no default webHttpBinding)

Co-Authored-By: Claude Opus 5.5 <noreply@anthropic.com>
</commit_message>
<xml_diff>
--- a/docs/architecture/architecture.pptx
+++ b/docs/architecture/architecture.pptx
@@ -15089,12 +15089,66 @@
         <p:spPr>
           <a:xfrm>
             <a:off x="728109" y="1062645"/>
-            <a:ext cx="1279110" cy="1023288"/>
+            <a:ext cx="491965" cy="1889147"/>
           </a:xfrm>
           <a:prstGeom prst="rect">
             <a:avLst/>
           </a:prstGeom>
           <a:solidFill>
+            <a:srgbClr val="E05A47"/>
+          </a:solidFill>
+          <a:ln>
+            <a:noFill/>
+          </a:ln>
+          <a:effectLst/>
+        </p:spPr>
+        <p:style>
+          <a:lnRef idx="1">
+            <a:schemeClr val="accent1"/>
+          </a:lnRef>
+          <a:fillRef idx="3">
+            <a:schemeClr val="accent1"/>
+          </a:fillRef>
+          <a:effectRef idx="2">
+            <a:schemeClr val="accent1"/>
+          </a:effectRef>
+          <a:fontRef idx="minor">
+            <a:schemeClr val="lt1"/>
+          </a:fontRef>
+        </p:style>
+        <p:txBody>
+          <a:bodyPr rtlCol="0" anchor="ctr" wrap="square" lIns="49196" rIns="49196" tIns="19678" bIns="19678" vert="eaVert"/>
+          <a:lstStyle/>
+          <a:p>
+            <a:pPr algn="ctr"/>
+            <a:r>
+              <a:rPr sz="851" b="1">
+                <a:solidFill>
+                  <a:srgbClr val="FFFFFF"/>
+                </a:solidFill>
+                <a:latin typeface="Yu Gothic UI"/>
+                <a:ea typeface="Yu Gothic UI"/>
+              </a:rPr>
+              <a:t>CoreWCF(サービスの本体)</a:t>
+            </a:r>
+          </a:p>
+        </p:txBody>
+      </p:sp>
+      <p:sp>
+        <p:nvSpPr>
+          <p:cNvPr id="18" name="Rectangle 17"/>
+          <p:cNvSpPr/>
+          <p:nvPr/>
+        </p:nvSpPr>
+        <p:spPr>
+          <a:xfrm>
+            <a:off x="1259431" y="1062645"/>
+            <a:ext cx="747787" cy="905216"/>
+          </a:xfrm>
+          <a:prstGeom prst="rect">
+            <a:avLst/>
+          </a:prstGeom>
+          <a:solidFill>
             <a:srgbClr val="C8102E"/>
           </a:solidFill>
           <a:ln>
@@ -15122,28 +15176,28 @@
           <a:p>
             <a:pPr algn="l"/>
             <a:r>
-              <a:rPr sz="929" b="1">
+              <a:rPr sz="851" b="1">
                 <a:solidFill>
                   <a:srgbClr val="FFFFFF"/>
                 </a:solidFill>
                 <a:latin typeface="Yu Gothic UI"/>
                 <a:ea typeface="Yu Gothic UI"/>
               </a:rPr>
-              <a:t>WCF の受け口(移植)</a:t>
-            </a:r>
-          </a:p>
-        </p:txBody>
-      </p:sp>
-      <p:sp>
-        <p:nvSpPr>
-          <p:cNvPr id="18" name="Rounded Rectangle 17"/>
-          <p:cNvSpPr/>
-          <p:nvPr/>
-        </p:nvSpPr>
-        <p:spPr>
-          <a:xfrm>
-            <a:off x="787144" y="1279110"/>
-            <a:ext cx="1161038" cy="167268"/>
+              <a:t>WCF の受け口</a:t>
+            </a:r>
+          </a:p>
+        </p:txBody>
+      </p:sp>
+      <p:sp>
+        <p:nvSpPr>
+          <p:cNvPr id="19" name="Rounded Rectangle 18"/>
+          <p:cNvSpPr/>
+          <p:nvPr/>
+        </p:nvSpPr>
+        <p:spPr>
+          <a:xfrm>
+            <a:off x="1318467" y="1279110"/>
+            <a:ext cx="629715" cy="167268"/>
           </a:xfrm>
           <a:prstGeom prst="roundRect">
             <a:avLst>
@@ -15185,21 +15239,21 @@
                 <a:latin typeface="Yu Gothic UI"/>
                 <a:ea typeface="Yu Gothic UI"/>
               </a:rPr>
-              <a:t>.svc の構成</a:t>
-            </a:r>
-          </a:p>
-        </p:txBody>
-      </p:sp>
-      <p:sp>
-        <p:nvSpPr>
-          <p:cNvPr id="19" name="Rounded Rectangle 18"/>
-          <p:cNvSpPr/>
-          <p:nvPr/>
-        </p:nvSpPr>
-        <p:spPr>
-          <a:xfrm>
-            <a:off x="787144" y="1475896"/>
-            <a:ext cx="1161038" cy="167268"/>
+              <a:t>.svc 登録</a:t>
+            </a:r>
+          </a:p>
+        </p:txBody>
+      </p:sp>
+      <p:sp>
+        <p:nvSpPr>
+          <p:cNvPr id="20" name="Rounded Rectangle 19"/>
+          <p:cNvSpPr/>
+          <p:nvPr/>
+        </p:nvSpPr>
+        <p:spPr>
+          <a:xfrm>
+            <a:off x="1318467" y="1475896"/>
+            <a:ext cx="629715" cy="167268"/>
           </a:xfrm>
           <a:prstGeom prst="roundRect">
             <a:avLst>
@@ -15241,129 +15295,21 @@
                 <a:latin typeface="Yu Gothic UI"/>
                 <a:ea typeface="Yu Gothic UI"/>
               </a:rPr>
-              <a:t>ASP.NET 互換</a:t>
-            </a:r>
-          </a:p>
-        </p:txBody>
-      </p:sp>
-      <p:sp>
-        <p:nvSpPr>
-          <p:cNvPr id="20" name="Rectangle 19"/>
-          <p:cNvSpPr/>
-          <p:nvPr/>
-        </p:nvSpPr>
-        <p:spPr>
-          <a:xfrm>
-            <a:off x="728109" y="2125291"/>
-            <a:ext cx="491965" cy="826502"/>
-          </a:xfrm>
-          <a:prstGeom prst="rect">
-            <a:avLst/>
-          </a:prstGeom>
-          <a:solidFill>
-            <a:srgbClr val="E05A47"/>
-          </a:solidFill>
-          <a:ln>
-            <a:noFill/>
-          </a:ln>
-          <a:effectLst/>
-        </p:spPr>
-        <p:style>
-          <a:lnRef idx="1">
-            <a:schemeClr val="accent1"/>
-          </a:lnRef>
-          <a:fillRef idx="3">
-            <a:schemeClr val="accent1"/>
-          </a:fillRef>
-          <a:effectRef idx="2">
-            <a:schemeClr val="accent1"/>
-          </a:effectRef>
-          <a:fontRef idx="minor">
-            <a:schemeClr val="lt1"/>
-          </a:fontRef>
-        </p:style>
-        <p:txBody>
-          <a:bodyPr rtlCol="0" anchor="ctr" wrap="square" lIns="49196" rIns="49196" tIns="19678" bIns="19678" vert="eaVert"/>
-          <a:lstStyle/>
-          <a:p>
-            <a:pPr algn="ctr"/>
-            <a:r>
-              <a:rPr sz="851" b="1">
-                <a:solidFill>
-                  <a:srgbClr val="FFFFFF"/>
-                </a:solidFill>
-                <a:latin typeface="Yu Gothic UI"/>
-                <a:ea typeface="Yu Gothic UI"/>
-              </a:rPr>
-              <a:t>CoreWCF</a:t>
-            </a:r>
-          </a:p>
-        </p:txBody>
-      </p:sp>
-      <p:sp>
-        <p:nvSpPr>
-          <p:cNvPr id="21" name="Rectangle 20"/>
-          <p:cNvSpPr/>
-          <p:nvPr/>
-        </p:nvSpPr>
-        <p:spPr>
-          <a:xfrm>
-            <a:off x="2046576" y="1062645"/>
-            <a:ext cx="1771076" cy="1023288"/>
-          </a:xfrm>
-          <a:prstGeom prst="rect">
-            <a:avLst/>
-          </a:prstGeom>
-          <a:solidFill>
-            <a:srgbClr val="C8102E"/>
-          </a:solidFill>
-          <a:ln>
-            <a:noFill/>
-          </a:ln>
-          <a:effectLst/>
-        </p:spPr>
-        <p:style>
-          <a:lnRef idx="1">
-            <a:schemeClr val="accent1"/>
-          </a:lnRef>
-          <a:fillRef idx="3">
-            <a:schemeClr val="accent1"/>
-          </a:fillRef>
-          <a:effectRef idx="2">
-            <a:schemeClr val="accent1"/>
-          </a:effectRef>
-          <a:fontRef idx="minor">
-            <a:schemeClr val="lt1"/>
-          </a:fontRef>
-        </p:style>
-        <p:txBody>
-          <a:bodyPr rtlCol="0" anchor="t" wrap="square" lIns="49196" rIns="49196" tIns="19678" bIns="19678"/>
-          <a:lstStyle/>
-          <a:p>
-            <a:pPr algn="l"/>
-            <a:r>
-              <a:rPr sz="929" b="1">
-                <a:solidFill>
-                  <a:srgbClr val="FFFFFF"/>
-                </a:solidFill>
-                <a:latin typeface="Yu Gothic UI"/>
-                <a:ea typeface="Yu Gothic UI"/>
-              </a:rPr>
-              <a:t>FrameworkOnCore(移植)</a:t>
-            </a:r>
-          </a:p>
-        </p:txBody>
-      </p:sp>
-      <p:sp>
-        <p:nvSpPr>
-          <p:cNvPr id="22" name="Rounded Rectangle 21"/>
-          <p:cNvSpPr/>
-          <p:nvPr/>
-        </p:nvSpPr>
-        <p:spPr>
-          <a:xfrm>
-            <a:off x="2105612" y="1279110"/>
-            <a:ext cx="1653004" cy="167268"/>
+              <a:t>AJAX(/js)</a:t>
+            </a:r>
+          </a:p>
+        </p:txBody>
+      </p:sp>
+      <p:sp>
+        <p:nvSpPr>
+          <p:cNvPr id="21" name="Rounded Rectangle 20"/>
+          <p:cNvSpPr/>
+          <p:nvPr/>
+        </p:nvSpPr>
+        <p:spPr>
+          <a:xfrm>
+            <a:off x="1318467" y="1672682"/>
+            <a:ext cx="629715" cy="167268"/>
           </a:xfrm>
           <a:prstGeom prst="roundRect">
             <a:avLst>
@@ -15405,7 +15351,61 @@
                 <a:latin typeface="Yu Gothic UI"/>
                 <a:ea typeface="Yu Gothic UI"/>
               </a:rPr>
-              <a:t>System.Web.UI(ページ)</a:t>
+              <a:t>互換の型</a:t>
+            </a:r>
+          </a:p>
+        </p:txBody>
+      </p:sp>
+      <p:sp>
+        <p:nvSpPr>
+          <p:cNvPr id="22" name="Rectangle 21"/>
+          <p:cNvSpPr/>
+          <p:nvPr/>
+        </p:nvSpPr>
+        <p:spPr>
+          <a:xfrm>
+            <a:off x="2046576" y="1062645"/>
+            <a:ext cx="1771076" cy="1023288"/>
+          </a:xfrm>
+          <a:prstGeom prst="rect">
+            <a:avLst/>
+          </a:prstGeom>
+          <a:solidFill>
+            <a:srgbClr val="C8102E"/>
+          </a:solidFill>
+          <a:ln>
+            <a:noFill/>
+          </a:ln>
+          <a:effectLst/>
+        </p:spPr>
+        <p:style>
+          <a:lnRef idx="1">
+            <a:schemeClr val="accent1"/>
+          </a:lnRef>
+          <a:fillRef idx="3">
+            <a:schemeClr val="accent1"/>
+          </a:fillRef>
+          <a:effectRef idx="2">
+            <a:schemeClr val="accent1"/>
+          </a:effectRef>
+          <a:fontRef idx="minor">
+            <a:schemeClr val="lt1"/>
+          </a:fontRef>
+        </p:style>
+        <p:txBody>
+          <a:bodyPr rtlCol="0" anchor="t" wrap="square" lIns="49196" rIns="49196" tIns="19678" bIns="19678"/>
+          <a:lstStyle/>
+          <a:p>
+            <a:pPr algn="l"/>
+            <a:r>
+              <a:rPr sz="929" b="1">
+                <a:solidFill>
+                  <a:srgbClr val="FFFFFF"/>
+                </a:solidFill>
+                <a:latin typeface="Yu Gothic UI"/>
+                <a:ea typeface="Yu Gothic UI"/>
+              </a:rPr>
+              <a:t>FrameworkOnCore(移植)</a:t>
             </a:r>
           </a:p>
         </p:txBody>
@@ -15418,7 +15418,7 @@
         </p:nvSpPr>
         <p:spPr>
           <a:xfrm>
-            <a:off x="2105612" y="1475896"/>
+            <a:off x="2105612" y="1279110"/>
             <a:ext cx="1653004" cy="167268"/>
           </a:xfrm>
           <a:prstGeom prst="roundRect">
@@ -15461,7 +15461,7 @@
                 <a:latin typeface="Yu Gothic UI"/>
                 <a:ea typeface="Yu Gothic UI"/>
               </a:rPr>
-              <a:t>ASP.NET AJAX(Extensions)</a:t>
+              <a:t>System.Web.UI(ページ)</a:t>
             </a:r>
           </a:p>
         </p:txBody>
@@ -15474,7 +15474,7 @@
         </p:nvSpPr>
         <p:spPr>
           <a:xfrm>
-            <a:off x="2105612" y="1672682"/>
+            <a:off x="2105612" y="1475896"/>
             <a:ext cx="1653004" cy="167268"/>
           </a:xfrm>
           <a:prstGeom prst="roundRect">
@@ -15517,7 +15517,7 @@
                 <a:latin typeface="Yu Gothic UI"/>
                 <a:ea typeface="Yu Gothic UI"/>
               </a:rPr>
-              <a:t>Chart・Dynamic Data・Mobile</a:t>
+              <a:t>ASP.NET AJAX(Extensions)</a:t>
             </a:r>
           </a:p>
         </p:txBody>
@@ -15530,7 +15530,7 @@
         </p:nvSpPr>
         <p:spPr>
           <a:xfrm>
-            <a:off x="2105612" y="1869469"/>
+            <a:off x="2105612" y="1672682"/>
             <a:ext cx="1653004" cy="167268"/>
           </a:xfrm>
           <a:prstGeom prst="roundRect">
@@ -15573,75 +15573,21 @@
                 <a:latin typeface="Yu Gothic UI"/>
                 <a:ea typeface="Yu Gothic UI"/>
               </a:rPr>
-              <a:t>バンドル(Optimization)</a:t>
-            </a:r>
-          </a:p>
-        </p:txBody>
-      </p:sp>
-      <p:sp>
-        <p:nvSpPr>
-          <p:cNvPr id="26" name="Rectangle 25"/>
-          <p:cNvSpPr/>
-          <p:nvPr/>
-        </p:nvSpPr>
-        <p:spPr>
-          <a:xfrm>
-            <a:off x="3857010" y="1062645"/>
-            <a:ext cx="1023288" cy="1023288"/>
-          </a:xfrm>
-          <a:prstGeom prst="rect">
-            <a:avLst/>
-          </a:prstGeom>
-          <a:solidFill>
-            <a:srgbClr val="C8102E"/>
-          </a:solidFill>
-          <a:ln>
-            <a:noFill/>
-          </a:ln>
-          <a:effectLst/>
-        </p:spPr>
-        <p:style>
-          <a:lnRef idx="1">
-            <a:schemeClr val="accent1"/>
-          </a:lnRef>
-          <a:fillRef idx="3">
-            <a:schemeClr val="accent1"/>
-          </a:fillRef>
-          <a:effectRef idx="2">
-            <a:schemeClr val="accent1"/>
-          </a:effectRef>
-          <a:fontRef idx="minor">
-            <a:schemeClr val="lt1"/>
-          </a:fontRef>
-        </p:style>
-        <p:txBody>
-          <a:bodyPr rtlCol="0" anchor="t" wrap="square" lIns="49196" rIns="49196" tIns="19678" bIns="19678"/>
-          <a:lstStyle/>
-          <a:p>
-            <a:pPr algn="l"/>
-            <a:r>
-              <a:rPr sz="929" b="1">
-                <a:solidFill>
-                  <a:srgbClr val="FFFFFF"/>
-                </a:solidFill>
-                <a:latin typeface="Yu Gothic UI"/>
-                <a:ea typeface="Yu Gothic UI"/>
-              </a:rPr>
-              <a:t>MVC 5(移植)</a:t>
-            </a:r>
-          </a:p>
-        </p:txBody>
-      </p:sp>
-      <p:sp>
-        <p:nvSpPr>
-          <p:cNvPr id="27" name="Rounded Rectangle 26"/>
-          <p:cNvSpPr/>
-          <p:nvPr/>
-        </p:nvSpPr>
-        <p:spPr>
-          <a:xfrm>
-            <a:off x="3916045" y="1279110"/>
-            <a:ext cx="905216" cy="167268"/>
+              <a:t>Chart・Dynamic Data・Mobile</a:t>
+            </a:r>
+          </a:p>
+        </p:txBody>
+      </p:sp>
+      <p:sp>
+        <p:nvSpPr>
+          <p:cNvPr id="26" name="Rounded Rectangle 25"/>
+          <p:cNvSpPr/>
+          <p:nvPr/>
+        </p:nvSpPr>
+        <p:spPr>
+          <a:xfrm>
+            <a:off x="2105612" y="1869469"/>
+            <a:ext cx="1653004" cy="167268"/>
           </a:xfrm>
           <a:prstGeom prst="roundRect">
             <a:avLst>
@@ -15683,7 +15629,61 @@
                 <a:latin typeface="Yu Gothic UI"/>
                 <a:ea typeface="Yu Gothic UI"/>
               </a:rPr>
-              <a:t>System.Web.Mvc</a:t>
+              <a:t>バンドル(Optimization)</a:t>
+            </a:r>
+          </a:p>
+        </p:txBody>
+      </p:sp>
+      <p:sp>
+        <p:nvSpPr>
+          <p:cNvPr id="27" name="Rectangle 26"/>
+          <p:cNvSpPr/>
+          <p:nvPr/>
+        </p:nvSpPr>
+        <p:spPr>
+          <a:xfrm>
+            <a:off x="3857010" y="1062645"/>
+            <a:ext cx="1023288" cy="1023288"/>
+          </a:xfrm>
+          <a:prstGeom prst="rect">
+            <a:avLst/>
+          </a:prstGeom>
+          <a:solidFill>
+            <a:srgbClr val="C8102E"/>
+          </a:solidFill>
+          <a:ln>
+            <a:noFill/>
+          </a:ln>
+          <a:effectLst/>
+        </p:spPr>
+        <p:style>
+          <a:lnRef idx="1">
+            <a:schemeClr val="accent1"/>
+          </a:lnRef>
+          <a:fillRef idx="3">
+            <a:schemeClr val="accent1"/>
+          </a:fillRef>
+          <a:effectRef idx="2">
+            <a:schemeClr val="accent1"/>
+          </a:effectRef>
+          <a:fontRef idx="minor">
+            <a:schemeClr val="lt1"/>
+          </a:fontRef>
+        </p:style>
+        <p:txBody>
+          <a:bodyPr rtlCol="0" anchor="t" wrap="square" lIns="49196" rIns="49196" tIns="19678" bIns="19678"/>
+          <a:lstStyle/>
+          <a:p>
+            <a:pPr algn="l"/>
+            <a:r>
+              <a:rPr sz="929" b="1">
+                <a:solidFill>
+                  <a:srgbClr val="FFFFFF"/>
+                </a:solidFill>
+                <a:latin typeface="Yu Gothic UI"/>
+                <a:ea typeface="Yu Gothic UI"/>
+              </a:rPr>
+              <a:t>MVC 5(移植)</a:t>
             </a:r>
           </a:p>
         </p:txBody>
@@ -15696,7 +15696,7 @@
         </p:nvSpPr>
         <p:spPr>
           <a:xfrm>
-            <a:off x="3916045" y="1475896"/>
+            <a:off x="3916045" y="1279110"/>
             <a:ext cx="905216" cy="167268"/>
           </a:xfrm>
           <a:prstGeom prst="roundRect">
@@ -15739,7 +15739,7 @@
                 <a:latin typeface="Yu Gothic UI"/>
                 <a:ea typeface="Yu Gothic UI"/>
               </a:rPr>
-              <a:t>Razor・WebPages</a:t>
+              <a:t>System.Web.Mvc</a:t>
             </a:r>
           </a:p>
         </p:txBody>
@@ -15752,7 +15752,7 @@
         </p:nvSpPr>
         <p:spPr>
           <a:xfrm>
-            <a:off x="3916045" y="1672682"/>
+            <a:off x="3916045" y="1475896"/>
             <a:ext cx="905216" cy="167268"/>
           </a:xfrm>
           <a:prstGeom prst="roundRect">
@@ -15795,7 +15795,7 @@
                 <a:latin typeface="Yu Gothic UI"/>
                 <a:ea typeface="Yu Gothic UI"/>
               </a:rPr>
-              <a:t>AspNetWebStack</a:t>
+              <a:t>Razor・WebPages</a:t>
             </a:r>
           </a:p>
         </p:txBody>
@@ -15808,7 +15808,7 @@
         </p:nvSpPr>
         <p:spPr>
           <a:xfrm>
-            <a:off x="3916045" y="1869469"/>
+            <a:off x="3916045" y="1672682"/>
             <a:ext cx="905216" cy="167268"/>
           </a:xfrm>
           <a:prstGeom prst="roundRect">
@@ -15851,75 +15851,21 @@
                 <a:latin typeface="Yu Gothic UI"/>
                 <a:ea typeface="Yu Gothic UI"/>
               </a:rPr>
-              <a:t>バンドル</a:t>
-            </a:r>
-          </a:p>
-        </p:txBody>
-      </p:sp>
-      <p:sp>
-        <p:nvSpPr>
-          <p:cNvPr id="31" name="Rectangle 30"/>
-          <p:cNvSpPr/>
-          <p:nvPr/>
-        </p:nvSpPr>
-        <p:spPr>
-          <a:xfrm>
-            <a:off x="4919655" y="1062645"/>
-            <a:ext cx="983931" cy="1023288"/>
-          </a:xfrm>
-          <a:prstGeom prst="rect">
-            <a:avLst/>
-          </a:prstGeom>
-          <a:solidFill>
-            <a:srgbClr val="C8102E"/>
-          </a:solidFill>
-          <a:ln>
-            <a:noFill/>
-          </a:ln>
-          <a:effectLst/>
-        </p:spPr>
-        <p:style>
-          <a:lnRef idx="1">
-            <a:schemeClr val="accent1"/>
-          </a:lnRef>
-          <a:fillRef idx="3">
-            <a:schemeClr val="accent1"/>
-          </a:fillRef>
-          <a:effectRef idx="2">
-            <a:schemeClr val="accent1"/>
-          </a:effectRef>
-          <a:fontRef idx="minor">
-            <a:schemeClr val="lt1"/>
-          </a:fontRef>
-        </p:style>
-        <p:txBody>
-          <a:bodyPr rtlCol="0" anchor="t" wrap="square" lIns="49196" rIns="49196" tIns="19678" bIns="19678"/>
-          <a:lstStyle/>
-          <a:p>
-            <a:pPr algn="l"/>
-            <a:r>
-              <a:rPr sz="929" b="1">
-                <a:solidFill>
-                  <a:srgbClr val="FFFFFF"/>
-                </a:solidFill>
-                <a:latin typeface="Yu Gothic UI"/>
-                <a:ea typeface="Yu Gothic UI"/>
-              </a:rPr>
-              <a:t>Web API 2(移植)</a:t>
-            </a:r>
-          </a:p>
-        </p:txBody>
-      </p:sp>
-      <p:sp>
-        <p:nvSpPr>
-          <p:cNvPr id="32" name="Rounded Rectangle 31"/>
-          <p:cNvSpPr/>
-          <p:nvPr/>
-        </p:nvSpPr>
-        <p:spPr>
-          <a:xfrm>
-            <a:off x="4978691" y="1279110"/>
-            <a:ext cx="865859" cy="167268"/>
+              <a:t>AspNetWebStack</a:t>
+            </a:r>
+          </a:p>
+        </p:txBody>
+      </p:sp>
+      <p:sp>
+        <p:nvSpPr>
+          <p:cNvPr id="31" name="Rounded Rectangle 30"/>
+          <p:cNvSpPr/>
+          <p:nvPr/>
+        </p:nvSpPr>
+        <p:spPr>
+          <a:xfrm>
+            <a:off x="3916045" y="1869469"/>
+            <a:ext cx="905216" cy="167268"/>
           </a:xfrm>
           <a:prstGeom prst="roundRect">
             <a:avLst>
@@ -15961,7 +15907,61 @@
                 <a:latin typeface="Yu Gothic UI"/>
                 <a:ea typeface="Yu Gothic UI"/>
               </a:rPr>
-              <a:t>Web.Http</a:t>
+              <a:t>バンドル</a:t>
+            </a:r>
+          </a:p>
+        </p:txBody>
+      </p:sp>
+      <p:sp>
+        <p:nvSpPr>
+          <p:cNvPr id="32" name="Rectangle 31"/>
+          <p:cNvSpPr/>
+          <p:nvPr/>
+        </p:nvSpPr>
+        <p:spPr>
+          <a:xfrm>
+            <a:off x="4919655" y="1062645"/>
+            <a:ext cx="983931" cy="1023288"/>
+          </a:xfrm>
+          <a:prstGeom prst="rect">
+            <a:avLst/>
+          </a:prstGeom>
+          <a:solidFill>
+            <a:srgbClr val="C8102E"/>
+          </a:solidFill>
+          <a:ln>
+            <a:noFill/>
+          </a:ln>
+          <a:effectLst/>
+        </p:spPr>
+        <p:style>
+          <a:lnRef idx="1">
+            <a:schemeClr val="accent1"/>
+          </a:lnRef>
+          <a:fillRef idx="3">
+            <a:schemeClr val="accent1"/>
+          </a:fillRef>
+          <a:effectRef idx="2">
+            <a:schemeClr val="accent1"/>
+          </a:effectRef>
+          <a:fontRef idx="minor">
+            <a:schemeClr val="lt1"/>
+          </a:fontRef>
+        </p:style>
+        <p:txBody>
+          <a:bodyPr rtlCol="0" anchor="t" wrap="square" lIns="49196" rIns="49196" tIns="19678" bIns="19678"/>
+          <a:lstStyle/>
+          <a:p>
+            <a:pPr algn="l"/>
+            <a:r>
+              <a:rPr sz="929" b="1">
+                <a:solidFill>
+                  <a:srgbClr val="FFFFFF"/>
+                </a:solidFill>
+                <a:latin typeface="Yu Gothic UI"/>
+                <a:ea typeface="Yu Gothic UI"/>
+              </a:rPr>
+              <a:t>Web API 2(移植)</a:t>
             </a:r>
           </a:p>
         </p:txBody>
@@ -15974,7 +15974,7 @@
         </p:nvSpPr>
         <p:spPr>
           <a:xfrm>
-            <a:off x="4978691" y="1475896"/>
+            <a:off x="4978691" y="1279110"/>
             <a:ext cx="865859" cy="167268"/>
           </a:xfrm>
           <a:prstGeom prst="roundRect">
@@ -16017,7 +16017,7 @@
                 <a:latin typeface="Yu Gothic UI"/>
                 <a:ea typeface="Yu Gothic UI"/>
               </a:rPr>
-              <a:t>Http.WebHost</a:t>
+              <a:t>Web.Http</a:t>
             </a:r>
           </a:p>
         </p:txBody>
@@ -16030,7 +16030,7 @@
         </p:nvSpPr>
         <p:spPr>
           <a:xfrm>
-            <a:off x="4978691" y="1672682"/>
+            <a:off x="4978691" y="1475896"/>
             <a:ext cx="865859" cy="167268"/>
           </a:xfrm>
           <a:prstGeom prst="roundRect">
@@ -16073,75 +16073,21 @@
                 <a:latin typeface="Yu Gothic UI"/>
                 <a:ea typeface="Yu Gothic UI"/>
               </a:rPr>
-              <a:t>Json.NET</a:t>
-            </a:r>
-          </a:p>
-        </p:txBody>
-      </p:sp>
-      <p:sp>
-        <p:nvSpPr>
-          <p:cNvPr id="35" name="Rectangle 34"/>
-          <p:cNvSpPr/>
-          <p:nvPr/>
-        </p:nvSpPr>
-        <p:spPr>
-          <a:xfrm>
-            <a:off x="5942944" y="1062645"/>
-            <a:ext cx="905216" cy="1023288"/>
-          </a:xfrm>
-          <a:prstGeom prst="rect">
-            <a:avLst/>
-          </a:prstGeom>
-          <a:solidFill>
-            <a:srgbClr val="C8102E"/>
-          </a:solidFill>
-          <a:ln>
-            <a:noFill/>
-          </a:ln>
-          <a:effectLst/>
-        </p:spPr>
-        <p:style>
-          <a:lnRef idx="1">
-            <a:schemeClr val="accent1"/>
-          </a:lnRef>
-          <a:fillRef idx="3">
-            <a:schemeClr val="accent1"/>
-          </a:fillRef>
-          <a:effectRef idx="2">
-            <a:schemeClr val="accent1"/>
-          </a:effectRef>
-          <a:fontRef idx="minor">
-            <a:schemeClr val="lt1"/>
-          </a:fontRef>
-        </p:style>
-        <p:txBody>
-          <a:bodyPr rtlCol="0" anchor="t" wrap="square" lIns="49196" rIns="49196" tIns="19678" bIns="19678"/>
-          <a:lstStyle/>
-          <a:p>
-            <a:pPr algn="l"/>
-            <a:r>
-              <a:rPr sz="929" b="1">
-                <a:solidFill>
-                  <a:srgbClr val="FFFFFF"/>
-                </a:solidFill>
-                <a:latin typeface="Yu Gothic UI"/>
-                <a:ea typeface="Yu Gothic UI"/>
-              </a:rPr>
-              <a:t>ASMX(移植)</a:t>
-            </a:r>
-          </a:p>
-        </p:txBody>
-      </p:sp>
-      <p:sp>
-        <p:nvSpPr>
-          <p:cNvPr id="36" name="Rounded Rectangle 35"/>
-          <p:cNvSpPr/>
-          <p:nvPr/>
-        </p:nvSpPr>
-        <p:spPr>
-          <a:xfrm>
-            <a:off x="6001979" y="1279110"/>
-            <a:ext cx="787144" cy="167268"/>
+              <a:t>Http.WebHost</a:t>
+            </a:r>
+          </a:p>
+        </p:txBody>
+      </p:sp>
+      <p:sp>
+        <p:nvSpPr>
+          <p:cNvPr id="35" name="Rounded Rectangle 34"/>
+          <p:cNvSpPr/>
+          <p:nvPr/>
+        </p:nvSpPr>
+        <p:spPr>
+          <a:xfrm>
+            <a:off x="4978691" y="1672682"/>
+            <a:ext cx="865859" cy="167268"/>
           </a:xfrm>
           <a:prstGeom prst="roundRect">
             <a:avLst>
@@ -16183,7 +16129,61 @@
                 <a:latin typeface="Yu Gothic UI"/>
                 <a:ea typeface="Yu Gothic UI"/>
               </a:rPr>
-              <a:t>Web.Services</a:t>
+              <a:t>Json.NET</a:t>
+            </a:r>
+          </a:p>
+        </p:txBody>
+      </p:sp>
+      <p:sp>
+        <p:nvSpPr>
+          <p:cNvPr id="36" name="Rectangle 35"/>
+          <p:cNvSpPr/>
+          <p:nvPr/>
+        </p:nvSpPr>
+        <p:spPr>
+          <a:xfrm>
+            <a:off x="5942944" y="1062645"/>
+            <a:ext cx="905216" cy="1023288"/>
+          </a:xfrm>
+          <a:prstGeom prst="rect">
+            <a:avLst/>
+          </a:prstGeom>
+          <a:solidFill>
+            <a:srgbClr val="C8102E"/>
+          </a:solidFill>
+          <a:ln>
+            <a:noFill/>
+          </a:ln>
+          <a:effectLst/>
+        </p:spPr>
+        <p:style>
+          <a:lnRef idx="1">
+            <a:schemeClr val="accent1"/>
+          </a:lnRef>
+          <a:fillRef idx="3">
+            <a:schemeClr val="accent1"/>
+          </a:fillRef>
+          <a:effectRef idx="2">
+            <a:schemeClr val="accent1"/>
+          </a:effectRef>
+          <a:fontRef idx="minor">
+            <a:schemeClr val="lt1"/>
+          </a:fontRef>
+        </p:style>
+        <p:txBody>
+          <a:bodyPr rtlCol="0" anchor="t" wrap="square" lIns="49196" rIns="49196" tIns="19678" bIns="19678"/>
+          <a:lstStyle/>
+          <a:p>
+            <a:pPr algn="l"/>
+            <a:r>
+              <a:rPr sz="929" b="1">
+                <a:solidFill>
+                  <a:srgbClr val="FFFFFF"/>
+                </a:solidFill>
+                <a:latin typeface="Yu Gothic UI"/>
+                <a:ea typeface="Yu Gothic UI"/>
+              </a:rPr>
+              <a:t>ASMX(移植)</a:t>
             </a:r>
           </a:p>
         </p:txBody>
@@ -16196,7 +16196,7 @@
         </p:nvSpPr>
         <p:spPr>
           <a:xfrm>
-            <a:off x="6001979" y="1475896"/>
+            <a:off x="6001979" y="1279110"/>
             <a:ext cx="787144" cy="167268"/>
           </a:xfrm>
           <a:prstGeom prst="roundRect">
@@ -16239,88 +16239,21 @@
                 <a:latin typeface="Yu Gothic UI"/>
                 <a:ea typeface="Yu Gothic UI"/>
               </a:rPr>
-              <a:t>WSDL・SOAP</a:t>
-            </a:r>
-          </a:p>
-        </p:txBody>
-      </p:sp>
-      <p:sp>
-        <p:nvSpPr>
-          <p:cNvPr id="38" name="Rectangle 37"/>
-          <p:cNvSpPr/>
-          <p:nvPr/>
-        </p:nvSpPr>
-        <p:spPr>
-          <a:xfrm>
-            <a:off x="6887517" y="393572"/>
-            <a:ext cx="3424080" cy="1692361"/>
-          </a:xfrm>
-          <a:prstGeom prst="rect">
-            <a:avLst/>
-          </a:prstGeom>
-          <a:solidFill>
-            <a:srgbClr val="F39A3D"/>
-          </a:solidFill>
-          <a:ln>
-            <a:noFill/>
-          </a:ln>
-          <a:effectLst/>
-        </p:spPr>
-        <p:style>
-          <a:lnRef idx="1">
-            <a:schemeClr val="accent1"/>
-          </a:lnRef>
-          <a:fillRef idx="3">
-            <a:schemeClr val="accent1"/>
-          </a:fillRef>
-          <a:effectRef idx="2">
-            <a:schemeClr val="accent1"/>
-          </a:effectRef>
-          <a:fontRef idx="minor">
-            <a:schemeClr val="lt1"/>
-          </a:fontRef>
-        </p:style>
-        <p:txBody>
-          <a:bodyPr rtlCol="0" anchor="t" wrap="square" lIns="49196" rIns="49196" tIns="19678" bIns="19678"/>
-          <a:lstStyle/>
-          <a:p>
-            <a:pPr algn="l"/>
-            <a:r>
-              <a:rPr sz="929" b="1">
-                <a:solidFill>
-                  <a:srgbClr val="FFFFFF"/>
-                </a:solidFill>
-                <a:latin typeface="Yu Gothic UI"/>
-                <a:ea typeface="Yu Gothic UI"/>
-              </a:rPr>
-              <a:t>お客様のアプリ</a:t>
-            </a:r>
-          </a:p>
-          <a:p>
-            <a:pPr algn="l"/>
-            <a:r>
-              <a:rPr sz="929" b="1">
-                <a:solidFill>
-                  <a:srgbClr val="FFFFFF"/>
-                </a:solidFill>
-                <a:latin typeface="Yu Gothic UI"/>
-                <a:ea typeface="Yu Gothic UI"/>
-              </a:rPr>
-              <a:t>全種類で共通(ほぼそのまま)</a:t>
-            </a:r>
-          </a:p>
-        </p:txBody>
-      </p:sp>
-      <p:sp>
-        <p:nvSpPr>
-          <p:cNvPr id="39" name="Rounded Rectangle 38"/>
-          <p:cNvSpPr/>
-          <p:nvPr/>
-        </p:nvSpPr>
-        <p:spPr>
-          <a:xfrm>
-            <a:off x="6946553" y="767466"/>
-            <a:ext cx="3306008" cy="167268"/>
+              <a:t>Web.Services</a:t>
+            </a:r>
+          </a:p>
+        </p:txBody>
+      </p:sp>
+      <p:sp>
+        <p:nvSpPr>
+          <p:cNvPr id="38" name="Rounded Rectangle 37"/>
+          <p:cNvSpPr/>
+          <p:nvPr/>
+        </p:nvSpPr>
+        <p:spPr>
+          <a:xfrm>
+            <a:off x="6001979" y="1475896"/>
+            <a:ext cx="787144" cy="167268"/>
           </a:xfrm>
           <a:prstGeom prst="roundRect">
             <a:avLst>
@@ -16328,7 +16261,7 @@
             </a:avLst>
           </a:prstGeom>
           <a:solidFill>
-            <a:srgbClr val="FEF3E8"/>
+            <a:srgbClr val="F8E2E6"/>
           </a:solidFill>
           <a:ln>
             <a:noFill/>
@@ -16362,7 +16295,74 @@
                 <a:latin typeface="Yu Gothic UI"/>
                 <a:ea typeface="Yu Gothic UI"/>
               </a:rPr>
-              <a:t>Global.asax</a:t>
+              <a:t>WSDL・SOAP</a:t>
+            </a:r>
+          </a:p>
+        </p:txBody>
+      </p:sp>
+      <p:sp>
+        <p:nvSpPr>
+          <p:cNvPr id="39" name="Rectangle 38"/>
+          <p:cNvSpPr/>
+          <p:nvPr/>
+        </p:nvSpPr>
+        <p:spPr>
+          <a:xfrm>
+            <a:off x="6887517" y="393572"/>
+            <a:ext cx="3424080" cy="1692361"/>
+          </a:xfrm>
+          <a:prstGeom prst="rect">
+            <a:avLst/>
+          </a:prstGeom>
+          <a:solidFill>
+            <a:srgbClr val="F39A3D"/>
+          </a:solidFill>
+          <a:ln>
+            <a:noFill/>
+          </a:ln>
+          <a:effectLst/>
+        </p:spPr>
+        <p:style>
+          <a:lnRef idx="1">
+            <a:schemeClr val="accent1"/>
+          </a:lnRef>
+          <a:fillRef idx="3">
+            <a:schemeClr val="accent1"/>
+          </a:fillRef>
+          <a:effectRef idx="2">
+            <a:schemeClr val="accent1"/>
+          </a:effectRef>
+          <a:fontRef idx="minor">
+            <a:schemeClr val="lt1"/>
+          </a:fontRef>
+        </p:style>
+        <p:txBody>
+          <a:bodyPr rtlCol="0" anchor="t" wrap="square" lIns="49196" rIns="49196" tIns="19678" bIns="19678"/>
+          <a:lstStyle/>
+          <a:p>
+            <a:pPr algn="l"/>
+            <a:r>
+              <a:rPr sz="929" b="1">
+                <a:solidFill>
+                  <a:srgbClr val="FFFFFF"/>
+                </a:solidFill>
+                <a:latin typeface="Yu Gothic UI"/>
+                <a:ea typeface="Yu Gothic UI"/>
+              </a:rPr>
+              <a:t>お客様のアプリ</a:t>
+            </a:r>
+          </a:p>
+          <a:p>
+            <a:pPr algn="l"/>
+            <a:r>
+              <a:rPr sz="929" b="1">
+                <a:solidFill>
+                  <a:srgbClr val="FFFFFF"/>
+                </a:solidFill>
+                <a:latin typeface="Yu Gothic UI"/>
+                <a:ea typeface="Yu Gothic UI"/>
+              </a:rPr>
+              <a:t>全種類で共通(ほぼそのまま)</a:t>
             </a:r>
           </a:p>
         </p:txBody>
@@ -16375,7 +16375,7 @@
         </p:nvSpPr>
         <p:spPr>
           <a:xfrm>
-            <a:off x="6946553" y="964252"/>
+            <a:off x="6946553" y="767466"/>
             <a:ext cx="3306008" cy="167268"/>
           </a:xfrm>
           <a:prstGeom prst="roundRect">
@@ -16418,7 +16418,7 @@
                 <a:latin typeface="Yu Gothic UI"/>
                 <a:ea typeface="Yu Gothic UI"/>
               </a:rPr>
-              <a:t>web.config</a:t>
+              <a:t>Global.asax</a:t>
             </a:r>
           </a:p>
         </p:txBody>
@@ -16431,7 +16431,7 @@
         </p:nvSpPr>
         <p:spPr>
           <a:xfrm>
-            <a:off x="6946553" y="1161038"/>
+            <a:off x="6946553" y="964252"/>
             <a:ext cx="3306008" cy="167268"/>
           </a:xfrm>
           <a:prstGeom prst="roundRect">
@@ -16474,7 +16474,7 @@
                 <a:latin typeface="Yu Gothic UI"/>
                 <a:ea typeface="Yu Gothic UI"/>
               </a:rPr>
-              <a:t>App_Code</a:t>
+              <a:t>web.config</a:t>
             </a:r>
           </a:p>
         </p:txBody>
@@ -16487,7 +16487,7 @@
         </p:nvSpPr>
         <p:spPr>
           <a:xfrm>
-            <a:off x="6946553" y="1357824"/>
+            <a:off x="6946553" y="1161038"/>
             <a:ext cx="3306008" cy="167268"/>
           </a:xfrm>
           <a:prstGeom prst="roundRect">
@@ -16530,7 +16530,7 @@
                 <a:latin typeface="Yu Gothic UI"/>
                 <a:ea typeface="Yu Gothic UI"/>
               </a:rPr>
-              <a:t>クラスライブラリ(C#・VB)</a:t>
+              <a:t>App_Code</a:t>
             </a:r>
           </a:p>
         </p:txBody>
@@ -16543,7 +16543,7 @@
         </p:nvSpPr>
         <p:spPr>
           <a:xfrm>
-            <a:off x="6946553" y="1554611"/>
+            <a:off x="6946553" y="1357824"/>
             <a:ext cx="3306008" cy="167268"/>
           </a:xfrm>
           <a:prstGeom prst="roundRect">
@@ -16586,354 +16586,21 @@
                 <a:latin typeface="Yu Gothic UI"/>
                 <a:ea typeface="Yu Gothic UI"/>
               </a:rPr>
-              <a:t>参照する DLL(付け替え)</a:t>
-            </a:r>
-          </a:p>
-        </p:txBody>
-      </p:sp>
-      <p:sp>
-        <p:nvSpPr>
-          <p:cNvPr id="44" name="Rectangle 43"/>
-          <p:cNvSpPr/>
-          <p:nvPr/>
-        </p:nvSpPr>
-        <p:spPr>
-          <a:xfrm>
-            <a:off x="8638915" y="2085934"/>
-            <a:ext cx="1672682" cy="905216"/>
-          </a:xfrm>
-          <a:prstGeom prst="rect">
-            <a:avLst/>
-          </a:prstGeom>
-          <a:solidFill>
-            <a:srgbClr val="F39A3D"/>
-          </a:solidFill>
-          <a:ln>
-            <a:noFill/>
-          </a:ln>
-          <a:effectLst/>
-        </p:spPr>
-        <p:style>
-          <a:lnRef idx="1">
-            <a:schemeClr val="accent1"/>
-          </a:lnRef>
-          <a:fillRef idx="3">
-            <a:schemeClr val="accent1"/>
-          </a:fillRef>
-          <a:effectRef idx="2">
-            <a:schemeClr val="accent1"/>
-          </a:effectRef>
-          <a:fontRef idx="minor">
-            <a:schemeClr val="lt1"/>
-          </a:fontRef>
-        </p:style>
-        <p:txBody>
-          <a:bodyPr rtlCol="0" anchor="t" wrap="square" lIns="49196" rIns="49196" tIns="19678" bIns="19678"/>
-          <a:lstStyle/>
-          <a:p>
-            <a:pPr algn="l"/>
-            <a:r>
-              <a:rPr sz="929" b="1">
-                <a:solidFill>
-                  <a:srgbClr val="FFFFFF"/>
-                </a:solidFill>
-                <a:latin typeface="Yu Gothic UI"/>
-                <a:ea typeface="Yu Gothic UI"/>
-              </a:rPr>
-              <a:t/>
-            </a:r>
-          </a:p>
-        </p:txBody>
-      </p:sp>
-      <p:sp>
-        <p:nvSpPr>
-          <p:cNvPr id="45" name="Rectangle 44"/>
-          <p:cNvSpPr/>
-          <p:nvPr/>
-        </p:nvSpPr>
-        <p:spPr>
-          <a:xfrm>
-            <a:off x="8638915" y="2755007"/>
-            <a:ext cx="1672682" cy="196786"/>
-          </a:xfrm>
-          <a:prstGeom prst="rect">
-            <a:avLst/>
-          </a:prstGeom>
-          <a:noFill/>
-          <a:ln>
-            <a:noFill/>
-          </a:ln>
-          <a:effectLst/>
-        </p:spPr>
-        <p:style>
-          <a:lnRef idx="1">
-            <a:schemeClr val="accent1"/>
-          </a:lnRef>
-          <a:fillRef idx="3">
-            <a:schemeClr val="accent1"/>
-          </a:fillRef>
-          <a:effectRef idx="2">
-            <a:schemeClr val="accent1"/>
-          </a:effectRef>
-          <a:fontRef idx="minor">
-            <a:schemeClr val="lt1"/>
-          </a:fontRef>
-        </p:style>
-        <p:txBody>
-          <a:bodyPr rtlCol="0" anchor="t" wrap="square" lIns="49196" rIns="49196" tIns="19678" bIns="19678"/>
-          <a:lstStyle/>
-          <a:p>
-            <a:pPr algn="l"/>
-            <a:r>
-              <a:rPr sz="851" b="1">
-                <a:solidFill>
-                  <a:srgbClr val="FFFFFF"/>
-                </a:solidFill>
-                <a:latin typeface="Yu Gothic UI"/>
-                <a:ea typeface="Yu Gothic UI"/>
-              </a:rPr>
-              <a:t>下の層も直接使う ↓</a:t>
-            </a:r>
-          </a:p>
-        </p:txBody>
-      </p:sp>
-      <p:sp>
-        <p:nvSpPr>
-          <p:cNvPr id="46" name="Rectangle 45"/>
-          <p:cNvSpPr/>
-          <p:nvPr/>
-        </p:nvSpPr>
-        <p:spPr>
-          <a:xfrm>
-            <a:off x="8973451" y="2991150"/>
-            <a:ext cx="1338146" cy="511644"/>
-          </a:xfrm>
-          <a:prstGeom prst="rect">
-            <a:avLst/>
-          </a:prstGeom>
-          <a:solidFill>
-            <a:srgbClr val="F39A3D"/>
-          </a:solidFill>
-          <a:ln>
-            <a:noFill/>
-          </a:ln>
-          <a:effectLst/>
-        </p:spPr>
-        <p:style>
-          <a:lnRef idx="1">
-            <a:schemeClr val="accent1"/>
-          </a:lnRef>
-          <a:fillRef idx="3">
-            <a:schemeClr val="accent1"/>
-          </a:fillRef>
-          <a:effectRef idx="2">
-            <a:schemeClr val="accent1"/>
-          </a:effectRef>
-          <a:fontRef idx="minor">
-            <a:schemeClr val="lt1"/>
-          </a:fontRef>
-        </p:style>
-        <p:txBody>
-          <a:bodyPr rtlCol="0" anchor="t" wrap="square" lIns="49196" rIns="49196" tIns="19678" bIns="19678"/>
-          <a:lstStyle/>
-          <a:p>
-            <a:pPr algn="l"/>
-            <a:r>
-              <a:rPr sz="929" b="1">
-                <a:solidFill>
-                  <a:srgbClr val="FFFFFF"/>
-                </a:solidFill>
-                <a:latin typeface="Yu Gothic UI"/>
-                <a:ea typeface="Yu Gothic UI"/>
-              </a:rPr>
-              <a:t/>
-            </a:r>
-          </a:p>
-        </p:txBody>
-      </p:sp>
-      <p:sp>
-        <p:nvSpPr>
-          <p:cNvPr id="47" name="Rectangle 46"/>
-          <p:cNvSpPr/>
-          <p:nvPr/>
-        </p:nvSpPr>
-        <p:spPr>
-          <a:xfrm>
-            <a:off x="8973451" y="3306008"/>
-            <a:ext cx="1338146" cy="196786"/>
-          </a:xfrm>
-          <a:prstGeom prst="rect">
-            <a:avLst/>
-          </a:prstGeom>
-          <a:noFill/>
-          <a:ln>
-            <a:noFill/>
-          </a:ln>
-          <a:effectLst/>
-        </p:spPr>
-        <p:style>
-          <a:lnRef idx="1">
-            <a:schemeClr val="accent1"/>
-          </a:lnRef>
-          <a:fillRef idx="3">
-            <a:schemeClr val="accent1"/>
-          </a:fillRef>
-          <a:effectRef idx="2">
-            <a:schemeClr val="accent1"/>
-          </a:effectRef>
-          <a:fontRef idx="minor">
-            <a:schemeClr val="lt1"/>
-          </a:fontRef>
-        </p:style>
-        <p:txBody>
-          <a:bodyPr rtlCol="0" anchor="t" wrap="square" lIns="49196" rIns="49196" tIns="19678" bIns="19678"/>
-          <a:lstStyle/>
-          <a:p>
-            <a:pPr algn="l"/>
-            <a:r>
-              <a:rPr sz="851" b="1">
-                <a:solidFill>
-                  <a:srgbClr val="FFFFFF"/>
-                </a:solidFill>
-                <a:latin typeface="Yu Gothic UI"/>
-                <a:ea typeface="Yu Gothic UI"/>
-              </a:rPr>
-              <a:t>Compat ↓(違う所だけ)</a:t>
-            </a:r>
-          </a:p>
-        </p:txBody>
-      </p:sp>
-      <p:sp>
-        <p:nvSpPr>
-          <p:cNvPr id="48" name="Rectangle 47"/>
-          <p:cNvSpPr/>
-          <p:nvPr/>
-        </p:nvSpPr>
-        <p:spPr>
-          <a:xfrm>
-            <a:off x="10036097" y="3502794"/>
-            <a:ext cx="275500" cy="1023288"/>
-          </a:xfrm>
-          <a:prstGeom prst="rect">
-            <a:avLst/>
-          </a:prstGeom>
-          <a:solidFill>
-            <a:srgbClr val="F39A3D"/>
-          </a:solidFill>
-          <a:ln>
-            <a:noFill/>
-          </a:ln>
-          <a:effectLst/>
-        </p:spPr>
-        <p:style>
-          <a:lnRef idx="1">
-            <a:schemeClr val="accent1"/>
-          </a:lnRef>
-          <a:fillRef idx="3">
-            <a:schemeClr val="accent1"/>
-          </a:fillRef>
-          <a:effectRef idx="2">
-            <a:schemeClr val="accent1"/>
-          </a:effectRef>
-          <a:fontRef idx="minor">
-            <a:schemeClr val="lt1"/>
-          </a:fontRef>
-        </p:style>
-        <p:txBody>
-          <a:bodyPr rtlCol="0" anchor="ctr" wrap="square" lIns="49196" rIns="49196" tIns="19678" bIns="19678" vert="eaVert"/>
-          <a:lstStyle/>
-          <a:p>
-            <a:pPr algn="ctr"/>
-            <a:r>
-              <a:rPr sz="774" b="1">
-                <a:solidFill>
-                  <a:srgbClr val="FFFFFF"/>
-                </a:solidFill>
-                <a:latin typeface="Yu Gothic UI"/>
-                <a:ea typeface="Yu Gothic UI"/>
-              </a:rPr>
-              <a:t>直接</a:t>
-            </a:r>
-          </a:p>
-        </p:txBody>
-      </p:sp>
-      <p:sp>
-        <p:nvSpPr>
-          <p:cNvPr id="49" name="Rectangle 48"/>
-          <p:cNvSpPr/>
-          <p:nvPr/>
-        </p:nvSpPr>
-        <p:spPr>
-          <a:xfrm>
-            <a:off x="8973451" y="3542152"/>
-            <a:ext cx="1023288" cy="983931"/>
-          </a:xfrm>
-          <a:prstGeom prst="rect">
-            <a:avLst/>
-          </a:prstGeom>
-          <a:solidFill>
-            <a:srgbClr val="3AA357"/>
-          </a:solidFill>
-          <a:ln>
-            <a:noFill/>
-          </a:ln>
-          <a:effectLst/>
-        </p:spPr>
-        <p:style>
-          <a:lnRef idx="1">
-            <a:schemeClr val="accent1"/>
-          </a:lnRef>
-          <a:fillRef idx="3">
-            <a:schemeClr val="accent1"/>
-          </a:fillRef>
-          <a:effectRef idx="2">
-            <a:schemeClr val="accent1"/>
-          </a:effectRef>
-          <a:fontRef idx="minor">
-            <a:schemeClr val="lt1"/>
-          </a:fontRef>
-        </p:style>
-        <p:txBody>
-          <a:bodyPr rtlCol="0" anchor="t" wrap="square" lIns="49196" rIns="49196" tIns="19678" bIns="19678"/>
-          <a:lstStyle/>
-          <a:p>
-            <a:pPr algn="l"/>
-            <a:r>
-              <a:rPr sz="851" b="1">
-                <a:solidFill>
-                  <a:srgbClr val="FFFFFF"/>
-                </a:solidFill>
-                <a:latin typeface="Yu Gothic UI"/>
-                <a:ea typeface="Yu Gothic UI"/>
-              </a:rPr>
-              <a:t>FrameworkOnCore</a:t>
-            </a:r>
-          </a:p>
-          <a:p>
-            <a:pPr algn="l"/>
-            <a:r>
-              <a:rPr sz="851" b="1">
-                <a:solidFill>
-                  <a:srgbClr val="FFFFFF"/>
-                </a:solidFill>
-                <a:latin typeface="Yu Gothic UI"/>
-                <a:ea typeface="Yu Gothic UI"/>
-              </a:rPr>
-              <a:t>.Compat</a:t>
-            </a:r>
-          </a:p>
-        </p:txBody>
-      </p:sp>
-      <p:sp>
-        <p:nvSpPr>
-          <p:cNvPr id="50" name="Rounded Rectangle 49"/>
-          <p:cNvSpPr/>
-          <p:nvPr/>
-        </p:nvSpPr>
-        <p:spPr>
-          <a:xfrm>
-            <a:off x="9032487" y="3896367"/>
-            <a:ext cx="905216" cy="167268"/>
+              <a:t>クラスライブラリ(C#・VB)</a:t>
+            </a:r>
+          </a:p>
+        </p:txBody>
+      </p:sp>
+      <p:sp>
+        <p:nvSpPr>
+          <p:cNvPr id="44" name="Rounded Rectangle 43"/>
+          <p:cNvSpPr/>
+          <p:nvPr/>
+        </p:nvSpPr>
+        <p:spPr>
+          <a:xfrm>
+            <a:off x="6946553" y="1554611"/>
+            <a:ext cx="3306008" cy="167268"/>
           </a:xfrm>
           <a:prstGeom prst="roundRect">
             <a:avLst>
@@ -16941,7 +16608,7 @@
             </a:avLst>
           </a:prstGeom>
           <a:solidFill>
-            <a:srgbClr val="E7F4EB"/>
+            <a:srgbClr val="FEF3E8"/>
           </a:solidFill>
           <a:ln>
             <a:noFill/>
@@ -16975,7 +16642,340 @@
                 <a:latin typeface="Yu Gothic UI"/>
                 <a:ea typeface="Yu Gothic UI"/>
               </a:rPr>
-              <a:t>数値・カルチャ</a:t>
+              <a:t>参照する DLL(付け替え)</a:t>
+            </a:r>
+          </a:p>
+        </p:txBody>
+      </p:sp>
+      <p:sp>
+        <p:nvSpPr>
+          <p:cNvPr id="45" name="Rectangle 44"/>
+          <p:cNvSpPr/>
+          <p:nvPr/>
+        </p:nvSpPr>
+        <p:spPr>
+          <a:xfrm>
+            <a:off x="8638915" y="2085934"/>
+            <a:ext cx="1672682" cy="905216"/>
+          </a:xfrm>
+          <a:prstGeom prst="rect">
+            <a:avLst/>
+          </a:prstGeom>
+          <a:solidFill>
+            <a:srgbClr val="F39A3D"/>
+          </a:solidFill>
+          <a:ln>
+            <a:noFill/>
+          </a:ln>
+          <a:effectLst/>
+        </p:spPr>
+        <p:style>
+          <a:lnRef idx="1">
+            <a:schemeClr val="accent1"/>
+          </a:lnRef>
+          <a:fillRef idx="3">
+            <a:schemeClr val="accent1"/>
+          </a:fillRef>
+          <a:effectRef idx="2">
+            <a:schemeClr val="accent1"/>
+          </a:effectRef>
+          <a:fontRef idx="minor">
+            <a:schemeClr val="lt1"/>
+          </a:fontRef>
+        </p:style>
+        <p:txBody>
+          <a:bodyPr rtlCol="0" anchor="t" wrap="square" lIns="49196" rIns="49196" tIns="19678" bIns="19678"/>
+          <a:lstStyle/>
+          <a:p>
+            <a:pPr algn="l"/>
+            <a:r>
+              <a:rPr sz="929" b="1">
+                <a:solidFill>
+                  <a:srgbClr val="FFFFFF"/>
+                </a:solidFill>
+                <a:latin typeface="Yu Gothic UI"/>
+                <a:ea typeface="Yu Gothic UI"/>
+              </a:rPr>
+              <a:t/>
+            </a:r>
+          </a:p>
+        </p:txBody>
+      </p:sp>
+      <p:sp>
+        <p:nvSpPr>
+          <p:cNvPr id="46" name="Rectangle 45"/>
+          <p:cNvSpPr/>
+          <p:nvPr/>
+        </p:nvSpPr>
+        <p:spPr>
+          <a:xfrm>
+            <a:off x="8638915" y="2755007"/>
+            <a:ext cx="1672682" cy="196786"/>
+          </a:xfrm>
+          <a:prstGeom prst="rect">
+            <a:avLst/>
+          </a:prstGeom>
+          <a:noFill/>
+          <a:ln>
+            <a:noFill/>
+          </a:ln>
+          <a:effectLst/>
+        </p:spPr>
+        <p:style>
+          <a:lnRef idx="1">
+            <a:schemeClr val="accent1"/>
+          </a:lnRef>
+          <a:fillRef idx="3">
+            <a:schemeClr val="accent1"/>
+          </a:fillRef>
+          <a:effectRef idx="2">
+            <a:schemeClr val="accent1"/>
+          </a:effectRef>
+          <a:fontRef idx="minor">
+            <a:schemeClr val="lt1"/>
+          </a:fontRef>
+        </p:style>
+        <p:txBody>
+          <a:bodyPr rtlCol="0" anchor="t" wrap="square" lIns="49196" rIns="49196" tIns="19678" bIns="19678"/>
+          <a:lstStyle/>
+          <a:p>
+            <a:pPr algn="l"/>
+            <a:r>
+              <a:rPr sz="851" b="1">
+                <a:solidFill>
+                  <a:srgbClr val="FFFFFF"/>
+                </a:solidFill>
+                <a:latin typeface="Yu Gothic UI"/>
+                <a:ea typeface="Yu Gothic UI"/>
+              </a:rPr>
+              <a:t>下の層も直接使う ↓</a:t>
+            </a:r>
+          </a:p>
+        </p:txBody>
+      </p:sp>
+      <p:sp>
+        <p:nvSpPr>
+          <p:cNvPr id="47" name="Rectangle 46"/>
+          <p:cNvSpPr/>
+          <p:nvPr/>
+        </p:nvSpPr>
+        <p:spPr>
+          <a:xfrm>
+            <a:off x="8973451" y="2991150"/>
+            <a:ext cx="1338146" cy="511644"/>
+          </a:xfrm>
+          <a:prstGeom prst="rect">
+            <a:avLst/>
+          </a:prstGeom>
+          <a:solidFill>
+            <a:srgbClr val="F39A3D"/>
+          </a:solidFill>
+          <a:ln>
+            <a:noFill/>
+          </a:ln>
+          <a:effectLst/>
+        </p:spPr>
+        <p:style>
+          <a:lnRef idx="1">
+            <a:schemeClr val="accent1"/>
+          </a:lnRef>
+          <a:fillRef idx="3">
+            <a:schemeClr val="accent1"/>
+          </a:fillRef>
+          <a:effectRef idx="2">
+            <a:schemeClr val="accent1"/>
+          </a:effectRef>
+          <a:fontRef idx="minor">
+            <a:schemeClr val="lt1"/>
+          </a:fontRef>
+        </p:style>
+        <p:txBody>
+          <a:bodyPr rtlCol="0" anchor="t" wrap="square" lIns="49196" rIns="49196" tIns="19678" bIns="19678"/>
+          <a:lstStyle/>
+          <a:p>
+            <a:pPr algn="l"/>
+            <a:r>
+              <a:rPr sz="929" b="1">
+                <a:solidFill>
+                  <a:srgbClr val="FFFFFF"/>
+                </a:solidFill>
+                <a:latin typeface="Yu Gothic UI"/>
+                <a:ea typeface="Yu Gothic UI"/>
+              </a:rPr>
+              <a:t/>
+            </a:r>
+          </a:p>
+        </p:txBody>
+      </p:sp>
+      <p:sp>
+        <p:nvSpPr>
+          <p:cNvPr id="48" name="Rectangle 47"/>
+          <p:cNvSpPr/>
+          <p:nvPr/>
+        </p:nvSpPr>
+        <p:spPr>
+          <a:xfrm>
+            <a:off x="8973451" y="3306008"/>
+            <a:ext cx="1338146" cy="196786"/>
+          </a:xfrm>
+          <a:prstGeom prst="rect">
+            <a:avLst/>
+          </a:prstGeom>
+          <a:noFill/>
+          <a:ln>
+            <a:noFill/>
+          </a:ln>
+          <a:effectLst/>
+        </p:spPr>
+        <p:style>
+          <a:lnRef idx="1">
+            <a:schemeClr val="accent1"/>
+          </a:lnRef>
+          <a:fillRef idx="3">
+            <a:schemeClr val="accent1"/>
+          </a:fillRef>
+          <a:effectRef idx="2">
+            <a:schemeClr val="accent1"/>
+          </a:effectRef>
+          <a:fontRef idx="minor">
+            <a:schemeClr val="lt1"/>
+          </a:fontRef>
+        </p:style>
+        <p:txBody>
+          <a:bodyPr rtlCol="0" anchor="t" wrap="square" lIns="49196" rIns="49196" tIns="19678" bIns="19678"/>
+          <a:lstStyle/>
+          <a:p>
+            <a:pPr algn="l"/>
+            <a:r>
+              <a:rPr sz="851" b="1">
+                <a:solidFill>
+                  <a:srgbClr val="FFFFFF"/>
+                </a:solidFill>
+                <a:latin typeface="Yu Gothic UI"/>
+                <a:ea typeface="Yu Gothic UI"/>
+              </a:rPr>
+              <a:t>Compat ↓(違う所だけ)</a:t>
+            </a:r>
+          </a:p>
+        </p:txBody>
+      </p:sp>
+      <p:sp>
+        <p:nvSpPr>
+          <p:cNvPr id="49" name="Rectangle 48"/>
+          <p:cNvSpPr/>
+          <p:nvPr/>
+        </p:nvSpPr>
+        <p:spPr>
+          <a:xfrm>
+            <a:off x="10036097" y="3502794"/>
+            <a:ext cx="275500" cy="1023288"/>
+          </a:xfrm>
+          <a:prstGeom prst="rect">
+            <a:avLst/>
+          </a:prstGeom>
+          <a:solidFill>
+            <a:srgbClr val="F39A3D"/>
+          </a:solidFill>
+          <a:ln>
+            <a:noFill/>
+          </a:ln>
+          <a:effectLst/>
+        </p:spPr>
+        <p:style>
+          <a:lnRef idx="1">
+            <a:schemeClr val="accent1"/>
+          </a:lnRef>
+          <a:fillRef idx="3">
+            <a:schemeClr val="accent1"/>
+          </a:fillRef>
+          <a:effectRef idx="2">
+            <a:schemeClr val="accent1"/>
+          </a:effectRef>
+          <a:fontRef idx="minor">
+            <a:schemeClr val="lt1"/>
+          </a:fontRef>
+        </p:style>
+        <p:txBody>
+          <a:bodyPr rtlCol="0" anchor="ctr" wrap="square" lIns="49196" rIns="49196" tIns="19678" bIns="19678" vert="eaVert"/>
+          <a:lstStyle/>
+          <a:p>
+            <a:pPr algn="ctr"/>
+            <a:r>
+              <a:rPr sz="774" b="1">
+                <a:solidFill>
+                  <a:srgbClr val="FFFFFF"/>
+                </a:solidFill>
+                <a:latin typeface="Yu Gothic UI"/>
+                <a:ea typeface="Yu Gothic UI"/>
+              </a:rPr>
+              <a:t>直接</a:t>
+            </a:r>
+          </a:p>
+        </p:txBody>
+      </p:sp>
+      <p:sp>
+        <p:nvSpPr>
+          <p:cNvPr id="50" name="Rectangle 49"/>
+          <p:cNvSpPr/>
+          <p:nvPr/>
+        </p:nvSpPr>
+        <p:spPr>
+          <a:xfrm>
+            <a:off x="8973451" y="3542152"/>
+            <a:ext cx="1023288" cy="983931"/>
+          </a:xfrm>
+          <a:prstGeom prst="rect">
+            <a:avLst/>
+          </a:prstGeom>
+          <a:solidFill>
+            <a:srgbClr val="3AA357"/>
+          </a:solidFill>
+          <a:ln>
+            <a:noFill/>
+          </a:ln>
+          <a:effectLst/>
+        </p:spPr>
+        <p:style>
+          <a:lnRef idx="1">
+            <a:schemeClr val="accent1"/>
+          </a:lnRef>
+          <a:fillRef idx="3">
+            <a:schemeClr val="accent1"/>
+          </a:fillRef>
+          <a:effectRef idx="2">
+            <a:schemeClr val="accent1"/>
+          </a:effectRef>
+          <a:fontRef idx="minor">
+            <a:schemeClr val="lt1"/>
+          </a:fontRef>
+        </p:style>
+        <p:txBody>
+          <a:bodyPr rtlCol="0" anchor="t" wrap="square" lIns="49196" rIns="49196" tIns="19678" bIns="19678"/>
+          <a:lstStyle/>
+          <a:p>
+            <a:pPr algn="l"/>
+            <a:r>
+              <a:rPr sz="851" b="1">
+                <a:solidFill>
+                  <a:srgbClr val="FFFFFF"/>
+                </a:solidFill>
+                <a:latin typeface="Yu Gothic UI"/>
+                <a:ea typeface="Yu Gothic UI"/>
+              </a:rPr>
+              <a:t>FrameworkOnCore</a:t>
+            </a:r>
+          </a:p>
+          <a:p>
+            <a:pPr algn="l"/>
+            <a:r>
+              <a:rPr sz="851" b="1">
+                <a:solidFill>
+                  <a:srgbClr val="FFFFFF"/>
+                </a:solidFill>
+                <a:latin typeface="Yu Gothic UI"/>
+                <a:ea typeface="Yu Gothic UI"/>
+              </a:rPr>
+              <a:t>.Compat</a:t>
             </a:r>
           </a:p>
         </p:txBody>
@@ -16988,7 +16988,7 @@
         </p:nvSpPr>
         <p:spPr>
           <a:xfrm>
-            <a:off x="9032487" y="4093153"/>
+            <a:off x="9032487" y="3896367"/>
             <a:ext cx="905216" cy="167268"/>
           </a:xfrm>
           <a:prstGeom prst="roundRect">
@@ -17031,7 +17031,7 @@
                 <a:latin typeface="Yu Gothic UI"/>
                 <a:ea typeface="Yu Gothic UI"/>
               </a:rPr>
-              <a:t>ファイル・VB</a:t>
+              <a:t>数値・カルチャ</a:t>
             </a:r>
           </a:p>
         </p:txBody>
@@ -17044,7 +17044,7 @@
         </p:nvSpPr>
         <p:spPr>
           <a:xfrm>
-            <a:off x="9032487" y="4289939"/>
+            <a:off x="9032487" y="4093153"/>
             <a:ext cx="905216" cy="167268"/>
           </a:xfrm>
           <a:prstGeom prst="roundRect">
@@ -17087,75 +17087,21 @@
                 <a:latin typeface="Yu Gothic UI"/>
                 <a:ea typeface="Yu Gothic UI"/>
               </a:rPr>
-              <a:t>削除された型</a:t>
-            </a:r>
-          </a:p>
-        </p:txBody>
-      </p:sp>
-      <p:sp>
-        <p:nvSpPr>
-          <p:cNvPr id="53" name="Rectangle 52"/>
-          <p:cNvSpPr/>
-          <p:nvPr/>
-        </p:nvSpPr>
-        <p:spPr>
-          <a:xfrm>
-            <a:off x="1259431" y="2125291"/>
-            <a:ext cx="6100373" cy="826502"/>
-          </a:xfrm>
-          <a:prstGeom prst="rect">
-            <a:avLst/>
-          </a:prstGeom>
-          <a:solidFill>
-            <a:srgbClr val="C8102E"/>
-          </a:solidFill>
-          <a:ln>
-            <a:noFill/>
-          </a:ln>
-          <a:effectLst/>
-        </p:spPr>
-        <p:style>
-          <a:lnRef idx="1">
-            <a:schemeClr val="accent1"/>
-          </a:lnRef>
-          <a:fillRef idx="3">
-            <a:schemeClr val="accent1"/>
-          </a:fillRef>
-          <a:effectRef idx="2">
-            <a:schemeClr val="accent1"/>
-          </a:effectRef>
-          <a:fontRef idx="minor">
-            <a:schemeClr val="lt1"/>
-          </a:fontRef>
-        </p:style>
-        <p:txBody>
-          <a:bodyPr rtlCol="0" anchor="t" wrap="square" lIns="49196" rIns="49196" tIns="19678" bIns="19678"/>
-          <a:lstStyle/>
-          <a:p>
-            <a:pPr algn="l"/>
-            <a:r>
-              <a:rPr sz="929" b="1">
-                <a:solidFill>
-                  <a:srgbClr val="FFFFFF"/>
-                </a:solidFill>
-                <a:latin typeface="Yu Gothic UI"/>
-                <a:ea typeface="Yu Gothic UI"/>
-              </a:rPr>
-              <a:t>FrameworkOnCore の System.Web のコア ― 全種類で共通(referencesource の移植)</a:t>
-            </a:r>
-          </a:p>
-        </p:txBody>
-      </p:sp>
-      <p:sp>
-        <p:nvSpPr>
-          <p:cNvPr id="54" name="Rounded Rectangle 53"/>
-          <p:cNvSpPr/>
-          <p:nvPr/>
-        </p:nvSpPr>
-        <p:spPr>
-          <a:xfrm>
-            <a:off x="1318467" y="2341756"/>
-            <a:ext cx="1693591" cy="167268"/>
+              <a:t>ファイル・VB</a:t>
+            </a:r>
+          </a:p>
+        </p:txBody>
+      </p:sp>
+      <p:sp>
+        <p:nvSpPr>
+          <p:cNvPr id="53" name="Rounded Rectangle 52"/>
+          <p:cNvSpPr/>
+          <p:nvPr/>
+        </p:nvSpPr>
+        <p:spPr>
+          <a:xfrm>
+            <a:off x="9032487" y="4289939"/>
+            <a:ext cx="905216" cy="167268"/>
           </a:xfrm>
           <a:prstGeom prst="roundRect">
             <a:avLst>
@@ -17163,7 +17109,7 @@
             </a:avLst>
           </a:prstGeom>
           <a:solidFill>
-            <a:srgbClr val="F8E2E6"/>
+            <a:srgbClr val="E7F4EB"/>
           </a:solidFill>
           <a:ln>
             <a:noFill/>
@@ -17197,7 +17143,61 @@
                 <a:latin typeface="Yu Gothic UI"/>
                 <a:ea typeface="Yu Gothic UI"/>
               </a:rPr>
-              <a:t>HttpApplication・パイプライン</a:t>
+              <a:t>削除された型</a:t>
+            </a:r>
+          </a:p>
+        </p:txBody>
+      </p:sp>
+      <p:sp>
+        <p:nvSpPr>
+          <p:cNvPr id="54" name="Rectangle 53"/>
+          <p:cNvSpPr/>
+          <p:nvPr/>
+        </p:nvSpPr>
+        <p:spPr>
+          <a:xfrm>
+            <a:off x="1259431" y="2125291"/>
+            <a:ext cx="6100373" cy="826502"/>
+          </a:xfrm>
+          <a:prstGeom prst="rect">
+            <a:avLst/>
+          </a:prstGeom>
+          <a:solidFill>
+            <a:srgbClr val="C8102E"/>
+          </a:solidFill>
+          <a:ln>
+            <a:noFill/>
+          </a:ln>
+          <a:effectLst/>
+        </p:spPr>
+        <p:style>
+          <a:lnRef idx="1">
+            <a:schemeClr val="accent1"/>
+          </a:lnRef>
+          <a:fillRef idx="3">
+            <a:schemeClr val="accent1"/>
+          </a:fillRef>
+          <a:effectRef idx="2">
+            <a:schemeClr val="accent1"/>
+          </a:effectRef>
+          <a:fontRef idx="minor">
+            <a:schemeClr val="lt1"/>
+          </a:fontRef>
+        </p:style>
+        <p:txBody>
+          <a:bodyPr rtlCol="0" anchor="t" wrap="square" lIns="49196" rIns="49196" tIns="19678" bIns="19678"/>
+          <a:lstStyle/>
+          <a:p>
+            <a:pPr algn="l"/>
+            <a:r>
+              <a:rPr sz="929" b="1">
+                <a:solidFill>
+                  <a:srgbClr val="FFFFFF"/>
+                </a:solidFill>
+                <a:latin typeface="Yu Gothic UI"/>
+                <a:ea typeface="Yu Gothic UI"/>
+              </a:rPr>
+              <a:t>FrameworkOnCore の System.Web のコア ― 全種類で共通(referencesource の移植)</a:t>
             </a:r>
           </a:p>
         </p:txBody>
@@ -17210,8 +17210,8 @@
         </p:nvSpPr>
         <p:spPr>
           <a:xfrm>
-            <a:off x="3041577" y="2341756"/>
-            <a:ext cx="1538622" cy="167268"/>
+            <a:off x="1318467" y="2341756"/>
+            <a:ext cx="1693591" cy="167268"/>
           </a:xfrm>
           <a:prstGeom prst="roundRect">
             <a:avLst>
@@ -17253,7 +17253,7 @@
                 <a:latin typeface="Yu Gothic UI"/>
                 <a:ea typeface="Yu Gothic UI"/>
               </a:rPr>
-              <a:t>HTTP モジュール・ハンドラー</a:t>
+              <a:t>HttpApplication・パイプライン</a:t>
             </a:r>
           </a:p>
         </p:txBody>
@@ -17266,8 +17266,8 @@
         </p:nvSpPr>
         <p:spPr>
           <a:xfrm>
-            <a:off x="4609717" y="2341756"/>
-            <a:ext cx="1874388" cy="167268"/>
+            <a:off x="3041577" y="2341756"/>
+            <a:ext cx="1538622" cy="167268"/>
           </a:xfrm>
           <a:prstGeom prst="roundRect">
             <a:avLst>
@@ -17309,7 +17309,7 @@
                 <a:latin typeface="Yu Gothic UI"/>
                 <a:ea typeface="Yu Gothic UI"/>
               </a:rPr>
-              <a:t>ルーティング(System.Web.Routing)</a:t>
+              <a:t>HTTP モジュール・ハンドラー</a:t>
             </a:r>
           </a:p>
         </p:txBody>
@@ -17322,8 +17322,8 @@
         </p:nvSpPr>
         <p:spPr>
           <a:xfrm>
-            <a:off x="1318467" y="2538542"/>
-            <a:ext cx="1254512" cy="167268"/>
+            <a:off x="4609717" y="2341756"/>
+            <a:ext cx="1874388" cy="167268"/>
           </a:xfrm>
           <a:prstGeom prst="roundRect">
             <a:avLst>
@@ -17365,7 +17365,7 @@
                 <a:latin typeface="Yu Gothic UI"/>
                 <a:ea typeface="Yu Gothic UI"/>
               </a:rPr>
-              <a:t>セッション・キャッシュ</a:t>
+              <a:t>ルーティング(System.Web.Routing)</a:t>
             </a:r>
           </a:p>
         </p:txBody>
@@ -17378,8 +17378,8 @@
         </p:nvSpPr>
         <p:spPr>
           <a:xfrm>
-            <a:off x="2602497" y="2538542"/>
-            <a:ext cx="1977701" cy="167268"/>
+            <a:off x="1318467" y="2538542"/>
+            <a:ext cx="1254512" cy="167268"/>
           </a:xfrm>
           <a:prstGeom prst="roundRect">
             <a:avLst>
@@ -17421,7 +17421,7 @@
                 <a:latin typeface="Yu Gothic UI"/>
                 <a:ea typeface="Yu Gothic UI"/>
               </a:rPr>
-              <a:t>フォーム認証・メンバーシップ・ロール</a:t>
+              <a:t>セッション・キャッシュ</a:t>
             </a:r>
           </a:p>
         </p:txBody>
@@ -17434,8 +17434,8 @@
         </p:nvSpPr>
         <p:spPr>
           <a:xfrm>
-            <a:off x="4609717" y="2538542"/>
-            <a:ext cx="1362990" cy="167268"/>
+            <a:off x="2602497" y="2538542"/>
+            <a:ext cx="1977701" cy="167268"/>
           </a:xfrm>
           <a:prstGeom prst="roundRect">
             <a:avLst>
@@ -17477,7 +17477,7 @@
                 <a:latin typeface="Yu Gothic UI"/>
                 <a:ea typeface="Yu Gothic UI"/>
               </a:rPr>
-              <a:t>web.config のセクション</a:t>
+              <a:t>フォーム認証・メンバーシップ・ロール</a:t>
             </a:r>
           </a:p>
         </p:txBody>
@@ -17490,8 +17490,8 @@
         </p:nvSpPr>
         <p:spPr>
           <a:xfrm>
-            <a:off x="1318467" y="2735328"/>
-            <a:ext cx="2153333" cy="167268"/>
+            <a:off x="4609717" y="2538542"/>
+            <a:ext cx="1362990" cy="167268"/>
           </a:xfrm>
           <a:prstGeom prst="roundRect">
             <a:avLst>
@@ -17533,75 +17533,21 @@
                 <a:latin typeface="Yu Gothic UI"/>
                 <a:ea typeface="Yu Gothic UI"/>
               </a:rPr>
-              <a:t>Compilers(実行時コンパイル + 書き換え)</a:t>
-            </a:r>
-          </a:p>
-        </p:txBody>
-      </p:sp>
-      <p:sp>
-        <p:nvSpPr>
-          <p:cNvPr id="61" name="Rectangle 60"/>
-          <p:cNvSpPr/>
-          <p:nvPr/>
-        </p:nvSpPr>
-        <p:spPr>
-          <a:xfrm>
-            <a:off x="7399162" y="2125291"/>
-            <a:ext cx="1200395" cy="826502"/>
-          </a:xfrm>
-          <a:prstGeom prst="rect">
-            <a:avLst/>
-          </a:prstGeom>
-          <a:solidFill>
-            <a:srgbClr val="E05A47"/>
-          </a:solidFill>
-          <a:ln>
-            <a:noFill/>
-          </a:ln>
-          <a:effectLst/>
-        </p:spPr>
-        <p:style>
-          <a:lnRef idx="1">
-            <a:schemeClr val="accent1"/>
-          </a:lnRef>
-          <a:fillRef idx="3">
-            <a:schemeClr val="accent1"/>
-          </a:fillRef>
-          <a:effectRef idx="2">
-            <a:schemeClr val="accent1"/>
-          </a:effectRef>
-          <a:fontRef idx="minor">
-            <a:schemeClr val="lt1"/>
-          </a:fontRef>
-        </p:style>
-        <p:txBody>
-          <a:bodyPr rtlCol="0" anchor="t" wrap="square" lIns="49196" rIns="49196" tIns="19678" bIns="19678"/>
-          <a:lstStyle/>
-          <a:p>
-            <a:pPr algn="l"/>
-            <a:r>
-              <a:rPr sz="929" b="1">
-                <a:solidFill>
-                  <a:srgbClr val="FFFFFF"/>
-                </a:solidFill>
-                <a:latin typeface="Yu Gothic UI"/>
-                <a:ea typeface="Yu Gothic UI"/>
-              </a:rPr>
-              <a:t>アプリのデータ</a:t>
-            </a:r>
-          </a:p>
-        </p:txBody>
-      </p:sp>
-      <p:sp>
-        <p:nvSpPr>
-          <p:cNvPr id="62" name="Rounded Rectangle 61"/>
-          <p:cNvSpPr/>
-          <p:nvPr/>
-        </p:nvSpPr>
-        <p:spPr>
-          <a:xfrm>
-            <a:off x="7458197" y="2341756"/>
-            <a:ext cx="1082324" cy="167268"/>
+              <a:t>web.config のセクション</a:t>
+            </a:r>
+          </a:p>
+        </p:txBody>
+      </p:sp>
+      <p:sp>
+        <p:nvSpPr>
+          <p:cNvPr id="61" name="Rounded Rectangle 60"/>
+          <p:cNvSpPr/>
+          <p:nvPr/>
+        </p:nvSpPr>
+        <p:spPr>
+          <a:xfrm>
+            <a:off x="1318467" y="2735328"/>
+            <a:ext cx="2153333" cy="167268"/>
           </a:xfrm>
           <a:prstGeom prst="roundRect">
             <a:avLst>
@@ -17609,7 +17555,7 @@
             </a:avLst>
           </a:prstGeom>
           <a:solidFill>
-            <a:srgbClr val="FBEBE9"/>
+            <a:srgbClr val="F8E2E6"/>
           </a:solidFill>
           <a:ln>
             <a:noFill/>
@@ -17643,7 +17589,61 @@
                 <a:latin typeface="Yu Gothic UI"/>
                 <a:ea typeface="Yu Gothic UI"/>
               </a:rPr>
-              <a:t>EF4 → EF6</a:t>
+              <a:t>Compilers(実行時コンパイル + 書き換え)</a:t>
+            </a:r>
+          </a:p>
+        </p:txBody>
+      </p:sp>
+      <p:sp>
+        <p:nvSpPr>
+          <p:cNvPr id="62" name="Rectangle 61"/>
+          <p:cNvSpPr/>
+          <p:nvPr/>
+        </p:nvSpPr>
+        <p:spPr>
+          <a:xfrm>
+            <a:off x="7399162" y="2125291"/>
+            <a:ext cx="1200395" cy="826502"/>
+          </a:xfrm>
+          <a:prstGeom prst="rect">
+            <a:avLst/>
+          </a:prstGeom>
+          <a:solidFill>
+            <a:srgbClr val="E05A47"/>
+          </a:solidFill>
+          <a:ln>
+            <a:noFill/>
+          </a:ln>
+          <a:effectLst/>
+        </p:spPr>
+        <p:style>
+          <a:lnRef idx="1">
+            <a:schemeClr val="accent1"/>
+          </a:lnRef>
+          <a:fillRef idx="3">
+            <a:schemeClr val="accent1"/>
+          </a:fillRef>
+          <a:effectRef idx="2">
+            <a:schemeClr val="accent1"/>
+          </a:effectRef>
+          <a:fontRef idx="minor">
+            <a:schemeClr val="lt1"/>
+          </a:fontRef>
+        </p:style>
+        <p:txBody>
+          <a:bodyPr rtlCol="0" anchor="t" wrap="square" lIns="49196" rIns="49196" tIns="19678" bIns="19678"/>
+          <a:lstStyle/>
+          <a:p>
+            <a:pPr algn="l"/>
+            <a:r>
+              <a:rPr sz="929" b="1">
+                <a:solidFill>
+                  <a:srgbClr val="FFFFFF"/>
+                </a:solidFill>
+                <a:latin typeface="Yu Gothic UI"/>
+                <a:ea typeface="Yu Gothic UI"/>
+              </a:rPr>
+              <a:t>アプリのデータ</a:t>
             </a:r>
           </a:p>
         </p:txBody>
@@ -17656,7 +17656,7 @@
         </p:nvSpPr>
         <p:spPr>
           <a:xfrm>
-            <a:off x="7458197" y="2538542"/>
+            <a:off x="7458197" y="2341756"/>
             <a:ext cx="1082324" cy="167268"/>
           </a:xfrm>
           <a:prstGeom prst="roundRect">
@@ -17699,75 +17699,21 @@
                 <a:latin typeface="Yu Gothic UI"/>
                 <a:ea typeface="Yu Gothic UI"/>
               </a:rPr>
-              <a:t>LINQ to SQL(移植)</a:t>
-            </a:r>
-          </a:p>
-        </p:txBody>
-      </p:sp>
-      <p:sp>
-        <p:nvSpPr>
-          <p:cNvPr id="64" name="Rectangle 63"/>
-          <p:cNvSpPr/>
-          <p:nvPr/>
-        </p:nvSpPr>
-        <p:spPr>
-          <a:xfrm>
-            <a:off x="1259431" y="2991150"/>
-            <a:ext cx="3325687" cy="1023288"/>
-          </a:xfrm>
-          <a:prstGeom prst="rect">
-            <a:avLst/>
-          </a:prstGeom>
-          <a:solidFill>
-            <a:srgbClr val="C8102E"/>
-          </a:solidFill>
-          <a:ln>
-            <a:noFill/>
-          </a:ln>
-          <a:effectLst/>
-        </p:spPr>
-        <p:style>
-          <a:lnRef idx="1">
-            <a:schemeClr val="accent1"/>
-          </a:lnRef>
-          <a:fillRef idx="3">
-            <a:schemeClr val="accent1"/>
-          </a:fillRef>
-          <a:effectRef idx="2">
-            <a:schemeClr val="accent1"/>
-          </a:effectRef>
-          <a:fontRef idx="minor">
-            <a:schemeClr val="lt1"/>
-          </a:fontRef>
-        </p:style>
-        <p:txBody>
-          <a:bodyPr rtlCol="0" anchor="t" wrap="square" lIns="49196" rIns="49196" tIns="19678" bIns="19678"/>
-          <a:lstStyle/>
-          <a:p>
-            <a:pPr algn="l"/>
-            <a:r>
-              <a:rPr sz="929" b="1">
-                <a:solidFill>
-                  <a:srgbClr val="FFFFFF"/>
-                </a:solidFill>
-                <a:latin typeface="Yu Gothic UI"/>
-                <a:ea typeface="Yu Gothic UI"/>
-              </a:rPr>
-              <a:t>IIS 互換ミドルウェア(FrameworkOnCore。IIS と同じ順)</a:t>
-            </a:r>
-          </a:p>
-        </p:txBody>
-      </p:sp>
-      <p:sp>
-        <p:nvSpPr>
-          <p:cNvPr id="65" name="Rounded Rectangle 64"/>
-          <p:cNvSpPr/>
-          <p:nvPr/>
-        </p:nvSpPr>
-        <p:spPr>
-          <a:xfrm>
-            <a:off x="1318467" y="3207615"/>
-            <a:ext cx="551985" cy="167268"/>
+              <a:t>EF4 → EF6</a:t>
+            </a:r>
+          </a:p>
+        </p:txBody>
+      </p:sp>
+      <p:sp>
+        <p:nvSpPr>
+          <p:cNvPr id="64" name="Rounded Rectangle 63"/>
+          <p:cNvSpPr/>
+          <p:nvPr/>
+        </p:nvSpPr>
+        <p:spPr>
+          <a:xfrm>
+            <a:off x="7458197" y="2538542"/>
+            <a:ext cx="1082324" cy="167268"/>
           </a:xfrm>
           <a:prstGeom prst="roundRect">
             <a:avLst>
@@ -17775,7 +17721,7 @@
             </a:avLst>
           </a:prstGeom>
           <a:solidFill>
-            <a:srgbClr val="F8E2E6"/>
+            <a:srgbClr val="FBEBE9"/>
           </a:solidFill>
           <a:ln>
             <a:noFill/>
@@ -17809,7 +17755,61 @@
                 <a:latin typeface="Yu Gothic UI"/>
                 <a:ea typeface="Yu Gothic UI"/>
               </a:rPr>
-              <a:t>W3C ログ</a:t>
+              <a:t>LINQ to SQL(移植)</a:t>
+            </a:r>
+          </a:p>
+        </p:txBody>
+      </p:sp>
+      <p:sp>
+        <p:nvSpPr>
+          <p:cNvPr id="65" name="Rectangle 64"/>
+          <p:cNvSpPr/>
+          <p:nvPr/>
+        </p:nvSpPr>
+        <p:spPr>
+          <a:xfrm>
+            <a:off x="1259431" y="2991150"/>
+            <a:ext cx="3325687" cy="1023288"/>
+          </a:xfrm>
+          <a:prstGeom prst="rect">
+            <a:avLst/>
+          </a:prstGeom>
+          <a:solidFill>
+            <a:srgbClr val="C8102E"/>
+          </a:solidFill>
+          <a:ln>
+            <a:noFill/>
+          </a:ln>
+          <a:effectLst/>
+        </p:spPr>
+        <p:style>
+          <a:lnRef idx="1">
+            <a:schemeClr val="accent1"/>
+          </a:lnRef>
+          <a:fillRef idx="3">
+            <a:schemeClr val="accent1"/>
+          </a:fillRef>
+          <a:effectRef idx="2">
+            <a:schemeClr val="accent1"/>
+          </a:effectRef>
+          <a:fontRef idx="minor">
+            <a:schemeClr val="lt1"/>
+          </a:fontRef>
+        </p:style>
+        <p:txBody>
+          <a:bodyPr rtlCol="0" anchor="t" wrap="square" lIns="49196" rIns="49196" tIns="19678" bIns="19678"/>
+          <a:lstStyle/>
+          <a:p>
+            <a:pPr algn="l"/>
+            <a:r>
+              <a:rPr sz="929" b="1">
+                <a:solidFill>
+                  <a:srgbClr val="FFFFFF"/>
+                </a:solidFill>
+                <a:latin typeface="Yu Gothic UI"/>
+                <a:ea typeface="Yu Gothic UI"/>
+              </a:rPr>
+              <a:t>IIS 互換ミドルウェア(FrameworkOnCore。IIS と同じ順)</a:t>
             </a:r>
           </a:p>
         </p:txBody>
@@ -17822,8 +17822,8 @@
         </p:nvSpPr>
         <p:spPr>
           <a:xfrm>
-            <a:off x="1899971" y="3207615"/>
-            <a:ext cx="1590278" cy="167268"/>
+            <a:off x="1318467" y="3207615"/>
+            <a:ext cx="551985" cy="167268"/>
           </a:xfrm>
           <a:prstGeom prst="roundRect">
             <a:avLst>
@@ -17865,7 +17865,7 @@
                 <a:latin typeface="Yu Gothic UI"/>
                 <a:ea typeface="Yu Gothic UI"/>
               </a:rPr>
-              <a:t>応答ヘッダー(customHeaders)</a:t>
+              <a:t>W3C ログ</a:t>
             </a:r>
           </a:p>
         </p:txBody>
@@ -17878,8 +17878,8 @@
         </p:nvSpPr>
         <p:spPr>
           <a:xfrm>
-            <a:off x="3519767" y="3207615"/>
-            <a:ext cx="324697" cy="167268"/>
+            <a:off x="1899971" y="3207615"/>
+            <a:ext cx="1590278" cy="167268"/>
           </a:xfrm>
           <a:prstGeom prst="roundRect">
             <a:avLst>
@@ -17921,7 +17921,7 @@
                 <a:latin typeface="Yu Gothic UI"/>
                 <a:ea typeface="Yu Gothic UI"/>
               </a:rPr>
-              <a:t>圧縮</a:t>
+              <a:t>応答ヘッダー(customHeaders)</a:t>
             </a:r>
           </a:p>
         </p:txBody>
@@ -17934,8 +17934,8 @@
         </p:nvSpPr>
         <p:spPr>
           <a:xfrm>
-            <a:off x="1318467" y="3404401"/>
-            <a:ext cx="1476634" cy="167268"/>
+            <a:off x="3519767" y="3207615"/>
+            <a:ext cx="324697" cy="167268"/>
           </a:xfrm>
           <a:prstGeom prst="roundRect">
             <a:avLst>
@@ -17977,7 +17977,7 @@
                 <a:latin typeface="Yu Gothic UI"/>
                 <a:ea typeface="Yu Gothic UI"/>
               </a:rPr>
-              <a:t>エラー ページ(httpErrors)</a:t>
+              <a:t>圧縮</a:t>
             </a:r>
           </a:p>
         </p:txBody>
@@ -17990,8 +17990,8 @@
         </p:nvSpPr>
         <p:spPr>
           <a:xfrm>
-            <a:off x="2824620" y="3404401"/>
-            <a:ext cx="743113" cy="167268"/>
+            <a:off x="1318467" y="3404401"/>
+            <a:ext cx="1476634" cy="167268"/>
           </a:xfrm>
           <a:prstGeom prst="roundRect">
             <a:avLst>
@@ -18033,7 +18033,7 @@
                 <a:latin typeface="Yu Gothic UI"/>
                 <a:ea typeface="Yu Gothic UI"/>
               </a:rPr>
-              <a:t>URL Rewrite</a:t>
+              <a:t>エラー ページ(httpErrors)</a:t>
             </a:r>
           </a:p>
         </p:txBody>
@@ -18046,8 +18046,8 @@
         </p:nvSpPr>
         <p:spPr>
           <a:xfrm>
-            <a:off x="3597252" y="3404401"/>
-            <a:ext cx="799936" cy="167268"/>
+            <a:off x="2824620" y="3404401"/>
+            <a:ext cx="743113" cy="167268"/>
           </a:xfrm>
           <a:prstGeom prst="roundRect">
             <a:avLst>
@@ -18089,7 +18089,7 @@
                 <a:latin typeface="Yu Gothic UI"/>
                 <a:ea typeface="Yu Gothic UI"/>
               </a:rPr>
-              <a:t>httpRedirect</a:t>
+              <a:t>URL Rewrite</a:t>
             </a:r>
           </a:p>
         </p:txBody>
@@ -18102,8 +18102,8 @@
         </p:nvSpPr>
         <p:spPr>
           <a:xfrm>
-            <a:off x="1318467" y="3601187"/>
-            <a:ext cx="2700890" cy="167268"/>
+            <a:off x="3597252" y="3404401"/>
+            <a:ext cx="799936" cy="167268"/>
           </a:xfrm>
           <a:prstGeom prst="roundRect">
             <a:avLst>
@@ -18145,7 +18145,7 @@
                 <a:latin typeface="Yu Gothic UI"/>
                 <a:ea typeface="Yu Gothic UI"/>
               </a:rPr>
-              <a:t>既定のドキュメント・静的ファイル・フォルダーの一覧</a:t>
+              <a:t>httpRedirect</a:t>
             </a:r>
           </a:p>
         </p:txBody>
@@ -18158,8 +18158,8 @@
         </p:nvSpPr>
         <p:spPr>
           <a:xfrm>
-            <a:off x="1318467" y="3797974"/>
-            <a:ext cx="634635" cy="167268"/>
+            <a:off x="1318467" y="3601187"/>
+            <a:ext cx="2700890" cy="167268"/>
           </a:xfrm>
           <a:prstGeom prst="roundRect">
             <a:avLst>
@@ -18201,183 +18201,21 @@
                 <a:latin typeface="Yu Gothic UI"/>
                 <a:ea typeface="Yu Gothic UI"/>
               </a:rPr>
-              <a:t>セッション</a:t>
-            </a:r>
-          </a:p>
-        </p:txBody>
-      </p:sp>
-      <p:sp>
-        <p:nvSpPr>
-          <p:cNvPr id="73" name="Rectangle 72"/>
-          <p:cNvSpPr/>
-          <p:nvPr/>
-        </p:nvSpPr>
-        <p:spPr>
-          <a:xfrm>
-            <a:off x="728109" y="2991150"/>
-            <a:ext cx="491965" cy="1062645"/>
-          </a:xfrm>
-          <a:prstGeom prst="rect">
-            <a:avLst/>
-          </a:prstGeom>
-          <a:solidFill>
-            <a:srgbClr val="3B73B9"/>
-          </a:solidFill>
-          <a:ln>
-            <a:noFill/>
-          </a:ln>
-          <a:effectLst/>
-        </p:spPr>
-        <p:style>
-          <a:lnRef idx="1">
-            <a:schemeClr val="accent1"/>
-          </a:lnRef>
-          <a:fillRef idx="3">
-            <a:schemeClr val="accent1"/>
-          </a:fillRef>
-          <a:effectRef idx="2">
-            <a:schemeClr val="accent1"/>
-          </a:effectRef>
-          <a:fontRef idx="minor">
-            <a:schemeClr val="lt1"/>
-          </a:fontRef>
-        </p:style>
-        <p:txBody>
-          <a:bodyPr rtlCol="0" anchor="t" wrap="square" lIns="49196" rIns="49196" tIns="19678" bIns="19678"/>
-          <a:lstStyle/>
-          <a:p>
-            <a:pPr algn="l"/>
-            <a:r>
-              <a:rPr sz="929" b="1">
-                <a:solidFill>
-                  <a:srgbClr val="FFFFFF"/>
-                </a:solidFill>
-                <a:latin typeface="Yu Gothic UI"/>
-                <a:ea typeface="Yu Gothic UI"/>
-              </a:rPr>
-              <a:t/>
-            </a:r>
-          </a:p>
-        </p:txBody>
-      </p:sp>
-      <p:sp>
-        <p:nvSpPr>
-          <p:cNvPr id="74" name="Rectangle 73"/>
-          <p:cNvSpPr/>
-          <p:nvPr/>
-        </p:nvSpPr>
-        <p:spPr>
-          <a:xfrm>
-            <a:off x="4624476" y="2991150"/>
-            <a:ext cx="491965" cy="1062645"/>
-          </a:xfrm>
-          <a:prstGeom prst="rect">
-            <a:avLst/>
-          </a:prstGeom>
-          <a:solidFill>
-            <a:srgbClr val="3B73B9"/>
-          </a:solidFill>
-          <a:ln>
-            <a:noFill/>
-          </a:ln>
-          <a:effectLst/>
-        </p:spPr>
-        <p:style>
-          <a:lnRef idx="1">
-            <a:schemeClr val="accent1"/>
-          </a:lnRef>
-          <a:fillRef idx="3">
-            <a:schemeClr val="accent1"/>
-          </a:fillRef>
-          <a:effectRef idx="2">
-            <a:schemeClr val="accent1"/>
-          </a:effectRef>
-          <a:fontRef idx="minor">
-            <a:schemeClr val="lt1"/>
-          </a:fontRef>
-        </p:style>
-        <p:txBody>
-          <a:bodyPr rtlCol="0" anchor="t" wrap="square" lIns="49196" rIns="49196" tIns="19678" bIns="19678"/>
-          <a:lstStyle/>
-          <a:p>
-            <a:pPr algn="l"/>
-            <a:r>
-              <a:rPr sz="929" b="1">
-                <a:solidFill>
-                  <a:srgbClr val="FFFFFF"/>
-                </a:solidFill>
-                <a:latin typeface="Yu Gothic UI"/>
-                <a:ea typeface="Yu Gothic UI"/>
-              </a:rPr>
-              <a:t/>
-            </a:r>
-          </a:p>
-        </p:txBody>
-      </p:sp>
-      <p:sp>
-        <p:nvSpPr>
-          <p:cNvPr id="75" name="Rectangle 74"/>
-          <p:cNvSpPr/>
-          <p:nvPr/>
-        </p:nvSpPr>
-        <p:spPr>
-          <a:xfrm>
-            <a:off x="728109" y="4053796"/>
-            <a:ext cx="4388332" cy="472286"/>
-          </a:xfrm>
-          <a:prstGeom prst="rect">
-            <a:avLst/>
-          </a:prstGeom>
-          <a:solidFill>
-            <a:srgbClr val="3B73B9"/>
-          </a:solidFill>
-          <a:ln>
-            <a:noFill/>
-          </a:ln>
-          <a:effectLst/>
-        </p:spPr>
-        <p:style>
-          <a:lnRef idx="1">
-            <a:schemeClr val="accent1"/>
-          </a:lnRef>
-          <a:fillRef idx="3">
-            <a:schemeClr val="accent1"/>
-          </a:fillRef>
-          <a:effectRef idx="2">
-            <a:schemeClr val="accent1"/>
-          </a:effectRef>
-          <a:fontRef idx="minor">
-            <a:schemeClr val="lt1"/>
-          </a:fontRef>
-        </p:style>
-        <p:txBody>
-          <a:bodyPr rtlCol="0" anchor="t" wrap="square" lIns="49196" rIns="49196" tIns="19678" bIns="19678"/>
-          <a:lstStyle/>
-          <a:p>
-            <a:pPr algn="l"/>
-            <a:r>
-              <a:rPr sz="929" b="1">
-                <a:solidFill>
-                  <a:srgbClr val="FFFFFF"/>
-                </a:solidFill>
-                <a:latin typeface="Yu Gothic UI"/>
-                <a:ea typeface="Yu Gothic UI"/>
-              </a:rPr>
-              <a:t>ASP.NET Core のパイプライン(Microsoft)</a:t>
-            </a:r>
-          </a:p>
-        </p:txBody>
-      </p:sp>
-      <p:sp>
-        <p:nvSpPr>
-          <p:cNvPr id="76" name="Rounded Rectangle 75"/>
-          <p:cNvSpPr/>
-          <p:nvPr/>
-        </p:nvSpPr>
-        <p:spPr>
-          <a:xfrm>
-            <a:off x="787144" y="4270261"/>
-            <a:ext cx="1466303" cy="167268"/>
+              <a:t>既定のドキュメント・静的ファイル・フォルダーの一覧</a:t>
+            </a:r>
+          </a:p>
+        </p:txBody>
+      </p:sp>
+      <p:sp>
+        <p:nvSpPr>
+          <p:cNvPr id="73" name="Rounded Rectangle 72"/>
+          <p:cNvSpPr/>
+          <p:nvPr/>
+        </p:nvSpPr>
+        <p:spPr>
+          <a:xfrm>
+            <a:off x="1318467" y="3797974"/>
+            <a:ext cx="634635" cy="167268"/>
           </a:xfrm>
           <a:prstGeom prst="roundRect">
             <a:avLst>
@@ -18385,7 +18223,7 @@
             </a:avLst>
           </a:prstGeom>
           <a:solidFill>
-            <a:srgbClr val="E7EEF7"/>
+            <a:srgbClr val="F8E2E6"/>
           </a:solidFill>
           <a:ln>
             <a:noFill/>
@@ -18419,7 +18257,169 @@
                 <a:latin typeface="Yu Gothic UI"/>
                 <a:ea typeface="Yu Gothic UI"/>
               </a:rPr>
-              <a:t>HttpContext・ミドルウェア</a:t>
+              <a:t>セッション</a:t>
+            </a:r>
+          </a:p>
+        </p:txBody>
+      </p:sp>
+      <p:sp>
+        <p:nvSpPr>
+          <p:cNvPr id="74" name="Rectangle 73"/>
+          <p:cNvSpPr/>
+          <p:nvPr/>
+        </p:nvSpPr>
+        <p:spPr>
+          <a:xfrm>
+            <a:off x="728109" y="2991150"/>
+            <a:ext cx="491965" cy="1062645"/>
+          </a:xfrm>
+          <a:prstGeom prst="rect">
+            <a:avLst/>
+          </a:prstGeom>
+          <a:solidFill>
+            <a:srgbClr val="3B73B9"/>
+          </a:solidFill>
+          <a:ln>
+            <a:noFill/>
+          </a:ln>
+          <a:effectLst/>
+        </p:spPr>
+        <p:style>
+          <a:lnRef idx="1">
+            <a:schemeClr val="accent1"/>
+          </a:lnRef>
+          <a:fillRef idx="3">
+            <a:schemeClr val="accent1"/>
+          </a:fillRef>
+          <a:effectRef idx="2">
+            <a:schemeClr val="accent1"/>
+          </a:effectRef>
+          <a:fontRef idx="minor">
+            <a:schemeClr val="lt1"/>
+          </a:fontRef>
+        </p:style>
+        <p:txBody>
+          <a:bodyPr rtlCol="0" anchor="t" wrap="square" lIns="49196" rIns="49196" tIns="19678" bIns="19678"/>
+          <a:lstStyle/>
+          <a:p>
+            <a:pPr algn="l"/>
+            <a:r>
+              <a:rPr sz="929" b="1">
+                <a:solidFill>
+                  <a:srgbClr val="FFFFFF"/>
+                </a:solidFill>
+                <a:latin typeface="Yu Gothic UI"/>
+                <a:ea typeface="Yu Gothic UI"/>
+              </a:rPr>
+              <a:t/>
+            </a:r>
+          </a:p>
+        </p:txBody>
+      </p:sp>
+      <p:sp>
+        <p:nvSpPr>
+          <p:cNvPr id="75" name="Rectangle 74"/>
+          <p:cNvSpPr/>
+          <p:nvPr/>
+        </p:nvSpPr>
+        <p:spPr>
+          <a:xfrm>
+            <a:off x="4624476" y="2991150"/>
+            <a:ext cx="491965" cy="1062645"/>
+          </a:xfrm>
+          <a:prstGeom prst="rect">
+            <a:avLst/>
+          </a:prstGeom>
+          <a:solidFill>
+            <a:srgbClr val="3B73B9"/>
+          </a:solidFill>
+          <a:ln>
+            <a:noFill/>
+          </a:ln>
+          <a:effectLst/>
+        </p:spPr>
+        <p:style>
+          <a:lnRef idx="1">
+            <a:schemeClr val="accent1"/>
+          </a:lnRef>
+          <a:fillRef idx="3">
+            <a:schemeClr val="accent1"/>
+          </a:fillRef>
+          <a:effectRef idx="2">
+            <a:schemeClr val="accent1"/>
+          </a:effectRef>
+          <a:fontRef idx="minor">
+            <a:schemeClr val="lt1"/>
+          </a:fontRef>
+        </p:style>
+        <p:txBody>
+          <a:bodyPr rtlCol="0" anchor="t" wrap="square" lIns="49196" rIns="49196" tIns="19678" bIns="19678"/>
+          <a:lstStyle/>
+          <a:p>
+            <a:pPr algn="l"/>
+            <a:r>
+              <a:rPr sz="929" b="1">
+                <a:solidFill>
+                  <a:srgbClr val="FFFFFF"/>
+                </a:solidFill>
+                <a:latin typeface="Yu Gothic UI"/>
+                <a:ea typeface="Yu Gothic UI"/>
+              </a:rPr>
+              <a:t/>
+            </a:r>
+          </a:p>
+        </p:txBody>
+      </p:sp>
+      <p:sp>
+        <p:nvSpPr>
+          <p:cNvPr id="76" name="Rectangle 75"/>
+          <p:cNvSpPr/>
+          <p:nvPr/>
+        </p:nvSpPr>
+        <p:spPr>
+          <a:xfrm>
+            <a:off x="728109" y="4053796"/>
+            <a:ext cx="4388332" cy="472286"/>
+          </a:xfrm>
+          <a:prstGeom prst="rect">
+            <a:avLst/>
+          </a:prstGeom>
+          <a:solidFill>
+            <a:srgbClr val="3B73B9"/>
+          </a:solidFill>
+          <a:ln>
+            <a:noFill/>
+          </a:ln>
+          <a:effectLst/>
+        </p:spPr>
+        <p:style>
+          <a:lnRef idx="1">
+            <a:schemeClr val="accent1"/>
+          </a:lnRef>
+          <a:fillRef idx="3">
+            <a:schemeClr val="accent1"/>
+          </a:fillRef>
+          <a:effectRef idx="2">
+            <a:schemeClr val="accent1"/>
+          </a:effectRef>
+          <a:fontRef idx="minor">
+            <a:schemeClr val="lt1"/>
+          </a:fontRef>
+        </p:style>
+        <p:txBody>
+          <a:bodyPr rtlCol="0" anchor="t" wrap="square" lIns="49196" rIns="49196" tIns="19678" bIns="19678"/>
+          <a:lstStyle/>
+          <a:p>
+            <a:pPr algn="l"/>
+            <a:r>
+              <a:rPr sz="929" b="1">
+                <a:solidFill>
+                  <a:srgbClr val="FFFFFF"/>
+                </a:solidFill>
+                <a:latin typeface="Yu Gothic UI"/>
+                <a:ea typeface="Yu Gothic UI"/>
+              </a:rPr>
+              <a:t>ASP.NET Core のパイプライン(Microsoft)</a:t>
             </a:r>
           </a:p>
         </p:txBody>
@@ -18432,8 +18432,8 @@
         </p:nvSpPr>
         <p:spPr>
           <a:xfrm>
-            <a:off x="2282966" y="4270261"/>
-            <a:ext cx="851592" cy="167268"/>
+            <a:off x="787144" y="4270261"/>
+            <a:ext cx="1466303" cy="167268"/>
           </a:xfrm>
           <a:prstGeom prst="roundRect">
             <a:avLst>
@@ -18475,7 +18475,7 @@
                 <a:latin typeface="Yu Gothic UI"/>
                 <a:ea typeface="Yu Gothic UI"/>
               </a:rPr>
-              <a:t>構成・ログ・DI</a:t>
+              <a:t>HttpContext・ミドルウェア</a:t>
             </a:r>
           </a:p>
         </p:txBody>
@@ -18488,8 +18488,8 @@
         </p:nvSpPr>
         <p:spPr>
           <a:xfrm>
-            <a:off x="3164076" y="4270261"/>
-            <a:ext cx="1053052" cy="167268"/>
+            <a:off x="2282966" y="4270261"/>
+            <a:ext cx="851592" cy="167268"/>
           </a:xfrm>
           <a:prstGeom prst="roundRect">
             <a:avLst>
@@ -18531,75 +18531,21 @@
                 <a:latin typeface="Yu Gothic UI"/>
                 <a:ea typeface="Yu Gothic UI"/>
               </a:rPr>
-              <a:t>圧縮・URL Rewrite</a:t>
-            </a:r>
-          </a:p>
-        </p:txBody>
-      </p:sp>
-      <p:sp>
-        <p:nvSpPr>
-          <p:cNvPr id="79" name="Rectangle 78"/>
-          <p:cNvSpPr/>
-          <p:nvPr/>
-        </p:nvSpPr>
-        <p:spPr>
-          <a:xfrm>
-            <a:off x="5155799" y="2991150"/>
-            <a:ext cx="3778295" cy="1534932"/>
-          </a:xfrm>
-          <a:prstGeom prst="rect">
-            <a:avLst/>
-          </a:prstGeom>
-          <a:solidFill>
-            <a:srgbClr val="E05A47"/>
-          </a:solidFill>
-          <a:ln>
-            <a:noFill/>
-          </a:ln>
-          <a:effectLst/>
-        </p:spPr>
-        <p:style>
-          <a:lnRef idx="1">
-            <a:schemeClr val="accent1"/>
-          </a:lnRef>
-          <a:fillRef idx="3">
-            <a:schemeClr val="accent1"/>
-          </a:fillRef>
-          <a:effectRef idx="2">
-            <a:schemeClr val="accent1"/>
-          </a:effectRef>
-          <a:fontRef idx="minor">
-            <a:schemeClr val="lt1"/>
-          </a:fontRef>
-        </p:style>
-        <p:txBody>
-          <a:bodyPr rtlCol="0" anchor="t" wrap="square" lIns="49196" rIns="49196" tIns="19678" bIns="19678"/>
-          <a:lstStyle/>
-          <a:p>
-            <a:pPr algn="l"/>
-            <a:r>
-              <a:rPr sz="929" b="1">
-                <a:solidFill>
-                  <a:srgbClr val="FFFFFF"/>
-                </a:solidFill>
-                <a:latin typeface="Yu Gothic UI"/>
-                <a:ea typeface="Yu Gothic UI"/>
-              </a:rPr>
-              <a:t>ライブラリの移植 ― System.Web もアプリも使う</a:t>
-            </a:r>
-          </a:p>
-        </p:txBody>
-      </p:sp>
-      <p:sp>
-        <p:nvSpPr>
-          <p:cNvPr id="80" name="Rounded Rectangle 79"/>
-          <p:cNvSpPr/>
-          <p:nvPr/>
-        </p:nvSpPr>
-        <p:spPr>
-          <a:xfrm>
-            <a:off x="5214835" y="3207615"/>
-            <a:ext cx="949739" cy="167268"/>
+              <a:t>構成・ログ・DI</a:t>
+            </a:r>
+          </a:p>
+        </p:txBody>
+      </p:sp>
+      <p:sp>
+        <p:nvSpPr>
+          <p:cNvPr id="79" name="Rounded Rectangle 78"/>
+          <p:cNvSpPr/>
+          <p:nvPr/>
+        </p:nvSpPr>
+        <p:spPr>
+          <a:xfrm>
+            <a:off x="3164076" y="4270261"/>
+            <a:ext cx="1053052" cy="167268"/>
           </a:xfrm>
           <a:prstGeom prst="roundRect">
             <a:avLst>
@@ -18607,7 +18553,7 @@
             </a:avLst>
           </a:prstGeom>
           <a:solidFill>
-            <a:srgbClr val="FBEBE9"/>
+            <a:srgbClr val="E7EEF7"/>
           </a:solidFill>
           <a:ln>
             <a:noFill/>
@@ -18641,7 +18587,61 @@
                 <a:latin typeface="Yu Gothic UI"/>
                 <a:ea typeface="Yu Gothic UI"/>
               </a:rPr>
-              <a:t>SqlClient(移植)</a:t>
+              <a:t>圧縮・URL Rewrite</a:t>
+            </a:r>
+          </a:p>
+        </p:txBody>
+      </p:sp>
+      <p:sp>
+        <p:nvSpPr>
+          <p:cNvPr id="80" name="Rectangle 79"/>
+          <p:cNvSpPr/>
+          <p:nvPr/>
+        </p:nvSpPr>
+        <p:spPr>
+          <a:xfrm>
+            <a:off x="5155799" y="2991150"/>
+            <a:ext cx="3778295" cy="1534932"/>
+          </a:xfrm>
+          <a:prstGeom prst="rect">
+            <a:avLst/>
+          </a:prstGeom>
+          <a:solidFill>
+            <a:srgbClr val="E05A47"/>
+          </a:solidFill>
+          <a:ln>
+            <a:noFill/>
+          </a:ln>
+          <a:effectLst/>
+        </p:spPr>
+        <p:style>
+          <a:lnRef idx="1">
+            <a:schemeClr val="accent1"/>
+          </a:lnRef>
+          <a:fillRef idx="3">
+            <a:schemeClr val="accent1"/>
+          </a:fillRef>
+          <a:effectRef idx="2">
+            <a:schemeClr val="accent1"/>
+          </a:effectRef>
+          <a:fontRef idx="minor">
+            <a:schemeClr val="lt1"/>
+          </a:fontRef>
+        </p:style>
+        <p:txBody>
+          <a:bodyPr rtlCol="0" anchor="t" wrap="square" lIns="49196" rIns="49196" tIns="19678" bIns="19678"/>
+          <a:lstStyle/>
+          <a:p>
+            <a:pPr algn="l"/>
+            <a:r>
+              <a:rPr sz="929" b="1">
+                <a:solidFill>
+                  <a:srgbClr val="FFFFFF"/>
+                </a:solidFill>
+                <a:latin typeface="Yu Gothic UI"/>
+                <a:ea typeface="Yu Gothic UI"/>
+              </a:rPr>
+              <a:t>ライブラリの移植 ― System.Web もアプリも使う</a:t>
             </a:r>
           </a:p>
         </p:txBody>
@@ -18654,8 +18654,8 @@
         </p:nvSpPr>
         <p:spPr>
           <a:xfrm>
-            <a:off x="6194092" y="3207615"/>
-            <a:ext cx="1311334" cy="167268"/>
+            <a:off x="5214835" y="3207615"/>
+            <a:ext cx="949739" cy="167268"/>
           </a:xfrm>
           <a:prstGeom prst="roundRect">
             <a:avLst>
@@ -18697,7 +18697,7 @@
                 <a:latin typeface="Yu Gothic UI"/>
                 <a:ea typeface="Yu Gothic UI"/>
               </a:rPr>
-              <a:t>Drawing.Common(Linux)</a:t>
+              <a:t>SqlClient(移植)</a:t>
             </a:r>
           </a:p>
         </p:txBody>
@@ -18710,8 +18710,8 @@
         </p:nvSpPr>
         <p:spPr>
           <a:xfrm>
-            <a:off x="7534944" y="3207615"/>
-            <a:ext cx="1290671" cy="167268"/>
+            <a:off x="6194092" y="3207615"/>
+            <a:ext cx="1311334" cy="167268"/>
           </a:xfrm>
           <a:prstGeom prst="roundRect">
             <a:avLst>
@@ -18753,7 +18753,7 @@
                 <a:latin typeface="Yu Gothic UI"/>
                 <a:ea typeface="Yu Gothic UI"/>
               </a:rPr>
-              <a:t>BinaryFormatter(互換)</a:t>
+              <a:t>Drawing.Common(Linux)</a:t>
             </a:r>
           </a:p>
         </p:txBody>
@@ -18766,8 +18766,8 @@
         </p:nvSpPr>
         <p:spPr>
           <a:xfrm>
-            <a:off x="5214835" y="3404401"/>
-            <a:ext cx="644966" cy="167268"/>
+            <a:off x="7534944" y="3207615"/>
+            <a:ext cx="1290671" cy="167268"/>
           </a:xfrm>
           <a:prstGeom prst="roundRect">
             <a:avLst>
@@ -18809,75 +18809,21 @@
                 <a:latin typeface="Yu Gothic UI"/>
                 <a:ea typeface="Yu Gothic UI"/>
               </a:rPr>
-              <a:t>構成(移植)</a:t>
-            </a:r>
-          </a:p>
-        </p:txBody>
-      </p:sp>
-      <p:sp>
-        <p:nvSpPr>
-          <p:cNvPr id="84" name="Rectangle 83"/>
-          <p:cNvSpPr/>
-          <p:nvPr/>
-        </p:nvSpPr>
-        <p:spPr>
-          <a:xfrm>
-            <a:off x="728109" y="4565440"/>
-            <a:ext cx="9583489" cy="432929"/>
-          </a:xfrm>
-          <a:prstGeom prst="rect">
-            <a:avLst/>
-          </a:prstGeom>
-          <a:solidFill>
-            <a:srgbClr val="7B5EA7"/>
-          </a:solidFill>
-          <a:ln>
-            <a:noFill/>
-          </a:ln>
-          <a:effectLst/>
-        </p:spPr>
-        <p:style>
-          <a:lnRef idx="1">
-            <a:schemeClr val="accent1"/>
-          </a:lnRef>
-          <a:fillRef idx="3">
-            <a:schemeClr val="accent1"/>
-          </a:fillRef>
-          <a:effectRef idx="2">
-            <a:schemeClr val="accent1"/>
-          </a:effectRef>
-          <a:fontRef idx="minor">
-            <a:schemeClr val="lt1"/>
-          </a:fontRef>
-        </p:style>
-        <p:txBody>
-          <a:bodyPr rtlCol="0" anchor="t" wrap="square" lIns="49196" rIns="49196" tIns="19678" bIns="19678"/>
-          <a:lstStyle/>
-          <a:p>
-            <a:pPr algn="l"/>
-            <a:r>
-              <a:rPr sz="929" b="1">
-                <a:solidFill>
-                  <a:srgbClr val="FFFFFF"/>
-                </a:solidFill>
-                <a:latin typeface="Yu Gothic UI"/>
-                <a:ea typeface="Yu Gothic UI"/>
-              </a:rPr>
-              <a:t>.NET 10 クラスライブラリ(そのまま。Compat も、その上で動く)</a:t>
-            </a:r>
-          </a:p>
-        </p:txBody>
-      </p:sp>
-      <p:sp>
-        <p:nvSpPr>
-          <p:cNvPr id="85" name="Rounded Rectangle 84"/>
-          <p:cNvSpPr/>
-          <p:nvPr/>
-        </p:nvSpPr>
-        <p:spPr>
-          <a:xfrm>
-            <a:off x="787144" y="4781905"/>
-            <a:ext cx="743113" cy="167268"/>
+              <a:t>BinaryFormatter(互換)</a:t>
+            </a:r>
+          </a:p>
+        </p:txBody>
+      </p:sp>
+      <p:sp>
+        <p:nvSpPr>
+          <p:cNvPr id="84" name="Rounded Rectangle 83"/>
+          <p:cNvSpPr/>
+          <p:nvPr/>
+        </p:nvSpPr>
+        <p:spPr>
+          <a:xfrm>
+            <a:off x="5214835" y="3404401"/>
+            <a:ext cx="644966" cy="167268"/>
           </a:xfrm>
           <a:prstGeom prst="roundRect">
             <a:avLst>
@@ -18885,7 +18831,7 @@
             </a:avLst>
           </a:prstGeom>
           <a:solidFill>
-            <a:srgbClr val="EFECF4"/>
+            <a:srgbClr val="FBEBE9"/>
           </a:solidFill>
           <a:ln>
             <a:noFill/>
@@ -18919,7 +18865,61 @@
                 <a:latin typeface="Yu Gothic UI"/>
                 <a:ea typeface="Yu Gothic UI"/>
               </a:rPr>
-              <a:t>System.Data</a:t>
+              <a:t>構成(移植)</a:t>
+            </a:r>
+          </a:p>
+        </p:txBody>
+      </p:sp>
+      <p:sp>
+        <p:nvSpPr>
+          <p:cNvPr id="85" name="Rectangle 84"/>
+          <p:cNvSpPr/>
+          <p:nvPr/>
+        </p:nvSpPr>
+        <p:spPr>
+          <a:xfrm>
+            <a:off x="728109" y="4565440"/>
+            <a:ext cx="9583489" cy="432929"/>
+          </a:xfrm>
+          <a:prstGeom prst="rect">
+            <a:avLst/>
+          </a:prstGeom>
+          <a:solidFill>
+            <a:srgbClr val="7B5EA7"/>
+          </a:solidFill>
+          <a:ln>
+            <a:noFill/>
+          </a:ln>
+          <a:effectLst/>
+        </p:spPr>
+        <p:style>
+          <a:lnRef idx="1">
+            <a:schemeClr val="accent1"/>
+          </a:lnRef>
+          <a:fillRef idx="3">
+            <a:schemeClr val="accent1"/>
+          </a:fillRef>
+          <a:effectRef idx="2">
+            <a:schemeClr val="accent1"/>
+          </a:effectRef>
+          <a:fontRef idx="minor">
+            <a:schemeClr val="lt1"/>
+          </a:fontRef>
+        </p:style>
+        <p:txBody>
+          <a:bodyPr rtlCol="0" anchor="t" wrap="square" lIns="49196" rIns="49196" tIns="19678" bIns="19678"/>
+          <a:lstStyle/>
+          <a:p>
+            <a:pPr algn="l"/>
+            <a:r>
+              <a:rPr sz="929" b="1">
+                <a:solidFill>
+                  <a:srgbClr val="FFFFFF"/>
+                </a:solidFill>
+                <a:latin typeface="Yu Gothic UI"/>
+                <a:ea typeface="Yu Gothic UI"/>
+              </a:rPr>
+              <a:t>.NET 10 クラスライブラリ(そのまま。Compat も、その上で動く)</a:t>
             </a:r>
           </a:p>
         </p:txBody>
@@ -18932,8 +18932,8 @@
         </p:nvSpPr>
         <p:spPr>
           <a:xfrm>
-            <a:off x="1559776" y="4781905"/>
-            <a:ext cx="686291" cy="167268"/>
+            <a:off x="787144" y="4781905"/>
+            <a:ext cx="743113" cy="167268"/>
           </a:xfrm>
           <a:prstGeom prst="roundRect">
             <a:avLst>
@@ -18975,7 +18975,7 @@
                 <a:latin typeface="Yu Gothic UI"/>
                 <a:ea typeface="Yu Gothic UI"/>
               </a:rPr>
-              <a:t>System.Xml</a:t>
+              <a:t>System.Data</a:t>
             </a:r>
           </a:p>
         </p:txBody>
@@ -18988,8 +18988,8 @@
         </p:nvSpPr>
         <p:spPr>
           <a:xfrm>
-            <a:off x="2275586" y="4781905"/>
-            <a:ext cx="1027224" cy="167268"/>
+            <a:off x="1559776" y="4781905"/>
+            <a:ext cx="686291" cy="167268"/>
           </a:xfrm>
           <a:prstGeom prst="roundRect">
             <a:avLst>
@@ -19031,7 +19031,7 @@
                 <a:latin typeface="Yu Gothic UI"/>
                 <a:ea typeface="Yu Gothic UI"/>
               </a:rPr>
-              <a:t>System.Text.Json</a:t>
+              <a:t>System.Xml</a:t>
             </a:r>
           </a:p>
         </p:txBody>
@@ -19044,8 +19044,8 @@
         </p:nvSpPr>
         <p:spPr>
           <a:xfrm>
-            <a:off x="3332328" y="4781905"/>
-            <a:ext cx="970402" cy="167268"/>
+            <a:off x="2275586" y="4781905"/>
+            <a:ext cx="1027224" cy="167268"/>
           </a:xfrm>
           <a:prstGeom prst="roundRect">
             <a:avLst>
@@ -19087,7 +19087,7 @@
                 <a:latin typeface="Yu Gothic UI"/>
                 <a:ea typeface="Yu Gothic UI"/>
               </a:rPr>
-              <a:t>System.Net.Http</a:t>
+              <a:t>System.Text.Json</a:t>
             </a:r>
           </a:p>
         </p:txBody>
@@ -19100,8 +19100,8 @@
         </p:nvSpPr>
         <p:spPr>
           <a:xfrm>
-            <a:off x="4332248" y="4781905"/>
-            <a:ext cx="1652266" cy="167268"/>
+            <a:off x="3332328" y="4781905"/>
+            <a:ext cx="970402" cy="167268"/>
           </a:xfrm>
           <a:prstGeom prst="roundRect">
             <a:avLst>
@@ -19143,6 +19143,62 @@
                 <a:latin typeface="Yu Gothic UI"/>
                 <a:ea typeface="Yu Gothic UI"/>
               </a:rPr>
+              <a:t>System.Net.Http</a:t>
+            </a:r>
+          </a:p>
+        </p:txBody>
+      </p:sp>
+      <p:sp>
+        <p:nvSpPr>
+          <p:cNvPr id="90" name="Rounded Rectangle 89"/>
+          <p:cNvSpPr/>
+          <p:nvPr/>
+        </p:nvSpPr>
+        <p:spPr>
+          <a:xfrm>
+            <a:off x="4332248" y="4781905"/>
+            <a:ext cx="1652266" cy="167268"/>
+          </a:xfrm>
+          <a:prstGeom prst="roundRect">
+            <a:avLst>
+              <a:gd name="adj" fmla="val 18000"/>
+            </a:avLst>
+          </a:prstGeom>
+          <a:solidFill>
+            <a:srgbClr val="EFECF4"/>
+          </a:solidFill>
+          <a:ln>
+            <a:noFill/>
+          </a:ln>
+          <a:effectLst/>
+        </p:spPr>
+        <p:style>
+          <a:lnRef idx="1">
+            <a:schemeClr val="accent1"/>
+          </a:lnRef>
+          <a:fillRef idx="3">
+            <a:schemeClr val="accent1"/>
+          </a:fillRef>
+          <a:effectRef idx="2">
+            <a:schemeClr val="accent1"/>
+          </a:effectRef>
+          <a:fontRef idx="minor">
+            <a:schemeClr val="lt1"/>
+          </a:fontRef>
+        </p:style>
+        <p:txBody>
+          <a:bodyPr rtlCol="0" anchor="ctr" wrap="none" lIns="49196" rIns="49196" tIns="19678" bIns="19678"/>
+          <a:lstStyle/>
+          <a:p>
+            <a:pPr algn="l"/>
+            <a:r>
+              <a:rPr sz="812" b="1">
+                <a:solidFill>
+                  <a:srgbClr val="333333"/>
+                </a:solidFill>
+                <a:latin typeface="Yu Gothic UI"/>
+                <a:ea typeface="Yu Gothic UI"/>
+              </a:rPr>
               <a:t>System.Diagnostics.EventLog</a:t>
             </a:r>
           </a:p>
@@ -19150,7 +19206,7 @@
       </p:sp>
       <p:sp>
         <p:nvSpPr>
-          <p:cNvPr id="90" name="Rectangle 89"/>
+          <p:cNvPr id="91" name="Rectangle 90"/>
           <p:cNvSpPr/>
           <p:nvPr/>
         </p:nvSpPr>
@@ -19206,7 +19262,7 @@
       </p:sp>
       <p:sp>
         <p:nvSpPr>
-          <p:cNvPr id="91" name="Rounded Rectangle 90"/>
+          <p:cNvPr id="92" name="Rounded Rectangle 91"/>
           <p:cNvSpPr/>
           <p:nvPr/>
         </p:nvSpPr>
@@ -19262,7 +19318,7 @@
       </p:sp>
       <p:sp>
         <p:nvSpPr>
-          <p:cNvPr id="92" name="Rounded Rectangle 91"/>
+          <p:cNvPr id="93" name="Rounded Rectangle 92"/>
           <p:cNvSpPr/>
           <p:nvPr/>
         </p:nvSpPr>
@@ -19318,7 +19374,7 @@
       </p:sp>
       <p:sp>
         <p:nvSpPr>
-          <p:cNvPr id="93" name="Rounded Rectangle 92"/>
+          <p:cNvPr id="94" name="Rounded Rectangle 93"/>
           <p:cNvSpPr/>
           <p:nvPr/>
         </p:nvSpPr>
@@ -19376,7 +19432,7 @@
       </p:sp>
       <p:sp>
         <p:nvSpPr>
-          <p:cNvPr id="94" name="Rectangle 93"/>
+          <p:cNvPr id="95" name="Rectangle 94"/>
           <p:cNvSpPr/>
           <p:nvPr/>
         </p:nvSpPr>
@@ -19430,7 +19486,7 @@
       </p:sp>
       <p:sp>
         <p:nvSpPr>
-          <p:cNvPr id="95" name="Rounded Rectangle 94"/>
+          <p:cNvPr id="96" name="Rounded Rectangle 95"/>
           <p:cNvSpPr/>
           <p:nvPr/>
         </p:nvSpPr>
@@ -19486,7 +19542,7 @@
       </p:sp>
       <p:sp>
         <p:nvSpPr>
-          <p:cNvPr id="96" name="Rounded Rectangle 95"/>
+          <p:cNvPr id="97" name="Rounded Rectangle 96"/>
           <p:cNvSpPr/>
           <p:nvPr/>
         </p:nvSpPr>
@@ -19542,7 +19598,7 @@
       </p:sp>
       <p:sp>
         <p:nvSpPr>
-          <p:cNvPr id="97" name="Rounded Rectangle 96"/>
+          <p:cNvPr id="98" name="Rounded Rectangle 97"/>
           <p:cNvSpPr/>
           <p:nvPr/>
         </p:nvSpPr>
@@ -19598,7 +19654,7 @@
       </p:sp>
       <p:sp>
         <p:nvSpPr>
-          <p:cNvPr id="98" name="Rounded Rectangle 97"/>
+          <p:cNvPr id="99" name="Rounded Rectangle 98"/>
           <p:cNvSpPr/>
           <p:nvPr/>
         </p:nvSpPr>
@@ -19654,7 +19710,7 @@
       </p:sp>
       <p:sp>
         <p:nvSpPr>
-          <p:cNvPr id="99" name="Rectangle 98"/>
+          <p:cNvPr id="100" name="Rectangle 99"/>
           <p:cNvSpPr/>
           <p:nvPr/>
         </p:nvSpPr>
@@ -19708,7 +19764,7 @@
       </p:sp>
       <p:sp>
         <p:nvSpPr>
-          <p:cNvPr id="100" name="Rounded Rectangle 99"/>
+          <p:cNvPr id="101" name="Rounded Rectangle 100"/>
           <p:cNvSpPr/>
           <p:nvPr/>
         </p:nvSpPr>
@@ -19764,7 +19820,7 @@
       </p:sp>
       <p:sp>
         <p:nvSpPr>
-          <p:cNvPr id="101" name="Rounded Rectangle 100"/>
+          <p:cNvPr id="102" name="Rounded Rectangle 101"/>
           <p:cNvSpPr/>
           <p:nvPr/>
         </p:nvSpPr>
@@ -19820,7 +19876,7 @@
       </p:sp>
       <p:sp>
         <p:nvSpPr>
-          <p:cNvPr id="102" name="Rounded Rectangle 101"/>
+          <p:cNvPr id="103" name="Rounded Rectangle 102"/>
           <p:cNvSpPr/>
           <p:nvPr/>
         </p:nvSpPr>
@@ -19876,7 +19932,7 @@
       </p:sp>
       <p:sp>
         <p:nvSpPr>
-          <p:cNvPr id="103" name="Rounded Rectangle 102"/>
+          <p:cNvPr id="104" name="Rounded Rectangle 103"/>
           <p:cNvSpPr/>
           <p:nvPr/>
         </p:nvSpPr>
@@ -19932,7 +19988,7 @@
       </p:sp>
       <p:sp>
         <p:nvSpPr>
-          <p:cNvPr id="104" name="Rounded Rectangle 103"/>
+          <p:cNvPr id="105" name="Rounded Rectangle 104"/>
           <p:cNvSpPr/>
           <p:nvPr/>
         </p:nvSpPr>
@@ -19988,7 +20044,7 @@
       </p:sp>
       <p:sp>
         <p:nvSpPr>
-          <p:cNvPr id="105" name="Rectangle 104"/>
+          <p:cNvPr id="106" name="Rectangle 105"/>
           <p:cNvSpPr/>
           <p:nvPr/>
         </p:nvSpPr>
@@ -20042,7 +20098,7 @@
       </p:sp>
       <p:sp>
         <p:nvSpPr>
-          <p:cNvPr id="106" name="Rectangle 105"/>
+          <p:cNvPr id="107" name="Rectangle 106"/>
           <p:cNvSpPr/>
           <p:nvPr/>
         </p:nvSpPr>
@@ -20096,7 +20152,7 @@
       </p:sp>
       <p:sp>
         <p:nvSpPr>
-          <p:cNvPr id="107" name="Rectangle 106"/>
+          <p:cNvPr id="108" name="Rectangle 107"/>
           <p:cNvSpPr/>
           <p:nvPr/>
         </p:nvSpPr>
@@ -20150,7 +20206,7 @@
       </p:sp>
       <p:sp>
         <p:nvSpPr>
-          <p:cNvPr id="108" name="Rectangle 107"/>
+          <p:cNvPr id="109" name="Rectangle 108"/>
           <p:cNvSpPr/>
           <p:nvPr/>
         </p:nvSpPr>
@@ -20219,7 +20275,7 @@
       </p:sp>
       <p:sp>
         <p:nvSpPr>
-          <p:cNvPr id="109" name="Rectangle 108"/>
+          <p:cNvPr id="110" name="Rectangle 109"/>
           <p:cNvSpPr/>
           <p:nvPr/>
         </p:nvSpPr>
@@ -20273,7 +20329,7 @@
       </p:sp>
       <p:sp>
         <p:nvSpPr>
-          <p:cNvPr id="110" name="Rectangle 109"/>
+          <p:cNvPr id="111" name="Rectangle 110"/>
           <p:cNvSpPr/>
           <p:nvPr/>
         </p:nvSpPr>
@@ -20327,7 +20383,7 @@
       </p:sp>
       <p:sp>
         <p:nvSpPr>
-          <p:cNvPr id="111" name="Rounded Rectangle 110"/>
+          <p:cNvPr id="112" name="Rounded Rectangle 111"/>
           <p:cNvSpPr/>
           <p:nvPr/>
         </p:nvSpPr>
@@ -20383,7 +20439,7 @@
       </p:sp>
       <p:sp>
         <p:nvSpPr>
-          <p:cNvPr id="112" name="Rounded Rectangle 111"/>
+          <p:cNvPr id="113" name="Rounded Rectangle 112"/>
           <p:cNvSpPr/>
           <p:nvPr/>
         </p:nvSpPr>
@@ -20439,7 +20495,7 @@
       </p:sp>
       <p:sp>
         <p:nvSpPr>
-          <p:cNvPr id="113" name="Rounded Rectangle 112"/>
+          <p:cNvPr id="114" name="Rounded Rectangle 113"/>
           <p:cNvSpPr/>
           <p:nvPr/>
         </p:nvSpPr>
@@ -20495,7 +20551,7 @@
       </p:sp>
       <p:sp>
         <p:nvSpPr>
-          <p:cNvPr id="114" name="Rounded Rectangle 113"/>
+          <p:cNvPr id="115" name="Rounded Rectangle 114"/>
           <p:cNvSpPr/>
           <p:nvPr/>
         </p:nvSpPr>
@@ -20551,7 +20607,7 @@
       </p:sp>
       <p:sp>
         <p:nvSpPr>
-          <p:cNvPr id="115" name="Rounded Rectangle 114"/>
+          <p:cNvPr id="116" name="Rounded Rectangle 115"/>
           <p:cNvSpPr/>
           <p:nvPr/>
         </p:nvSpPr>
@@ -20607,7 +20663,7 @@
       </p:sp>
       <p:sp>
         <p:nvSpPr>
-          <p:cNvPr id="116" name="Rounded Rectangle 115"/>
+          <p:cNvPr id="117" name="Rounded Rectangle 116"/>
           <p:cNvSpPr/>
           <p:nvPr/>
         </p:nvSpPr>
@@ -20663,7 +20719,7 @@
       </p:sp>
       <p:sp>
         <p:nvSpPr>
-          <p:cNvPr id="117" name="Rounded Rectangle 116"/>
+          <p:cNvPr id="118" name="Rounded Rectangle 117"/>
           <p:cNvSpPr/>
           <p:nvPr/>
         </p:nvSpPr>
@@ -20719,7 +20775,7 @@
       </p:sp>
       <p:sp>
         <p:nvSpPr>
-          <p:cNvPr id="118" name="Rounded Rectangle 117"/>
+          <p:cNvPr id="119" name="Rounded Rectangle 118"/>
           <p:cNvSpPr/>
           <p:nvPr/>
         </p:nvSpPr>
@@ -20775,7 +20831,7 @@
       </p:sp>
       <p:sp>
         <p:nvSpPr>
-          <p:cNvPr id="119" name="Rectangle 118"/>
+          <p:cNvPr id="120" name="Rectangle 119"/>
           <p:cNvSpPr/>
           <p:nvPr/>
         </p:nvSpPr>
@@ -20827,7 +20883,7 @@
       </p:sp>
       <p:sp>
         <p:nvSpPr>
-          <p:cNvPr id="120" name="Rectangle 119"/>
+          <p:cNvPr id="121" name="Rectangle 120"/>
           <p:cNvSpPr/>
           <p:nvPr/>
         </p:nvSpPr>
@@ -20881,7 +20937,7 @@
       </p:sp>
       <p:sp>
         <p:nvSpPr>
-          <p:cNvPr id="121" name="Rectangle 120"/>
+          <p:cNvPr id="122" name="Rectangle 121"/>
           <p:cNvSpPr/>
           <p:nvPr/>
         </p:nvSpPr>
@@ -20933,7 +20989,7 @@
       </p:sp>
       <p:sp>
         <p:nvSpPr>
-          <p:cNvPr id="122" name="Rectangle 121"/>
+          <p:cNvPr id="123" name="Rectangle 122"/>
           <p:cNvSpPr/>
           <p:nvPr/>
         </p:nvSpPr>
@@ -20987,7 +21043,7 @@
       </p:sp>
       <p:sp>
         <p:nvSpPr>
-          <p:cNvPr id="123" name="Rectangle 122"/>
+          <p:cNvPr id="124" name="Rectangle 123"/>
           <p:cNvSpPr/>
           <p:nvPr/>
         </p:nvSpPr>
@@ -21039,7 +21095,7 @@
       </p:sp>
       <p:sp>
         <p:nvSpPr>
-          <p:cNvPr id="124" name="Rectangle 123"/>
+          <p:cNvPr id="125" name="Rectangle 124"/>
           <p:cNvSpPr/>
           <p:nvPr/>
         </p:nvSpPr>
@@ -21093,7 +21149,7 @@
       </p:sp>
       <p:sp>
         <p:nvSpPr>
-          <p:cNvPr id="125" name="Rectangle 124"/>
+          <p:cNvPr id="126" name="Rectangle 125"/>
           <p:cNvSpPr/>
           <p:nvPr/>
         </p:nvSpPr>
@@ -21145,7 +21201,7 @@
       </p:sp>
       <p:sp>
         <p:nvSpPr>
-          <p:cNvPr id="126" name="Rectangle 125"/>
+          <p:cNvPr id="127" name="Rectangle 126"/>
           <p:cNvSpPr/>
           <p:nvPr/>
         </p:nvSpPr>
@@ -21199,7 +21255,7 @@
       </p:sp>
       <p:sp>
         <p:nvSpPr>
-          <p:cNvPr id="127" name="Rectangle 126"/>
+          <p:cNvPr id="128" name="Rectangle 127"/>
           <p:cNvSpPr/>
           <p:nvPr/>
         </p:nvSpPr>
@@ -21251,7 +21307,7 @@
       </p:sp>
       <p:sp>
         <p:nvSpPr>
-          <p:cNvPr id="128" name="Rectangle 127"/>
+          <p:cNvPr id="129" name="Rectangle 128"/>
           <p:cNvSpPr/>
           <p:nvPr/>
         </p:nvSpPr>
@@ -21305,7 +21361,7 @@
       </p:sp>
       <p:sp>
         <p:nvSpPr>
-          <p:cNvPr id="129" name="Rectangle 128"/>
+          <p:cNvPr id="130" name="Rectangle 129"/>
           <p:cNvSpPr/>
           <p:nvPr/>
         </p:nvSpPr>
@@ -21357,7 +21413,7 @@
       </p:sp>
       <p:sp>
         <p:nvSpPr>
-          <p:cNvPr id="130" name="Rectangle 129"/>
+          <p:cNvPr id="131" name="Rectangle 130"/>
           <p:cNvSpPr/>
           <p:nvPr/>
         </p:nvSpPr>
@@ -21411,7 +21467,7 @@
       </p:sp>
       <p:sp>
         <p:nvSpPr>
-          <p:cNvPr id="131" name="Rectangle 130"/>
+          <p:cNvPr id="132" name="Rectangle 131"/>
           <p:cNvSpPr/>
           <p:nvPr/>
         </p:nvSpPr>
@@ -21463,7 +21519,7 @@
       </p:sp>
       <p:sp>
         <p:nvSpPr>
-          <p:cNvPr id="132" name="Rectangle 131"/>
+          <p:cNvPr id="133" name="Rectangle 132"/>
           <p:cNvSpPr/>
           <p:nvPr/>
         </p:nvSpPr>
@@ -21517,7 +21573,7 @@
       </p:sp>
       <p:sp>
         <p:nvSpPr>
-          <p:cNvPr id="133" name="Rectangle 132"/>
+          <p:cNvPr id="134" name="Rectangle 133"/>
           <p:cNvSpPr/>
           <p:nvPr/>
         </p:nvSpPr>
@@ -21569,7 +21625,7 @@
       </p:sp>
       <p:sp>
         <p:nvSpPr>
-          <p:cNvPr id="134" name="Rectangle 133"/>
+          <p:cNvPr id="135" name="Rectangle 134"/>
           <p:cNvSpPr/>
           <p:nvPr/>
         </p:nvSpPr>
@@ -21623,7 +21679,7 @@
       </p:sp>
       <p:sp>
         <p:nvSpPr>
-          <p:cNvPr id="135" name="Rectangle 134"/>
+          <p:cNvPr id="136" name="Rectangle 135"/>
           <p:cNvSpPr/>
           <p:nvPr/>
         </p:nvSpPr>
@@ -21675,7 +21731,7 @@
       </p:sp>
       <p:sp>
         <p:nvSpPr>
-          <p:cNvPr id="136" name="Rectangle 135"/>
+          <p:cNvPr id="137" name="Rectangle 136"/>
           <p:cNvSpPr/>
           <p:nvPr/>
         </p:nvSpPr>
@@ -21729,7 +21785,7 @@
       </p:sp>
       <p:sp>
         <p:nvSpPr>
-          <p:cNvPr id="137" name="Rectangle 136"/>
+          <p:cNvPr id="138" name="Rectangle 137"/>
           <p:cNvSpPr/>
           <p:nvPr/>
         </p:nvSpPr>

</xml_diff>